<commit_message>
changed labels in charts for consistency with text in paper
</commit_message>
<xml_diff>
--- a/representations image.pptx
+++ b/representations image.pptx
@@ -10,7 +10,8 @@
     <p:sldId id="258" r:id="rId4"/>
     <p:sldId id="259" r:id="rId5"/>
     <p:sldId id="260" r:id="rId6"/>
-    <p:sldId id="261" r:id="rId7"/>
+    <p:sldId id="262" r:id="rId7"/>
+    <p:sldId id="261" r:id="rId8"/>
   </p:sldIdLst>
   <p:sldSz cx="12192000" cy="6858000"/>
   <p:notesSz cx="6858000" cy="9144000"/>
@@ -109,6 +110,11 @@
       </a:defRPr>
     </a:lvl9pPr>
   </p:defaultTextStyle>
+  <p:extLst>
+    <p:ext uri="{EFAFB233-063F-42B5-8137-9DF3F51BA10A}">
+      <p15:sldGuideLst xmlns:p15="http://schemas.microsoft.com/office/powerpoint/2012/main"/>
+    </p:ext>
+  </p:extLst>
 </p:presentation>
 </file>
 
@@ -261,7 +267,7 @@
           <a:p>
             <a:fld id="{170662DF-287D-431E-B338-DA766D8B3B6C}" type="datetimeFigureOut">
               <a:rPr lang="nl-NL" smtClean="0"/>
-              <a:t>11-12-2025</a:t>
+              <a:t>9-1-2026</a:t>
             </a:fld>
             <a:endParaRPr lang="nl-NL"/>
           </a:p>
@@ -461,7 +467,7 @@
           <a:p>
             <a:fld id="{170662DF-287D-431E-B338-DA766D8B3B6C}" type="datetimeFigureOut">
               <a:rPr lang="nl-NL" smtClean="0"/>
-              <a:t>11-12-2025</a:t>
+              <a:t>9-1-2026</a:t>
             </a:fld>
             <a:endParaRPr lang="nl-NL"/>
           </a:p>
@@ -671,7 +677,7 @@
           <a:p>
             <a:fld id="{170662DF-287D-431E-B338-DA766D8B3B6C}" type="datetimeFigureOut">
               <a:rPr lang="nl-NL" smtClean="0"/>
-              <a:t>11-12-2025</a:t>
+              <a:t>9-1-2026</a:t>
             </a:fld>
             <a:endParaRPr lang="nl-NL"/>
           </a:p>
@@ -871,7 +877,7 @@
           <a:p>
             <a:fld id="{170662DF-287D-431E-B338-DA766D8B3B6C}" type="datetimeFigureOut">
               <a:rPr lang="nl-NL" smtClean="0"/>
-              <a:t>11-12-2025</a:t>
+              <a:t>9-1-2026</a:t>
             </a:fld>
             <a:endParaRPr lang="nl-NL"/>
           </a:p>
@@ -1147,7 +1153,7 @@
           <a:p>
             <a:fld id="{170662DF-287D-431E-B338-DA766D8B3B6C}" type="datetimeFigureOut">
               <a:rPr lang="nl-NL" smtClean="0"/>
-              <a:t>11-12-2025</a:t>
+              <a:t>9-1-2026</a:t>
             </a:fld>
             <a:endParaRPr lang="nl-NL"/>
           </a:p>
@@ -1415,7 +1421,7 @@
           <a:p>
             <a:fld id="{170662DF-287D-431E-B338-DA766D8B3B6C}" type="datetimeFigureOut">
               <a:rPr lang="nl-NL" smtClean="0"/>
-              <a:t>11-12-2025</a:t>
+              <a:t>9-1-2026</a:t>
             </a:fld>
             <a:endParaRPr lang="nl-NL"/>
           </a:p>
@@ -1830,7 +1836,7 @@
           <a:p>
             <a:fld id="{170662DF-287D-431E-B338-DA766D8B3B6C}" type="datetimeFigureOut">
               <a:rPr lang="nl-NL" smtClean="0"/>
-              <a:t>11-12-2025</a:t>
+              <a:t>9-1-2026</a:t>
             </a:fld>
             <a:endParaRPr lang="nl-NL"/>
           </a:p>
@@ -1972,7 +1978,7 @@
           <a:p>
             <a:fld id="{170662DF-287D-431E-B338-DA766D8B3B6C}" type="datetimeFigureOut">
               <a:rPr lang="nl-NL" smtClean="0"/>
-              <a:t>11-12-2025</a:t>
+              <a:t>9-1-2026</a:t>
             </a:fld>
             <a:endParaRPr lang="nl-NL"/>
           </a:p>
@@ -2085,7 +2091,7 @@
           <a:p>
             <a:fld id="{170662DF-287D-431E-B338-DA766D8B3B6C}" type="datetimeFigureOut">
               <a:rPr lang="nl-NL" smtClean="0"/>
-              <a:t>11-12-2025</a:t>
+              <a:t>9-1-2026</a:t>
             </a:fld>
             <a:endParaRPr lang="nl-NL"/>
           </a:p>
@@ -2398,7 +2404,7 @@
           <a:p>
             <a:fld id="{170662DF-287D-431E-B338-DA766D8B3B6C}" type="datetimeFigureOut">
               <a:rPr lang="nl-NL" smtClean="0"/>
-              <a:t>11-12-2025</a:t>
+              <a:t>9-1-2026</a:t>
             </a:fld>
             <a:endParaRPr lang="nl-NL"/>
           </a:p>
@@ -2687,7 +2693,7 @@
           <a:p>
             <a:fld id="{170662DF-287D-431E-B338-DA766D8B3B6C}" type="datetimeFigureOut">
               <a:rPr lang="nl-NL" smtClean="0"/>
-              <a:t>11-12-2025</a:t>
+              <a:t>9-1-2026</a:t>
             </a:fld>
             <a:endParaRPr lang="nl-NL"/>
           </a:p>
@@ -2930,7 +2936,7 @@
           <a:p>
             <a:fld id="{170662DF-287D-431E-B338-DA766D8B3B6C}" type="datetimeFigureOut">
               <a:rPr lang="nl-NL" smtClean="0"/>
-              <a:t>11-12-2025</a:t>
+              <a:t>9-1-2026</a:t>
             </a:fld>
             <a:endParaRPr lang="nl-NL"/>
           </a:p>
@@ -6853,10 +6859,10 @@
         </p:nvGrpSpPr>
         <p:grpSpPr>
           <a:xfrm>
-            <a:off x="-1" y="-11377"/>
-            <a:ext cx="17024186" cy="7703641"/>
-            <a:chOff x="-1" y="-11377"/>
-            <a:chExt cx="17024186" cy="7703641"/>
+            <a:off x="-3751474" y="-11377"/>
+            <a:ext cx="20775659" cy="7703641"/>
+            <a:chOff x="-3751474" y="-11377"/>
+            <a:chExt cx="20775659" cy="7703641"/>
           </a:xfrm>
         </p:grpSpPr>
         <p:sp>
@@ -6907,7 +6913,7 @@
             <a:lstStyle/>
             <a:p>
               <a:pPr algn="ctr"/>
-              <a:endParaRPr lang="nl-NL"/>
+              <a:endParaRPr lang="nl-NL" dirty="0"/>
             </a:p>
           </p:txBody>
         </p:sp>
@@ -6925,10 +6931,10 @@
           </p:nvGrpSpPr>
           <p:grpSpPr>
             <a:xfrm>
-              <a:off x="0" y="25360"/>
-              <a:ext cx="17024185" cy="7660369"/>
-              <a:chOff x="0" y="25360"/>
-              <a:chExt cx="17024185" cy="7660369"/>
+              <a:off x="-3751474" y="25360"/>
+              <a:ext cx="20775659" cy="7660369"/>
+              <a:chOff x="-3751474" y="25360"/>
+              <a:chExt cx="20775659" cy="7660369"/>
             </a:xfrm>
             <a:solidFill>
               <a:schemeClr val="bg1"/>
@@ -6948,7 +6954,7 @@
             </p:nvSpPr>
             <p:spPr>
               <a:xfrm>
-                <a:off x="0" y="394693"/>
+                <a:off x="-3751474" y="25360"/>
                 <a:ext cx="4082889" cy="7259598"/>
               </a:xfrm>
               <a:prstGeom prst="rect">
@@ -8904,7 +8910,13 @@
   <p:cSld>
     <p:spTree>
       <p:nvGrpSpPr>
-        <p:cNvPr id="1" name=""/>
+        <p:cNvPr id="1" name="">
+          <a:extLst>
+            <a:ext uri="{FF2B5EF4-FFF2-40B4-BE49-F238E27FC236}">
+              <a16:creationId xmlns:a16="http://schemas.microsoft.com/office/drawing/2014/main" id="{67B35DE1-6288-C542-88ED-A4A185AB7D7A}"/>
+            </a:ext>
+          </a:extLst>
+        </p:cNvPr>
         <p:cNvGrpSpPr/>
         <p:nvPr/>
       </p:nvGrpSpPr>
@@ -8918,54 +8930,4779 @@
       </p:grpSpPr>
       <p:sp>
         <p:nvSpPr>
-          <p:cNvPr id="2" name="Title 1">
+          <p:cNvPr id="22" name="Rectangle 21">
             <a:extLst>
               <a:ext uri="{FF2B5EF4-FFF2-40B4-BE49-F238E27FC236}">
-                <a16:creationId xmlns:a16="http://schemas.microsoft.com/office/drawing/2014/main" id="{E5CEB11A-3BDF-87C1-589D-7F7C28129324}"/>
+                <a16:creationId xmlns:a16="http://schemas.microsoft.com/office/drawing/2014/main" id="{7E808DF2-CCEF-C3DF-5FE0-7FECB91BBD18}"/>
               </a:ext>
             </a:extLst>
           </p:cNvPr>
-          <p:cNvSpPr>
-            <a:spLocks noGrp="1"/>
-          </p:cNvSpPr>
-          <p:nvPr>
-            <p:ph type="title"/>
-          </p:nvPr>
+          <p:cNvSpPr/>
+          <p:nvPr/>
         </p:nvSpPr>
-        <p:spPr/>
+        <p:spPr>
+          <a:xfrm>
+            <a:off x="-1" y="-11377"/>
+            <a:ext cx="17024185" cy="7703641"/>
+          </a:xfrm>
+          <a:prstGeom prst="rect">
+            <a:avLst/>
+          </a:prstGeom>
+          <a:solidFill>
+            <a:schemeClr val="bg1"/>
+          </a:solidFill>
+          <a:ln>
+            <a:noFill/>
+          </a:ln>
+        </p:spPr>
+        <p:style>
+          <a:lnRef idx="2">
+            <a:schemeClr val="accent1">
+              <a:shade val="15000"/>
+            </a:schemeClr>
+          </a:lnRef>
+          <a:fillRef idx="1">
+            <a:schemeClr val="accent1"/>
+          </a:fillRef>
+          <a:effectRef idx="0">
+            <a:schemeClr val="accent1"/>
+          </a:effectRef>
+          <a:fontRef idx="minor">
+            <a:schemeClr val="lt1"/>
+          </a:fontRef>
+        </p:style>
         <p:txBody>
-          <a:bodyPr/>
+          <a:bodyPr rtlCol="0" anchor="ctr"/>
           <a:lstStyle/>
           <a:p>
+            <a:pPr algn="ctr"/>
             <a:endParaRPr lang="nl-NL"/>
           </a:p>
         </p:txBody>
       </p:sp>
       <p:sp>
         <p:nvSpPr>
-          <p:cNvPr id="3" name="Content Placeholder 2">
+          <p:cNvPr id="4" name="TextBox 3">
             <a:extLst>
               <a:ext uri="{FF2B5EF4-FFF2-40B4-BE49-F238E27FC236}">
-                <a16:creationId xmlns:a16="http://schemas.microsoft.com/office/drawing/2014/main" id="{1601C020-810B-CB24-2B76-3B14C0FCC327}"/>
+                <a16:creationId xmlns:a16="http://schemas.microsoft.com/office/drawing/2014/main" id="{B1CF8945-EE92-441D-D713-3C5F2EB4EE90}"/>
               </a:ext>
             </a:extLst>
           </p:cNvPr>
-          <p:cNvSpPr>
-            <a:spLocks noGrp="1"/>
-          </p:cNvSpPr>
-          <p:nvPr>
-            <p:ph idx="1"/>
-          </p:nvPr>
+          <p:cNvSpPr txBox="1"/>
+          <p:nvPr/>
         </p:nvSpPr>
-        <p:spPr/>
+        <p:spPr>
+          <a:xfrm>
+            <a:off x="0" y="394693"/>
+            <a:ext cx="4082889" cy="7259598"/>
+          </a:xfrm>
+          <a:prstGeom prst="rect">
+            <a:avLst/>
+          </a:prstGeom>
+          <a:solidFill>
+            <a:schemeClr val="bg1"/>
+          </a:solidFill>
+          <a:ln>
+            <a:solidFill>
+              <a:schemeClr val="tx1"/>
+            </a:solidFill>
+          </a:ln>
+        </p:spPr>
         <p:txBody>
-          <a:bodyPr/>
+          <a:bodyPr wrap="square">
+            <a:spAutoFit/>
+          </a:bodyPr>
           <a:lstStyle/>
           <a:p>
-            <a:endParaRPr lang="nl-NL"/>
+            <a:r>
+              <a:rPr lang="nl-NL" sz="1800" dirty="0">
+                <a:solidFill>
+                  <a:srgbClr val="000000"/>
+                </a:solidFill>
+                <a:latin typeface="Consolas" panose="020B0609020204030204" pitchFamily="49" charset="0"/>
+              </a:rPr>
+              <a:t>{</a:t>
+            </a:r>
+          </a:p>
+          <a:p>
+            <a:r>
+              <a:rPr lang="nl-NL" sz="1800" dirty="0">
+                <a:solidFill>
+                  <a:srgbClr val="000000"/>
+                </a:solidFill>
+                <a:latin typeface="Consolas" panose="020B0609020204030204" pitchFamily="49" charset="0"/>
+              </a:rPr>
+              <a:t>    </a:t>
+            </a:r>
+            <a:r>
+              <a:rPr lang="nl-NL" sz="1800" dirty="0">
+                <a:solidFill>
+                  <a:srgbClr val="2E75B6"/>
+                </a:solidFill>
+                <a:latin typeface="Consolas" panose="020B0609020204030204" pitchFamily="49" charset="0"/>
+              </a:rPr>
+              <a:t>"size"</a:t>
+            </a:r>
+            <a:r>
+              <a:rPr lang="nl-NL" sz="1800" dirty="0">
+                <a:solidFill>
+                  <a:srgbClr val="000000"/>
+                </a:solidFill>
+                <a:latin typeface="Consolas" panose="020B0609020204030204" pitchFamily="49" charset="0"/>
+              </a:rPr>
+              <a:t>: {</a:t>
+            </a:r>
+          </a:p>
+          <a:p>
+            <a:r>
+              <a:rPr lang="nl-NL" sz="1800" dirty="0">
+                <a:solidFill>
+                  <a:srgbClr val="000000"/>
+                </a:solidFill>
+                <a:latin typeface="Consolas" panose="020B0609020204030204" pitchFamily="49" charset="0"/>
+              </a:rPr>
+              <a:t>        </a:t>
+            </a:r>
+            <a:r>
+              <a:rPr lang="nl-NL" sz="1800" dirty="0">
+                <a:solidFill>
+                  <a:srgbClr val="2E75B6"/>
+                </a:solidFill>
+                <a:latin typeface="Consolas" panose="020B0609020204030204" pitchFamily="49" charset="0"/>
+              </a:rPr>
+              <a:t>"columns"</a:t>
+            </a:r>
+            <a:r>
+              <a:rPr lang="nl-NL" sz="1800" dirty="0">
+                <a:solidFill>
+                  <a:srgbClr val="000000"/>
+                </a:solidFill>
+                <a:latin typeface="Consolas" panose="020B0609020204030204" pitchFamily="49" charset="0"/>
+              </a:rPr>
+              <a:t>: 3,</a:t>
+            </a:r>
+          </a:p>
+          <a:p>
+            <a:r>
+              <a:rPr lang="nl-NL" sz="1800" dirty="0">
+                <a:solidFill>
+                  <a:srgbClr val="000000"/>
+                </a:solidFill>
+                <a:latin typeface="Consolas" panose="020B0609020204030204" pitchFamily="49" charset="0"/>
+              </a:rPr>
+              <a:t>        </a:t>
+            </a:r>
+            <a:r>
+              <a:rPr lang="nl-NL" sz="1800" dirty="0">
+                <a:solidFill>
+                  <a:srgbClr val="2E75B6"/>
+                </a:solidFill>
+                <a:latin typeface="Consolas" panose="020B0609020204030204" pitchFamily="49" charset="0"/>
+              </a:rPr>
+              <a:t>"rows"</a:t>
+            </a:r>
+            <a:r>
+              <a:rPr lang="nl-NL" sz="1800" dirty="0">
+                <a:solidFill>
+                  <a:srgbClr val="000000"/>
+                </a:solidFill>
+                <a:latin typeface="Consolas" panose="020B0609020204030204" pitchFamily="49" charset="0"/>
+              </a:rPr>
+              <a:t>: 3</a:t>
+            </a:r>
+          </a:p>
+          <a:p>
+            <a:r>
+              <a:rPr lang="nl-NL" sz="1800" dirty="0">
+                <a:solidFill>
+                  <a:srgbClr val="000000"/>
+                </a:solidFill>
+                <a:latin typeface="Consolas" panose="020B0609020204030204" pitchFamily="49" charset="0"/>
+              </a:rPr>
+              <a:t>    },</a:t>
+            </a:r>
+          </a:p>
+          <a:p>
+            <a:r>
+              <a:rPr lang="nl-NL" sz="1800" dirty="0">
+                <a:solidFill>
+                  <a:srgbClr val="000000"/>
+                </a:solidFill>
+                <a:latin typeface="Consolas" panose="020B0609020204030204" pitchFamily="49" charset="0"/>
+              </a:rPr>
+              <a:t>    </a:t>
+            </a:r>
+            <a:r>
+              <a:rPr lang="nl-NL" sz="1800" dirty="0">
+                <a:solidFill>
+                  <a:srgbClr val="2E75B6"/>
+                </a:solidFill>
+                <a:latin typeface="Consolas" panose="020B0609020204030204" pitchFamily="49" charset="0"/>
+              </a:rPr>
+              <a:t>"start"</a:t>
+            </a:r>
+            <a:r>
+              <a:rPr lang="nl-NL" sz="1800" dirty="0">
+                <a:solidFill>
+                  <a:srgbClr val="000000"/>
+                </a:solidFill>
+                <a:latin typeface="Consolas" panose="020B0609020204030204" pitchFamily="49" charset="0"/>
+              </a:rPr>
+              <a:t>: [</a:t>
+            </a:r>
+          </a:p>
+          <a:p>
+            <a:r>
+              <a:rPr lang="nl-NL" sz="1800" dirty="0">
+                <a:solidFill>
+                  <a:srgbClr val="000000"/>
+                </a:solidFill>
+                <a:latin typeface="Consolas" panose="020B0609020204030204" pitchFamily="49" charset="0"/>
+              </a:rPr>
+              <a:t>        0,</a:t>
+            </a:r>
+          </a:p>
+          <a:p>
+            <a:r>
+              <a:rPr lang="nl-NL" sz="1800" dirty="0">
+                <a:solidFill>
+                  <a:srgbClr val="000000"/>
+                </a:solidFill>
+                <a:latin typeface="Consolas" panose="020B0609020204030204" pitchFamily="49" charset="0"/>
+              </a:rPr>
+              <a:t>        0</a:t>
+            </a:r>
+          </a:p>
+          <a:p>
+            <a:r>
+              <a:rPr lang="nl-NL" sz="1800" dirty="0">
+                <a:solidFill>
+                  <a:srgbClr val="000000"/>
+                </a:solidFill>
+                <a:latin typeface="Consolas" panose="020B0609020204030204" pitchFamily="49" charset="0"/>
+              </a:rPr>
+              <a:t>    ],</a:t>
+            </a:r>
+          </a:p>
+          <a:p>
+            <a:r>
+              <a:rPr lang="nl-NL" sz="1800" dirty="0">
+                <a:solidFill>
+                  <a:srgbClr val="000000"/>
+                </a:solidFill>
+                <a:latin typeface="Consolas" panose="020B0609020204030204" pitchFamily="49" charset="0"/>
+              </a:rPr>
+              <a:t>    </a:t>
+            </a:r>
+            <a:r>
+              <a:rPr lang="nl-NL" sz="1800" dirty="0">
+                <a:solidFill>
+                  <a:srgbClr val="2E75B6"/>
+                </a:solidFill>
+                <a:latin typeface="Consolas" panose="020B0609020204030204" pitchFamily="49" charset="0"/>
+              </a:rPr>
+              <a:t>"end"</a:t>
+            </a:r>
+            <a:r>
+              <a:rPr lang="nl-NL" sz="1800" dirty="0">
+                <a:solidFill>
+                  <a:srgbClr val="000000"/>
+                </a:solidFill>
+                <a:latin typeface="Consolas" panose="020B0609020204030204" pitchFamily="49" charset="0"/>
+              </a:rPr>
+              <a:t>: [</a:t>
+            </a:r>
+          </a:p>
+          <a:p>
+            <a:r>
+              <a:rPr lang="nl-NL" sz="1800" dirty="0">
+                <a:solidFill>
+                  <a:srgbClr val="000000"/>
+                </a:solidFill>
+                <a:latin typeface="Consolas" panose="020B0609020204030204" pitchFamily="49" charset="0"/>
+              </a:rPr>
+              <a:t>        2,</a:t>
+            </a:r>
+          </a:p>
+          <a:p>
+            <a:r>
+              <a:rPr lang="nl-NL" sz="1800" dirty="0">
+                <a:solidFill>
+                  <a:srgbClr val="000000"/>
+                </a:solidFill>
+                <a:latin typeface="Consolas" panose="020B0609020204030204" pitchFamily="49" charset="0"/>
+              </a:rPr>
+              <a:t>        2</a:t>
+            </a:r>
+          </a:p>
+          <a:p>
+            <a:r>
+              <a:rPr lang="nl-NL" sz="1800" dirty="0">
+                <a:solidFill>
+                  <a:srgbClr val="000000"/>
+                </a:solidFill>
+                <a:latin typeface="Consolas" panose="020B0609020204030204" pitchFamily="49" charset="0"/>
+              </a:rPr>
+              <a:t>    ],</a:t>
+            </a:r>
+          </a:p>
+          <a:p>
+            <a:r>
+              <a:rPr lang="nl-NL" sz="1800" dirty="0">
+                <a:solidFill>
+                  <a:srgbClr val="000000"/>
+                </a:solidFill>
+                <a:latin typeface="Consolas" panose="020B0609020204030204" pitchFamily="49" charset="0"/>
+              </a:rPr>
+              <a:t>    </a:t>
+            </a:r>
+            <a:r>
+              <a:rPr lang="nl-NL" sz="1800" dirty="0">
+                <a:solidFill>
+                  <a:srgbClr val="2E75B6"/>
+                </a:solidFill>
+                <a:latin typeface="Consolas" panose="020B0609020204030204" pitchFamily="49" charset="0"/>
+              </a:rPr>
+              <a:t>"grid"</a:t>
+            </a:r>
+            <a:r>
+              <a:rPr lang="nl-NL" sz="1800" dirty="0">
+                <a:solidFill>
+                  <a:srgbClr val="000000"/>
+                </a:solidFill>
+                <a:latin typeface="Consolas" panose="020B0609020204030204" pitchFamily="49" charset="0"/>
+              </a:rPr>
+              <a:t>: [</a:t>
+            </a:r>
+          </a:p>
+          <a:p>
+            <a:r>
+              <a:rPr lang="nl-NL" sz="1800" dirty="0">
+                <a:solidFill>
+                  <a:srgbClr val="000000"/>
+                </a:solidFill>
+                <a:latin typeface="Consolas" panose="020B0609020204030204" pitchFamily="49" charset="0"/>
+              </a:rPr>
+              <a:t>        [</a:t>
+            </a:r>
+          </a:p>
+          <a:p>
+            <a:r>
+              <a:rPr lang="nl-NL" sz="1800" dirty="0">
+                <a:solidFill>
+                  <a:srgbClr val="000000"/>
+                </a:solidFill>
+                <a:latin typeface="Consolas" panose="020B0609020204030204" pitchFamily="49" charset="0"/>
+              </a:rPr>
+              <a:t>            {</a:t>
+            </a:r>
+          </a:p>
+          <a:p>
+            <a:r>
+              <a:rPr lang="nl-NL" sz="1800" dirty="0">
+                <a:solidFill>
+                  <a:srgbClr val="000000"/>
+                </a:solidFill>
+                <a:latin typeface="Consolas" panose="020B0609020204030204" pitchFamily="49" charset="0"/>
+              </a:rPr>
+              <a:t>                </a:t>
+            </a:r>
+            <a:r>
+              <a:rPr lang="nl-NL" sz="1800" dirty="0">
+                <a:solidFill>
+                  <a:srgbClr val="2E75B6"/>
+                </a:solidFill>
+                <a:latin typeface="Consolas" panose="020B0609020204030204" pitchFamily="49" charset="0"/>
+              </a:rPr>
+              <a:t>"walls"</a:t>
+            </a:r>
+            <a:r>
+              <a:rPr lang="nl-NL" sz="1800" dirty="0">
+                <a:solidFill>
+                  <a:srgbClr val="000000"/>
+                </a:solidFill>
+                <a:latin typeface="Consolas" panose="020B0609020204030204" pitchFamily="49" charset="0"/>
+              </a:rPr>
+              <a:t>: {</a:t>
+            </a:r>
+          </a:p>
+          <a:p>
+            <a:r>
+              <a:rPr lang="nl-NL" sz="1800" dirty="0">
+                <a:solidFill>
+                  <a:srgbClr val="000000"/>
+                </a:solidFill>
+                <a:latin typeface="Consolas" panose="020B0609020204030204" pitchFamily="49" charset="0"/>
+              </a:rPr>
+              <a:t>                    </a:t>
+            </a:r>
+            <a:r>
+              <a:rPr lang="nl-NL" sz="1800" dirty="0">
+                <a:solidFill>
+                  <a:srgbClr val="2E75B6"/>
+                </a:solidFill>
+                <a:latin typeface="Consolas" panose="020B0609020204030204" pitchFamily="49" charset="0"/>
+              </a:rPr>
+              <a:t>"N"</a:t>
+            </a:r>
+            <a:r>
+              <a:rPr lang="nl-NL" sz="1800" dirty="0">
+                <a:solidFill>
+                  <a:srgbClr val="000000"/>
+                </a:solidFill>
+                <a:latin typeface="Consolas" panose="020B0609020204030204" pitchFamily="49" charset="0"/>
+              </a:rPr>
+              <a:t>: </a:t>
+            </a:r>
+            <a:r>
+              <a:rPr lang="nl-NL" sz="1800" dirty="0">
+                <a:solidFill>
+                  <a:srgbClr val="0000FF"/>
+                </a:solidFill>
+                <a:latin typeface="Consolas" panose="020B0609020204030204" pitchFamily="49" charset="0"/>
+              </a:rPr>
+              <a:t>true</a:t>
+            </a:r>
+            <a:r>
+              <a:rPr lang="nl-NL" sz="1800" dirty="0">
+                <a:solidFill>
+                  <a:srgbClr val="000000"/>
+                </a:solidFill>
+                <a:latin typeface="Consolas" panose="020B0609020204030204" pitchFamily="49" charset="0"/>
+              </a:rPr>
+              <a:t>,</a:t>
+            </a:r>
+          </a:p>
+          <a:p>
+            <a:r>
+              <a:rPr lang="nl-NL" sz="1800" dirty="0">
+                <a:solidFill>
+                  <a:srgbClr val="000000"/>
+                </a:solidFill>
+                <a:latin typeface="Consolas" panose="020B0609020204030204" pitchFamily="49" charset="0"/>
+              </a:rPr>
+              <a:t>                    </a:t>
+            </a:r>
+            <a:r>
+              <a:rPr lang="nl-NL" sz="1800" dirty="0">
+                <a:solidFill>
+                  <a:srgbClr val="2E75B6"/>
+                </a:solidFill>
+                <a:latin typeface="Consolas" panose="020B0609020204030204" pitchFamily="49" charset="0"/>
+              </a:rPr>
+              <a:t>"E"</a:t>
+            </a:r>
+            <a:r>
+              <a:rPr lang="nl-NL" sz="1800" dirty="0">
+                <a:solidFill>
+                  <a:srgbClr val="000000"/>
+                </a:solidFill>
+                <a:latin typeface="Consolas" panose="020B0609020204030204" pitchFamily="49" charset="0"/>
+              </a:rPr>
+              <a:t>: </a:t>
+            </a:r>
+            <a:r>
+              <a:rPr lang="nl-NL" sz="1800" dirty="0">
+                <a:solidFill>
+                  <a:srgbClr val="0000FF"/>
+                </a:solidFill>
+                <a:latin typeface="Consolas" panose="020B0609020204030204" pitchFamily="49" charset="0"/>
+              </a:rPr>
+              <a:t>true</a:t>
+            </a:r>
+            <a:r>
+              <a:rPr lang="nl-NL" sz="1800" dirty="0">
+                <a:solidFill>
+                  <a:srgbClr val="000000"/>
+                </a:solidFill>
+                <a:latin typeface="Consolas" panose="020B0609020204030204" pitchFamily="49" charset="0"/>
+              </a:rPr>
+              <a:t>,</a:t>
+            </a:r>
+          </a:p>
+          <a:p>
+            <a:r>
+              <a:rPr lang="nl-NL" sz="1800" dirty="0">
+                <a:solidFill>
+                  <a:srgbClr val="000000"/>
+                </a:solidFill>
+                <a:latin typeface="Consolas" panose="020B0609020204030204" pitchFamily="49" charset="0"/>
+              </a:rPr>
+              <a:t>                    </a:t>
+            </a:r>
+            <a:r>
+              <a:rPr lang="nl-NL" sz="1800" dirty="0">
+                <a:solidFill>
+                  <a:srgbClr val="2E75B6"/>
+                </a:solidFill>
+                <a:latin typeface="Consolas" panose="020B0609020204030204" pitchFamily="49" charset="0"/>
+              </a:rPr>
+              <a:t>"S"</a:t>
+            </a:r>
+            <a:r>
+              <a:rPr lang="nl-NL" sz="1800" dirty="0">
+                <a:solidFill>
+                  <a:srgbClr val="000000"/>
+                </a:solidFill>
+                <a:latin typeface="Consolas" panose="020B0609020204030204" pitchFamily="49" charset="0"/>
+              </a:rPr>
+              <a:t>: </a:t>
+            </a:r>
+            <a:r>
+              <a:rPr lang="nl-NL" sz="1800" dirty="0">
+                <a:solidFill>
+                  <a:srgbClr val="0000FF"/>
+                </a:solidFill>
+                <a:latin typeface="Consolas" panose="020B0609020204030204" pitchFamily="49" charset="0"/>
+              </a:rPr>
+              <a:t>false</a:t>
+            </a:r>
+            <a:r>
+              <a:rPr lang="nl-NL" sz="1800" dirty="0">
+                <a:solidFill>
+                  <a:srgbClr val="000000"/>
+                </a:solidFill>
+                <a:latin typeface="Consolas" panose="020B0609020204030204" pitchFamily="49" charset="0"/>
+              </a:rPr>
+              <a:t>,</a:t>
+            </a:r>
+          </a:p>
+          <a:p>
+            <a:r>
+              <a:rPr lang="nl-NL" sz="1800" dirty="0">
+                <a:solidFill>
+                  <a:srgbClr val="000000"/>
+                </a:solidFill>
+                <a:latin typeface="Consolas" panose="020B0609020204030204" pitchFamily="49" charset="0"/>
+              </a:rPr>
+              <a:t>                    </a:t>
+            </a:r>
+            <a:r>
+              <a:rPr lang="nl-NL" sz="1800" dirty="0">
+                <a:solidFill>
+                  <a:srgbClr val="2E75B6"/>
+                </a:solidFill>
+                <a:latin typeface="Consolas" panose="020B0609020204030204" pitchFamily="49" charset="0"/>
+              </a:rPr>
+              <a:t>"W"</a:t>
+            </a:r>
+            <a:r>
+              <a:rPr lang="nl-NL" sz="1800" dirty="0">
+                <a:solidFill>
+                  <a:srgbClr val="000000"/>
+                </a:solidFill>
+                <a:latin typeface="Consolas" panose="020B0609020204030204" pitchFamily="49" charset="0"/>
+              </a:rPr>
+              <a:t>: </a:t>
+            </a:r>
+            <a:r>
+              <a:rPr lang="nl-NL" sz="1800" dirty="0">
+                <a:solidFill>
+                  <a:srgbClr val="0000FF"/>
+                </a:solidFill>
+                <a:latin typeface="Consolas" panose="020B0609020204030204" pitchFamily="49" charset="0"/>
+              </a:rPr>
+              <a:t>true</a:t>
+            </a:r>
+            <a:endParaRPr lang="nl-NL" sz="1800" dirty="0">
+              <a:solidFill>
+                <a:srgbClr val="000000"/>
+              </a:solidFill>
+              <a:latin typeface="Consolas" panose="020B0609020204030204" pitchFamily="49" charset="0"/>
+            </a:endParaRPr>
+          </a:p>
+          <a:p>
+            <a:r>
+              <a:rPr lang="nl-NL" sz="1800" dirty="0">
+                <a:solidFill>
+                  <a:srgbClr val="000000"/>
+                </a:solidFill>
+                <a:latin typeface="Consolas" panose="020B0609020204030204" pitchFamily="49" charset="0"/>
+              </a:rPr>
+              <a:t>                }</a:t>
+            </a:r>
+          </a:p>
+          <a:p>
+            <a:r>
+              <a:rPr lang="nl-NL" sz="1800" dirty="0">
+                <a:solidFill>
+                  <a:srgbClr val="000000"/>
+                </a:solidFill>
+                <a:latin typeface="Consolas" panose="020B0609020204030204" pitchFamily="49" charset="0"/>
+              </a:rPr>
+              <a:t>            },</a:t>
+            </a:r>
+          </a:p>
+          <a:p>
+            <a:endParaRPr lang="nl-NL" dirty="0">
+              <a:solidFill>
+                <a:srgbClr val="000000"/>
+              </a:solidFill>
+              <a:latin typeface="Consolas" panose="020B0609020204030204" pitchFamily="49" charset="0"/>
+            </a:endParaRPr>
+          </a:p>
+          <a:p>
+            <a:endParaRPr lang="nl-NL" sz="1800" dirty="0">
+              <a:solidFill>
+                <a:srgbClr val="000000"/>
+              </a:solidFill>
+              <a:latin typeface="Consolas" panose="020B0609020204030204" pitchFamily="49" charset="0"/>
+            </a:endParaRPr>
+          </a:p>
+          <a:p>
+            <a:endParaRPr lang="nl-NL" sz="1800" dirty="0">
+              <a:solidFill>
+                <a:srgbClr val="000000"/>
+              </a:solidFill>
+              <a:latin typeface="Consolas" panose="020B0609020204030204" pitchFamily="49" charset="0"/>
+            </a:endParaRPr>
           </a:p>
         </p:txBody>
       </p:sp>
+      <p:sp>
+        <p:nvSpPr>
+          <p:cNvPr id="5" name="TextBox 4">
+            <a:extLst>
+              <a:ext uri="{FF2B5EF4-FFF2-40B4-BE49-F238E27FC236}">
+                <a16:creationId xmlns:a16="http://schemas.microsoft.com/office/drawing/2014/main" id="{8DD223BC-B585-6BA6-D171-928C796616F9}"/>
+              </a:ext>
+            </a:extLst>
+          </p:cNvPr>
+          <p:cNvSpPr txBox="1"/>
+          <p:nvPr/>
+        </p:nvSpPr>
+        <p:spPr>
+          <a:xfrm>
+            <a:off x="344048" y="27146"/>
+            <a:ext cx="2766060" cy="369332"/>
+          </a:xfrm>
+          <a:prstGeom prst="rect">
+            <a:avLst/>
+          </a:prstGeom>
+          <a:solidFill>
+            <a:schemeClr val="bg1"/>
+          </a:solidFill>
+        </p:spPr>
+        <p:txBody>
+          <a:bodyPr wrap="square" rtlCol="0">
+            <a:spAutoFit/>
+          </a:bodyPr>
+          <a:lstStyle/>
+          <a:p>
+            <a:r>
+              <a:rPr lang="en-US" b="1" dirty="0"/>
+              <a:t>JSON – Line-walled maze</a:t>
+            </a:r>
+            <a:endParaRPr lang="nl-NL" b="1" dirty="0"/>
+          </a:p>
+        </p:txBody>
+      </p:sp>
+      <p:sp>
+        <p:nvSpPr>
+          <p:cNvPr id="6" name="TextBox 5">
+            <a:extLst>
+              <a:ext uri="{FF2B5EF4-FFF2-40B4-BE49-F238E27FC236}">
+                <a16:creationId xmlns:a16="http://schemas.microsoft.com/office/drawing/2014/main" id="{59C1B755-8E25-8A06-571A-A83F03D616C6}"/>
+              </a:ext>
+            </a:extLst>
+          </p:cNvPr>
+          <p:cNvSpPr txBox="1"/>
+          <p:nvPr/>
+        </p:nvSpPr>
+        <p:spPr>
+          <a:xfrm>
+            <a:off x="7282815" y="391424"/>
+            <a:ext cx="3524250" cy="7294305"/>
+          </a:xfrm>
+          <a:prstGeom prst="rect">
+            <a:avLst/>
+          </a:prstGeom>
+          <a:solidFill>
+            <a:schemeClr val="bg1"/>
+          </a:solidFill>
+          <a:ln>
+            <a:solidFill>
+              <a:schemeClr val="tx1"/>
+            </a:solidFill>
+          </a:ln>
+        </p:spPr>
+        <p:txBody>
+          <a:bodyPr wrap="square">
+            <a:spAutoFit/>
+          </a:bodyPr>
+          <a:lstStyle/>
+          <a:p>
+            <a:r>
+              <a:rPr lang="nl-NL" sz="1800" dirty="0">
+                <a:solidFill>
+                  <a:srgbClr val="000000"/>
+                </a:solidFill>
+                <a:latin typeface="Consolas" panose="020B0609020204030204" pitchFamily="49" charset="0"/>
+              </a:rPr>
+              <a:t>{</a:t>
+            </a:r>
+          </a:p>
+          <a:p>
+            <a:r>
+              <a:rPr lang="nl-NL" sz="1800" dirty="0">
+                <a:solidFill>
+                  <a:srgbClr val="000000"/>
+                </a:solidFill>
+                <a:latin typeface="Consolas" panose="020B0609020204030204" pitchFamily="49" charset="0"/>
+              </a:rPr>
+              <a:t>    </a:t>
+            </a:r>
+            <a:r>
+              <a:rPr lang="nl-NL" sz="1800" dirty="0">
+                <a:solidFill>
+                  <a:srgbClr val="2E75B6"/>
+                </a:solidFill>
+                <a:latin typeface="Consolas" panose="020B0609020204030204" pitchFamily="49" charset="0"/>
+              </a:rPr>
+              <a:t>"size"</a:t>
+            </a:r>
+            <a:r>
+              <a:rPr lang="nl-NL" sz="1800" dirty="0">
+                <a:solidFill>
+                  <a:srgbClr val="000000"/>
+                </a:solidFill>
+                <a:latin typeface="Consolas" panose="020B0609020204030204" pitchFamily="49" charset="0"/>
+              </a:rPr>
+              <a:t>: {</a:t>
+            </a:r>
+          </a:p>
+          <a:p>
+            <a:r>
+              <a:rPr lang="nl-NL" sz="1800" dirty="0">
+                <a:solidFill>
+                  <a:srgbClr val="000000"/>
+                </a:solidFill>
+                <a:latin typeface="Consolas" panose="020B0609020204030204" pitchFamily="49" charset="0"/>
+              </a:rPr>
+              <a:t>        </a:t>
+            </a:r>
+            <a:r>
+              <a:rPr lang="nl-NL" sz="1800" dirty="0">
+                <a:solidFill>
+                  <a:srgbClr val="2E75B6"/>
+                </a:solidFill>
+                <a:latin typeface="Consolas" panose="020B0609020204030204" pitchFamily="49" charset="0"/>
+              </a:rPr>
+              <a:t>"columns"</a:t>
+            </a:r>
+            <a:r>
+              <a:rPr lang="nl-NL" sz="1800" dirty="0">
+                <a:solidFill>
+                  <a:srgbClr val="000000"/>
+                </a:solidFill>
+                <a:latin typeface="Consolas" panose="020B0609020204030204" pitchFamily="49" charset="0"/>
+              </a:rPr>
+              <a:t>: 3,</a:t>
+            </a:r>
+          </a:p>
+          <a:p>
+            <a:r>
+              <a:rPr lang="nl-NL" sz="1800" dirty="0">
+                <a:solidFill>
+                  <a:srgbClr val="000000"/>
+                </a:solidFill>
+                <a:latin typeface="Consolas" panose="020B0609020204030204" pitchFamily="49" charset="0"/>
+              </a:rPr>
+              <a:t>        </a:t>
+            </a:r>
+            <a:r>
+              <a:rPr lang="nl-NL" sz="1800" dirty="0">
+                <a:solidFill>
+                  <a:srgbClr val="2E75B6"/>
+                </a:solidFill>
+                <a:latin typeface="Consolas" panose="020B0609020204030204" pitchFamily="49" charset="0"/>
+              </a:rPr>
+              <a:t>"rows"</a:t>
+            </a:r>
+            <a:r>
+              <a:rPr lang="nl-NL" sz="1800" dirty="0">
+                <a:solidFill>
+                  <a:srgbClr val="000000"/>
+                </a:solidFill>
+                <a:latin typeface="Consolas" panose="020B0609020204030204" pitchFamily="49" charset="0"/>
+              </a:rPr>
+              <a:t>: 3</a:t>
+            </a:r>
+          </a:p>
+          <a:p>
+            <a:r>
+              <a:rPr lang="nl-NL" sz="1800" dirty="0">
+                <a:solidFill>
+                  <a:srgbClr val="000000"/>
+                </a:solidFill>
+                <a:latin typeface="Consolas" panose="020B0609020204030204" pitchFamily="49" charset="0"/>
+              </a:rPr>
+              <a:t>    },</a:t>
+            </a:r>
+          </a:p>
+          <a:p>
+            <a:r>
+              <a:rPr lang="nl-NL" sz="1800" dirty="0">
+                <a:solidFill>
+                  <a:srgbClr val="000000"/>
+                </a:solidFill>
+                <a:latin typeface="Consolas" panose="020B0609020204030204" pitchFamily="49" charset="0"/>
+              </a:rPr>
+              <a:t>    </a:t>
+            </a:r>
+            <a:r>
+              <a:rPr lang="nl-NL" sz="1800" dirty="0">
+                <a:solidFill>
+                  <a:srgbClr val="2E75B6"/>
+                </a:solidFill>
+                <a:latin typeface="Consolas" panose="020B0609020204030204" pitchFamily="49" charset="0"/>
+              </a:rPr>
+              <a:t>"start"</a:t>
+            </a:r>
+            <a:r>
+              <a:rPr lang="nl-NL" sz="1800" dirty="0">
+                <a:solidFill>
+                  <a:srgbClr val="000000"/>
+                </a:solidFill>
+                <a:latin typeface="Consolas" panose="020B0609020204030204" pitchFamily="49" charset="0"/>
+              </a:rPr>
+              <a:t>: [</a:t>
+            </a:r>
+          </a:p>
+          <a:p>
+            <a:r>
+              <a:rPr lang="nl-NL" sz="1800" dirty="0">
+                <a:solidFill>
+                  <a:srgbClr val="000000"/>
+                </a:solidFill>
+                <a:latin typeface="Consolas" panose="020B0609020204030204" pitchFamily="49" charset="0"/>
+              </a:rPr>
+              <a:t>        0,</a:t>
+            </a:r>
+          </a:p>
+          <a:p>
+            <a:r>
+              <a:rPr lang="nl-NL" sz="1800" dirty="0">
+                <a:solidFill>
+                  <a:srgbClr val="000000"/>
+                </a:solidFill>
+                <a:latin typeface="Consolas" panose="020B0609020204030204" pitchFamily="49" charset="0"/>
+              </a:rPr>
+              <a:t>        0</a:t>
+            </a:r>
+          </a:p>
+          <a:p>
+            <a:r>
+              <a:rPr lang="nl-NL" sz="1800" dirty="0">
+                <a:solidFill>
+                  <a:srgbClr val="000000"/>
+                </a:solidFill>
+                <a:latin typeface="Consolas" panose="020B0609020204030204" pitchFamily="49" charset="0"/>
+              </a:rPr>
+              <a:t>    ],</a:t>
+            </a:r>
+          </a:p>
+          <a:p>
+            <a:r>
+              <a:rPr lang="nl-NL" sz="1800" dirty="0">
+                <a:solidFill>
+                  <a:srgbClr val="000000"/>
+                </a:solidFill>
+                <a:latin typeface="Consolas" panose="020B0609020204030204" pitchFamily="49" charset="0"/>
+              </a:rPr>
+              <a:t>    </a:t>
+            </a:r>
+            <a:r>
+              <a:rPr lang="nl-NL" sz="1800" dirty="0">
+                <a:solidFill>
+                  <a:srgbClr val="2E75B6"/>
+                </a:solidFill>
+                <a:latin typeface="Consolas" panose="020B0609020204030204" pitchFamily="49" charset="0"/>
+              </a:rPr>
+              <a:t>"end"</a:t>
+            </a:r>
+            <a:r>
+              <a:rPr lang="nl-NL" sz="1800" dirty="0">
+                <a:solidFill>
+                  <a:srgbClr val="000000"/>
+                </a:solidFill>
+                <a:latin typeface="Consolas" panose="020B0609020204030204" pitchFamily="49" charset="0"/>
+              </a:rPr>
+              <a:t>: [</a:t>
+            </a:r>
+          </a:p>
+          <a:p>
+            <a:r>
+              <a:rPr lang="nl-NL" sz="1800" dirty="0">
+                <a:solidFill>
+                  <a:srgbClr val="000000"/>
+                </a:solidFill>
+                <a:latin typeface="Consolas" panose="020B0609020204030204" pitchFamily="49" charset="0"/>
+              </a:rPr>
+              <a:t>        2,</a:t>
+            </a:r>
+          </a:p>
+          <a:p>
+            <a:r>
+              <a:rPr lang="nl-NL" sz="1800" dirty="0">
+                <a:solidFill>
+                  <a:srgbClr val="000000"/>
+                </a:solidFill>
+                <a:latin typeface="Consolas" panose="020B0609020204030204" pitchFamily="49" charset="0"/>
+              </a:rPr>
+              <a:t>        2</a:t>
+            </a:r>
+          </a:p>
+          <a:p>
+            <a:r>
+              <a:rPr lang="nl-NL" sz="1800" dirty="0">
+                <a:solidFill>
+                  <a:srgbClr val="000000"/>
+                </a:solidFill>
+                <a:latin typeface="Consolas" panose="020B0609020204030204" pitchFamily="49" charset="0"/>
+              </a:rPr>
+              <a:t>    ],</a:t>
+            </a:r>
+          </a:p>
+          <a:p>
+            <a:r>
+              <a:rPr lang="nl-NL" sz="1800" dirty="0">
+                <a:solidFill>
+                  <a:srgbClr val="000000"/>
+                </a:solidFill>
+                <a:latin typeface="Consolas" panose="020B0609020204030204" pitchFamily="49" charset="0"/>
+              </a:rPr>
+              <a:t>    </a:t>
+            </a:r>
+            <a:r>
+              <a:rPr lang="nl-NL" sz="1800" dirty="0">
+                <a:solidFill>
+                  <a:srgbClr val="2E75B6"/>
+                </a:solidFill>
+                <a:latin typeface="Consolas" panose="020B0609020204030204" pitchFamily="49" charset="0"/>
+              </a:rPr>
+              <a:t>"grid"</a:t>
+            </a:r>
+            <a:r>
+              <a:rPr lang="nl-NL" sz="1800" dirty="0">
+                <a:solidFill>
+                  <a:srgbClr val="000000"/>
+                </a:solidFill>
+                <a:latin typeface="Consolas" panose="020B0609020204030204" pitchFamily="49" charset="0"/>
+              </a:rPr>
+              <a:t>: [</a:t>
+            </a:r>
+          </a:p>
+          <a:p>
+            <a:r>
+              <a:rPr lang="nl-NL" sz="1800" dirty="0">
+                <a:solidFill>
+                  <a:srgbClr val="000000"/>
+                </a:solidFill>
+                <a:latin typeface="Consolas" panose="020B0609020204030204" pitchFamily="49" charset="0"/>
+              </a:rPr>
+              <a:t>        {</a:t>
+            </a:r>
+          </a:p>
+          <a:p>
+            <a:r>
+              <a:rPr lang="nl-NL" sz="1800" dirty="0">
+                <a:solidFill>
+                  <a:srgbClr val="000000"/>
+                </a:solidFill>
+                <a:latin typeface="Consolas" panose="020B0609020204030204" pitchFamily="49" charset="0"/>
+              </a:rPr>
+              <a:t>            </a:t>
+            </a:r>
+            <a:r>
+              <a:rPr lang="nl-NL" sz="1800" dirty="0">
+                <a:solidFill>
+                  <a:srgbClr val="2E75B6"/>
+                </a:solidFill>
+                <a:latin typeface="Consolas" panose="020B0609020204030204" pitchFamily="49" charset="0"/>
+              </a:rPr>
+              <a:t>"node"</a:t>
+            </a:r>
+            <a:r>
+              <a:rPr lang="nl-NL" sz="1800" dirty="0">
+                <a:solidFill>
+                  <a:srgbClr val="000000"/>
+                </a:solidFill>
+                <a:latin typeface="Consolas" panose="020B0609020204030204" pitchFamily="49" charset="0"/>
+              </a:rPr>
+              <a:t>: [</a:t>
+            </a:r>
+          </a:p>
+          <a:p>
+            <a:r>
+              <a:rPr lang="nl-NL" sz="1800" dirty="0">
+                <a:solidFill>
+                  <a:srgbClr val="000000"/>
+                </a:solidFill>
+                <a:latin typeface="Consolas" panose="020B0609020204030204" pitchFamily="49" charset="0"/>
+              </a:rPr>
+              <a:t>                0,</a:t>
+            </a:r>
+          </a:p>
+          <a:p>
+            <a:r>
+              <a:rPr lang="nl-NL" sz="1800" dirty="0">
+                <a:solidFill>
+                  <a:srgbClr val="000000"/>
+                </a:solidFill>
+                <a:latin typeface="Consolas" panose="020B0609020204030204" pitchFamily="49" charset="0"/>
+              </a:rPr>
+              <a:t>                0</a:t>
+            </a:r>
+          </a:p>
+          <a:p>
+            <a:r>
+              <a:rPr lang="nl-NL" sz="1800" dirty="0">
+                <a:solidFill>
+                  <a:srgbClr val="000000"/>
+                </a:solidFill>
+                <a:latin typeface="Consolas" panose="020B0609020204030204" pitchFamily="49" charset="0"/>
+              </a:rPr>
+              <a:t>            ],</a:t>
+            </a:r>
+          </a:p>
+          <a:p>
+            <a:r>
+              <a:rPr lang="nl-NL" sz="1800" dirty="0">
+                <a:solidFill>
+                  <a:srgbClr val="000000"/>
+                </a:solidFill>
+                <a:latin typeface="Consolas" panose="020B0609020204030204" pitchFamily="49" charset="0"/>
+              </a:rPr>
+              <a:t>            </a:t>
+            </a:r>
+            <a:r>
+              <a:rPr lang="nl-NL" sz="1800" dirty="0">
+                <a:solidFill>
+                  <a:srgbClr val="2E75B6"/>
+                </a:solidFill>
+                <a:latin typeface="Consolas" panose="020B0609020204030204" pitchFamily="49" charset="0"/>
+              </a:rPr>
+              <a:t>"neighbors"</a:t>
+            </a:r>
+            <a:r>
+              <a:rPr lang="nl-NL" sz="1800" dirty="0">
+                <a:solidFill>
+                  <a:srgbClr val="000000"/>
+                </a:solidFill>
+                <a:latin typeface="Consolas" panose="020B0609020204030204" pitchFamily="49" charset="0"/>
+              </a:rPr>
+              <a:t>: [</a:t>
+            </a:r>
+          </a:p>
+          <a:p>
+            <a:r>
+              <a:rPr lang="nl-NL" sz="1800" dirty="0">
+                <a:solidFill>
+                  <a:srgbClr val="000000"/>
+                </a:solidFill>
+                <a:latin typeface="Consolas" panose="020B0609020204030204" pitchFamily="49" charset="0"/>
+              </a:rPr>
+              <a:t>                [</a:t>
+            </a:r>
+          </a:p>
+          <a:p>
+            <a:r>
+              <a:rPr lang="nl-NL" sz="1800" dirty="0">
+                <a:solidFill>
+                  <a:srgbClr val="000000"/>
+                </a:solidFill>
+                <a:latin typeface="Consolas" panose="020B0609020204030204" pitchFamily="49" charset="0"/>
+              </a:rPr>
+              <a:t>                    1,</a:t>
+            </a:r>
+          </a:p>
+          <a:p>
+            <a:r>
+              <a:rPr lang="nl-NL" sz="1800" dirty="0">
+                <a:solidFill>
+                  <a:srgbClr val="000000"/>
+                </a:solidFill>
+                <a:latin typeface="Consolas" panose="020B0609020204030204" pitchFamily="49" charset="0"/>
+              </a:rPr>
+              <a:t>                    0</a:t>
+            </a:r>
+          </a:p>
+          <a:p>
+            <a:r>
+              <a:rPr lang="nl-NL" sz="1800" dirty="0">
+                <a:solidFill>
+                  <a:srgbClr val="000000"/>
+                </a:solidFill>
+                <a:latin typeface="Consolas" panose="020B0609020204030204" pitchFamily="49" charset="0"/>
+              </a:rPr>
+              <a:t>                ]</a:t>
+            </a:r>
+          </a:p>
+          <a:p>
+            <a:r>
+              <a:rPr lang="nl-NL" sz="1800" dirty="0">
+                <a:solidFill>
+                  <a:srgbClr val="000000"/>
+                </a:solidFill>
+                <a:latin typeface="Consolas" panose="020B0609020204030204" pitchFamily="49" charset="0"/>
+              </a:rPr>
+              <a:t>            ]</a:t>
+            </a:r>
+          </a:p>
+          <a:p>
+            <a:r>
+              <a:rPr lang="nl-NL" sz="1800" dirty="0">
+                <a:solidFill>
+                  <a:srgbClr val="000000"/>
+                </a:solidFill>
+                <a:latin typeface="Consolas" panose="020B0609020204030204" pitchFamily="49" charset="0"/>
+              </a:rPr>
+              <a:t>        },</a:t>
+            </a:r>
+            <a:endParaRPr lang="nl-NL" dirty="0"/>
+          </a:p>
+        </p:txBody>
+      </p:sp>
+      <p:sp>
+        <p:nvSpPr>
+          <p:cNvPr id="7" name="TextBox 6">
+            <a:extLst>
+              <a:ext uri="{FF2B5EF4-FFF2-40B4-BE49-F238E27FC236}">
+                <a16:creationId xmlns:a16="http://schemas.microsoft.com/office/drawing/2014/main" id="{14B7BC84-56E5-44C5-57D7-8CC35322F2E5}"/>
+              </a:ext>
+            </a:extLst>
+          </p:cNvPr>
+          <p:cNvSpPr txBox="1"/>
+          <p:nvPr/>
+        </p:nvSpPr>
+        <p:spPr>
+          <a:xfrm>
+            <a:off x="7270182" y="25360"/>
+            <a:ext cx="4263390" cy="369332"/>
+          </a:xfrm>
+          <a:prstGeom prst="rect">
+            <a:avLst/>
+          </a:prstGeom>
+          <a:solidFill>
+            <a:schemeClr val="bg1"/>
+          </a:solidFill>
+        </p:spPr>
+        <p:txBody>
+          <a:bodyPr wrap="square" rtlCol="0">
+            <a:spAutoFit/>
+          </a:bodyPr>
+          <a:lstStyle/>
+          <a:p>
+            <a:r>
+              <a:rPr lang="en-US" b="1" dirty="0"/>
+              <a:t>Adjacency list JSON – Both maze styles</a:t>
+            </a:r>
+            <a:endParaRPr lang="nl-NL" b="1" dirty="0"/>
+          </a:p>
+        </p:txBody>
+      </p:sp>
+      <p:sp>
+        <p:nvSpPr>
+          <p:cNvPr id="8" name="TextBox 7">
+            <a:extLst>
+              <a:ext uri="{FF2B5EF4-FFF2-40B4-BE49-F238E27FC236}">
+                <a16:creationId xmlns:a16="http://schemas.microsoft.com/office/drawing/2014/main" id="{EA85DF3D-9359-D289-F353-7A4E7056D582}"/>
+              </a:ext>
+            </a:extLst>
+          </p:cNvPr>
+          <p:cNvSpPr txBox="1"/>
+          <p:nvPr/>
+        </p:nvSpPr>
+        <p:spPr>
+          <a:xfrm>
+            <a:off x="4082889" y="391424"/>
+            <a:ext cx="3199926" cy="7294305"/>
+          </a:xfrm>
+          <a:prstGeom prst="rect">
+            <a:avLst/>
+          </a:prstGeom>
+          <a:solidFill>
+            <a:schemeClr val="bg1"/>
+          </a:solidFill>
+          <a:ln>
+            <a:solidFill>
+              <a:schemeClr val="tx1"/>
+            </a:solidFill>
+          </a:ln>
+        </p:spPr>
+        <p:txBody>
+          <a:bodyPr wrap="square">
+            <a:spAutoFit/>
+          </a:bodyPr>
+          <a:lstStyle/>
+          <a:p>
+            <a:r>
+              <a:rPr lang="nl-NL" sz="1800" dirty="0">
+                <a:solidFill>
+                  <a:srgbClr val="000000"/>
+                </a:solidFill>
+                <a:latin typeface="Consolas" panose="020B0609020204030204" pitchFamily="49" charset="0"/>
+              </a:rPr>
+              <a:t>{</a:t>
+            </a:r>
+          </a:p>
+          <a:p>
+            <a:r>
+              <a:rPr lang="nl-NL" sz="1800" dirty="0">
+                <a:solidFill>
+                  <a:srgbClr val="000000"/>
+                </a:solidFill>
+                <a:latin typeface="Consolas" panose="020B0609020204030204" pitchFamily="49" charset="0"/>
+              </a:rPr>
+              <a:t>    </a:t>
+            </a:r>
+            <a:r>
+              <a:rPr lang="nl-NL" sz="1800" dirty="0">
+                <a:solidFill>
+                  <a:srgbClr val="2E75B6"/>
+                </a:solidFill>
+                <a:latin typeface="Consolas" panose="020B0609020204030204" pitchFamily="49" charset="0"/>
+              </a:rPr>
+              <a:t>"size"</a:t>
+            </a:r>
+            <a:r>
+              <a:rPr lang="nl-NL" sz="1800" dirty="0">
+                <a:solidFill>
+                  <a:srgbClr val="000000"/>
+                </a:solidFill>
+                <a:latin typeface="Consolas" panose="020B0609020204030204" pitchFamily="49" charset="0"/>
+              </a:rPr>
+              <a:t>: {</a:t>
+            </a:r>
+          </a:p>
+          <a:p>
+            <a:r>
+              <a:rPr lang="nl-NL" sz="1800" dirty="0">
+                <a:solidFill>
+                  <a:srgbClr val="000000"/>
+                </a:solidFill>
+                <a:latin typeface="Consolas" panose="020B0609020204030204" pitchFamily="49" charset="0"/>
+              </a:rPr>
+              <a:t>        </a:t>
+            </a:r>
+            <a:r>
+              <a:rPr lang="nl-NL" sz="1800" dirty="0">
+                <a:solidFill>
+                  <a:srgbClr val="2E75B6"/>
+                </a:solidFill>
+                <a:latin typeface="Consolas" panose="020B0609020204030204" pitchFamily="49" charset="0"/>
+              </a:rPr>
+              <a:t>"columns"</a:t>
+            </a:r>
+            <a:r>
+              <a:rPr lang="nl-NL" sz="1800" dirty="0">
+                <a:solidFill>
+                  <a:srgbClr val="000000"/>
+                </a:solidFill>
+                <a:latin typeface="Consolas" panose="020B0609020204030204" pitchFamily="49" charset="0"/>
+              </a:rPr>
+              <a:t>: 7,</a:t>
+            </a:r>
+          </a:p>
+          <a:p>
+            <a:r>
+              <a:rPr lang="nl-NL" sz="1800" dirty="0">
+                <a:solidFill>
+                  <a:srgbClr val="000000"/>
+                </a:solidFill>
+                <a:latin typeface="Consolas" panose="020B0609020204030204" pitchFamily="49" charset="0"/>
+              </a:rPr>
+              <a:t>        </a:t>
+            </a:r>
+            <a:r>
+              <a:rPr lang="nl-NL" sz="1800" dirty="0">
+                <a:solidFill>
+                  <a:srgbClr val="2E75B6"/>
+                </a:solidFill>
+                <a:latin typeface="Consolas" panose="020B0609020204030204" pitchFamily="49" charset="0"/>
+              </a:rPr>
+              <a:t>"rows"</a:t>
+            </a:r>
+            <a:r>
+              <a:rPr lang="nl-NL" sz="1800" dirty="0">
+                <a:solidFill>
+                  <a:srgbClr val="000000"/>
+                </a:solidFill>
+                <a:latin typeface="Consolas" panose="020B0609020204030204" pitchFamily="49" charset="0"/>
+              </a:rPr>
+              <a:t>: 7</a:t>
+            </a:r>
+          </a:p>
+          <a:p>
+            <a:r>
+              <a:rPr lang="nl-NL" sz="1800" dirty="0">
+                <a:solidFill>
+                  <a:srgbClr val="000000"/>
+                </a:solidFill>
+                <a:latin typeface="Consolas" panose="020B0609020204030204" pitchFamily="49" charset="0"/>
+              </a:rPr>
+              <a:t>    },</a:t>
+            </a:r>
+          </a:p>
+          <a:p>
+            <a:r>
+              <a:rPr lang="nl-NL" sz="1800" dirty="0">
+                <a:solidFill>
+                  <a:srgbClr val="000000"/>
+                </a:solidFill>
+                <a:latin typeface="Consolas" panose="020B0609020204030204" pitchFamily="49" charset="0"/>
+              </a:rPr>
+              <a:t>    </a:t>
+            </a:r>
+            <a:r>
+              <a:rPr lang="nl-NL" sz="1800" dirty="0">
+                <a:solidFill>
+                  <a:srgbClr val="2E75B6"/>
+                </a:solidFill>
+                <a:latin typeface="Consolas" panose="020B0609020204030204" pitchFamily="49" charset="0"/>
+              </a:rPr>
+              <a:t>"start"</a:t>
+            </a:r>
+            <a:r>
+              <a:rPr lang="nl-NL" sz="1800" dirty="0">
+                <a:solidFill>
+                  <a:srgbClr val="000000"/>
+                </a:solidFill>
+                <a:latin typeface="Consolas" panose="020B0609020204030204" pitchFamily="49" charset="0"/>
+              </a:rPr>
+              <a:t>: [</a:t>
+            </a:r>
+          </a:p>
+          <a:p>
+            <a:r>
+              <a:rPr lang="nl-NL" sz="1800" dirty="0">
+                <a:solidFill>
+                  <a:srgbClr val="000000"/>
+                </a:solidFill>
+                <a:latin typeface="Consolas" panose="020B0609020204030204" pitchFamily="49" charset="0"/>
+              </a:rPr>
+              <a:t>        1,</a:t>
+            </a:r>
+          </a:p>
+          <a:p>
+            <a:r>
+              <a:rPr lang="nl-NL" sz="1800" dirty="0">
+                <a:solidFill>
+                  <a:srgbClr val="000000"/>
+                </a:solidFill>
+                <a:latin typeface="Consolas" panose="020B0609020204030204" pitchFamily="49" charset="0"/>
+              </a:rPr>
+              <a:t>        1</a:t>
+            </a:r>
+          </a:p>
+          <a:p>
+            <a:r>
+              <a:rPr lang="nl-NL" sz="1800" dirty="0">
+                <a:solidFill>
+                  <a:srgbClr val="000000"/>
+                </a:solidFill>
+                <a:latin typeface="Consolas" panose="020B0609020204030204" pitchFamily="49" charset="0"/>
+              </a:rPr>
+              <a:t>    ],</a:t>
+            </a:r>
+          </a:p>
+          <a:p>
+            <a:r>
+              <a:rPr lang="nl-NL" sz="1800" dirty="0">
+                <a:solidFill>
+                  <a:srgbClr val="000000"/>
+                </a:solidFill>
+                <a:latin typeface="Consolas" panose="020B0609020204030204" pitchFamily="49" charset="0"/>
+              </a:rPr>
+              <a:t>    </a:t>
+            </a:r>
+            <a:r>
+              <a:rPr lang="nl-NL" sz="1800" dirty="0">
+                <a:solidFill>
+                  <a:srgbClr val="2E75B6"/>
+                </a:solidFill>
+                <a:latin typeface="Consolas" panose="020B0609020204030204" pitchFamily="49" charset="0"/>
+              </a:rPr>
+              <a:t>"end"</a:t>
+            </a:r>
+            <a:r>
+              <a:rPr lang="nl-NL" sz="1800" dirty="0">
+                <a:solidFill>
+                  <a:srgbClr val="000000"/>
+                </a:solidFill>
+                <a:latin typeface="Consolas" panose="020B0609020204030204" pitchFamily="49" charset="0"/>
+              </a:rPr>
+              <a:t>: [</a:t>
+            </a:r>
+          </a:p>
+          <a:p>
+            <a:r>
+              <a:rPr lang="nl-NL" sz="1800" dirty="0">
+                <a:solidFill>
+                  <a:srgbClr val="000000"/>
+                </a:solidFill>
+                <a:latin typeface="Consolas" panose="020B0609020204030204" pitchFamily="49" charset="0"/>
+              </a:rPr>
+              <a:t>        5,</a:t>
+            </a:r>
+          </a:p>
+          <a:p>
+            <a:r>
+              <a:rPr lang="nl-NL" sz="1800" dirty="0">
+                <a:solidFill>
+                  <a:srgbClr val="000000"/>
+                </a:solidFill>
+                <a:latin typeface="Consolas" panose="020B0609020204030204" pitchFamily="49" charset="0"/>
+              </a:rPr>
+              <a:t>        5</a:t>
+            </a:r>
+          </a:p>
+          <a:p>
+            <a:r>
+              <a:rPr lang="nl-NL" sz="1800" dirty="0">
+                <a:solidFill>
+                  <a:srgbClr val="000000"/>
+                </a:solidFill>
+                <a:latin typeface="Consolas" panose="020B0609020204030204" pitchFamily="49" charset="0"/>
+              </a:rPr>
+              <a:t>    ],</a:t>
+            </a:r>
+          </a:p>
+          <a:p>
+            <a:r>
+              <a:rPr lang="nl-NL" sz="1800" dirty="0">
+                <a:solidFill>
+                  <a:srgbClr val="000000"/>
+                </a:solidFill>
+                <a:latin typeface="Consolas" panose="020B0609020204030204" pitchFamily="49" charset="0"/>
+              </a:rPr>
+              <a:t>    </a:t>
+            </a:r>
+            <a:r>
+              <a:rPr lang="nl-NL" sz="1800" dirty="0">
+                <a:solidFill>
+                  <a:srgbClr val="2E75B6"/>
+                </a:solidFill>
+                <a:latin typeface="Consolas" panose="020B0609020204030204" pitchFamily="49" charset="0"/>
+              </a:rPr>
+              <a:t>"grid"</a:t>
+            </a:r>
+            <a:r>
+              <a:rPr lang="nl-NL" sz="1800" dirty="0">
+                <a:solidFill>
+                  <a:srgbClr val="000000"/>
+                </a:solidFill>
+                <a:latin typeface="Consolas" panose="020B0609020204030204" pitchFamily="49" charset="0"/>
+              </a:rPr>
+              <a:t>: [</a:t>
+            </a:r>
+          </a:p>
+          <a:p>
+            <a:r>
+              <a:rPr lang="nl-NL" sz="1800" dirty="0">
+                <a:solidFill>
+                  <a:srgbClr val="000000"/>
+                </a:solidFill>
+                <a:latin typeface="Consolas" panose="020B0609020204030204" pitchFamily="49" charset="0"/>
+              </a:rPr>
+              <a:t>        [</a:t>
+            </a:r>
+          </a:p>
+          <a:p>
+            <a:r>
+              <a:rPr lang="nl-NL" sz="1800" dirty="0">
+                <a:solidFill>
+                  <a:srgbClr val="000000"/>
+                </a:solidFill>
+                <a:latin typeface="Consolas" panose="020B0609020204030204" pitchFamily="49" charset="0"/>
+              </a:rPr>
+              <a:t>            1,</a:t>
+            </a:r>
+          </a:p>
+          <a:p>
+            <a:r>
+              <a:rPr lang="nl-NL" sz="1800" dirty="0">
+                <a:solidFill>
+                  <a:srgbClr val="000000"/>
+                </a:solidFill>
+                <a:latin typeface="Consolas" panose="020B0609020204030204" pitchFamily="49" charset="0"/>
+              </a:rPr>
+              <a:t>            1,</a:t>
+            </a:r>
+          </a:p>
+          <a:p>
+            <a:r>
+              <a:rPr lang="nl-NL" sz="1800" dirty="0">
+                <a:solidFill>
+                  <a:srgbClr val="000000"/>
+                </a:solidFill>
+                <a:latin typeface="Consolas" panose="020B0609020204030204" pitchFamily="49" charset="0"/>
+              </a:rPr>
+              <a:t>            1,</a:t>
+            </a:r>
+          </a:p>
+          <a:p>
+            <a:r>
+              <a:rPr lang="nl-NL" sz="1800" dirty="0">
+                <a:solidFill>
+                  <a:srgbClr val="000000"/>
+                </a:solidFill>
+                <a:latin typeface="Consolas" panose="020B0609020204030204" pitchFamily="49" charset="0"/>
+              </a:rPr>
+              <a:t>            1,</a:t>
+            </a:r>
+          </a:p>
+          <a:p>
+            <a:r>
+              <a:rPr lang="nl-NL" sz="1800" dirty="0">
+                <a:solidFill>
+                  <a:srgbClr val="000000"/>
+                </a:solidFill>
+                <a:latin typeface="Consolas" panose="020B0609020204030204" pitchFamily="49" charset="0"/>
+              </a:rPr>
+              <a:t>            1,</a:t>
+            </a:r>
+          </a:p>
+          <a:p>
+            <a:r>
+              <a:rPr lang="nl-NL" sz="1800" dirty="0">
+                <a:solidFill>
+                  <a:srgbClr val="000000"/>
+                </a:solidFill>
+                <a:latin typeface="Consolas" panose="020B0609020204030204" pitchFamily="49" charset="0"/>
+              </a:rPr>
+              <a:t>            1,</a:t>
+            </a:r>
+          </a:p>
+          <a:p>
+            <a:r>
+              <a:rPr lang="nl-NL" sz="1800" dirty="0">
+                <a:solidFill>
+                  <a:srgbClr val="000000"/>
+                </a:solidFill>
+                <a:latin typeface="Consolas" panose="020B0609020204030204" pitchFamily="49" charset="0"/>
+              </a:rPr>
+              <a:t>            1</a:t>
+            </a:r>
+          </a:p>
+          <a:p>
+            <a:r>
+              <a:rPr lang="nl-NL" sz="1800" dirty="0">
+                <a:solidFill>
+                  <a:srgbClr val="000000"/>
+                </a:solidFill>
+                <a:latin typeface="Consolas" panose="020B0609020204030204" pitchFamily="49" charset="0"/>
+              </a:rPr>
+              <a:t>        ],</a:t>
+            </a:r>
+          </a:p>
+          <a:p>
+            <a:endParaRPr lang="nl-NL" dirty="0">
+              <a:solidFill>
+                <a:srgbClr val="000000"/>
+              </a:solidFill>
+              <a:latin typeface="Consolas" panose="020B0609020204030204" pitchFamily="49" charset="0"/>
+            </a:endParaRPr>
+          </a:p>
+          <a:p>
+            <a:endParaRPr lang="nl-NL" dirty="0">
+              <a:solidFill>
+                <a:srgbClr val="000000"/>
+              </a:solidFill>
+              <a:latin typeface="Consolas" panose="020B0609020204030204" pitchFamily="49" charset="0"/>
+            </a:endParaRPr>
+          </a:p>
+          <a:p>
+            <a:endParaRPr lang="nl-NL" dirty="0"/>
+          </a:p>
+        </p:txBody>
+      </p:sp>
+      <p:sp>
+        <p:nvSpPr>
+          <p:cNvPr id="9" name="TextBox 8">
+            <a:extLst>
+              <a:ext uri="{FF2B5EF4-FFF2-40B4-BE49-F238E27FC236}">
+                <a16:creationId xmlns:a16="http://schemas.microsoft.com/office/drawing/2014/main" id="{CA5D80C2-6A4D-27B9-89CD-55AB8640ECF7}"/>
+              </a:ext>
+            </a:extLst>
+          </p:cNvPr>
+          <p:cNvSpPr txBox="1"/>
+          <p:nvPr/>
+        </p:nvSpPr>
+        <p:spPr>
+          <a:xfrm>
+            <a:off x="4070257" y="25360"/>
+            <a:ext cx="3199925" cy="369332"/>
+          </a:xfrm>
+          <a:prstGeom prst="rect">
+            <a:avLst/>
+          </a:prstGeom>
+          <a:solidFill>
+            <a:schemeClr val="bg1"/>
+          </a:solidFill>
+        </p:spPr>
+        <p:txBody>
+          <a:bodyPr wrap="square" rtlCol="0">
+            <a:spAutoFit/>
+          </a:bodyPr>
+          <a:lstStyle/>
+          <a:p>
+            <a:r>
+              <a:rPr lang="en-US" b="1" dirty="0"/>
+              <a:t>JSON – Occupancy grid maze</a:t>
+            </a:r>
+            <a:endParaRPr lang="nl-NL" b="1" dirty="0"/>
+          </a:p>
+        </p:txBody>
+      </p:sp>
+      <p:grpSp>
+        <p:nvGrpSpPr>
+          <p:cNvPr id="18" name="Group 17">
+            <a:extLst>
+              <a:ext uri="{FF2B5EF4-FFF2-40B4-BE49-F238E27FC236}">
+                <a16:creationId xmlns:a16="http://schemas.microsoft.com/office/drawing/2014/main" id="{D576F593-2530-ACCA-01A2-6F5DD1FF8EB9}"/>
+              </a:ext>
+            </a:extLst>
+          </p:cNvPr>
+          <p:cNvGrpSpPr/>
+          <p:nvPr/>
+        </p:nvGrpSpPr>
+        <p:grpSpPr>
+          <a:xfrm>
+            <a:off x="12303064" y="1689074"/>
+            <a:ext cx="3947160" cy="1292662"/>
+            <a:chOff x="12386468" y="2787769"/>
+            <a:chExt cx="3947160" cy="1292662"/>
+          </a:xfrm>
+          <a:solidFill>
+            <a:schemeClr val="bg1"/>
+          </a:solidFill>
+        </p:grpSpPr>
+        <p:sp>
+          <p:nvSpPr>
+            <p:cNvPr id="10" name="TextBox 9">
+              <a:extLst>
+                <a:ext uri="{FF2B5EF4-FFF2-40B4-BE49-F238E27FC236}">
+                  <a16:creationId xmlns:a16="http://schemas.microsoft.com/office/drawing/2014/main" id="{4E8AA519-3D7E-F106-D1C5-477D4C79BD09}"/>
+                </a:ext>
+              </a:extLst>
+            </p:cNvPr>
+            <p:cNvSpPr txBox="1"/>
+            <p:nvPr/>
+          </p:nvSpPr>
+          <p:spPr>
+            <a:xfrm>
+              <a:off x="12386468" y="3157101"/>
+              <a:ext cx="3947160" cy="923330"/>
+            </a:xfrm>
+            <a:prstGeom prst="rect">
+              <a:avLst/>
+            </a:prstGeom>
+            <a:grpFill/>
+            <a:ln>
+              <a:solidFill>
+                <a:schemeClr val="tx1"/>
+              </a:solidFill>
+            </a:ln>
+          </p:spPr>
+          <p:txBody>
+            <a:bodyPr wrap="square">
+              <a:spAutoFit/>
+            </a:bodyPr>
+            <a:lstStyle/>
+            <a:p>
+              <a:r>
+                <a:rPr lang="nl-NL" dirty="0"/>
+                <a:t>&lt;|0-0|&gt; &lt;|uprightleft_wall|&gt; &lt;|origin|&gt;</a:t>
+              </a:r>
+            </a:p>
+            <a:p>
+              <a:r>
+                <a:rPr lang="nl-NL" dirty="0"/>
+                <a:t>&lt;|0-1|&gt; &lt;|updownleft_wall|&gt; …</a:t>
+              </a:r>
+            </a:p>
+            <a:p>
+              <a:r>
+                <a:rPr lang="nl-NL" dirty="0"/>
+                <a:t>&lt;|2-2|&gt; &lt;|downright_wall|&gt; &lt;|target|&gt;</a:t>
+              </a:r>
+            </a:p>
+          </p:txBody>
+        </p:sp>
+        <p:sp>
+          <p:nvSpPr>
+            <p:cNvPr id="11" name="TextBox 10">
+              <a:extLst>
+                <a:ext uri="{FF2B5EF4-FFF2-40B4-BE49-F238E27FC236}">
+                  <a16:creationId xmlns:a16="http://schemas.microsoft.com/office/drawing/2014/main" id="{DE880138-F093-B25C-F0D0-998162FD408D}"/>
+                </a:ext>
+              </a:extLst>
+            </p:cNvPr>
+            <p:cNvSpPr txBox="1"/>
+            <p:nvPr/>
+          </p:nvSpPr>
+          <p:spPr>
+            <a:xfrm>
+              <a:off x="12696983" y="2787769"/>
+              <a:ext cx="3326130" cy="369332"/>
+            </a:xfrm>
+            <a:prstGeom prst="rect">
+              <a:avLst/>
+            </a:prstGeom>
+            <a:grpFill/>
+          </p:spPr>
+          <p:txBody>
+            <a:bodyPr wrap="square" rtlCol="0">
+              <a:spAutoFit/>
+            </a:bodyPr>
+            <a:lstStyle/>
+            <a:p>
+              <a:r>
+                <a:rPr lang="en-US" b="1" dirty="0"/>
+                <a:t>Tokenized – Line-walled maze</a:t>
+              </a:r>
+              <a:endParaRPr lang="nl-NL" b="1" dirty="0"/>
+            </a:p>
+          </p:txBody>
+        </p:sp>
+      </p:grpSp>
+      <p:grpSp>
+        <p:nvGrpSpPr>
+          <p:cNvPr id="19" name="Group 18">
+            <a:extLst>
+              <a:ext uri="{FF2B5EF4-FFF2-40B4-BE49-F238E27FC236}">
+                <a16:creationId xmlns:a16="http://schemas.microsoft.com/office/drawing/2014/main" id="{365D7B92-9AD6-8027-F7D8-26E7D6E24865}"/>
+              </a:ext>
+            </a:extLst>
+          </p:cNvPr>
+          <p:cNvGrpSpPr/>
+          <p:nvPr/>
+        </p:nvGrpSpPr>
+        <p:grpSpPr>
+          <a:xfrm>
+            <a:off x="12014872" y="3351068"/>
+            <a:ext cx="4764405" cy="1292662"/>
+            <a:chOff x="9075420" y="10521818"/>
+            <a:chExt cx="4764405" cy="1292662"/>
+          </a:xfrm>
+          <a:solidFill>
+            <a:schemeClr val="bg1"/>
+          </a:solidFill>
+        </p:grpSpPr>
+        <p:sp>
+          <p:nvSpPr>
+            <p:cNvPr id="12" name="TextBox 11">
+              <a:extLst>
+                <a:ext uri="{FF2B5EF4-FFF2-40B4-BE49-F238E27FC236}">
+                  <a16:creationId xmlns:a16="http://schemas.microsoft.com/office/drawing/2014/main" id="{A57B741D-02F8-8BBB-E1AE-6A0E478D25F4}"/>
+                </a:ext>
+              </a:extLst>
+            </p:cNvPr>
+            <p:cNvSpPr txBox="1"/>
+            <p:nvPr/>
+          </p:nvSpPr>
+          <p:spPr>
+            <a:xfrm>
+              <a:off x="9075420" y="10891150"/>
+              <a:ext cx="4764405" cy="923330"/>
+            </a:xfrm>
+            <a:prstGeom prst="rect">
+              <a:avLst/>
+            </a:prstGeom>
+            <a:grpFill/>
+            <a:ln>
+              <a:solidFill>
+                <a:schemeClr val="tx1"/>
+              </a:solidFill>
+            </a:ln>
+          </p:spPr>
+          <p:txBody>
+            <a:bodyPr wrap="square">
+              <a:spAutoFit/>
+            </a:bodyPr>
+            <a:lstStyle/>
+            <a:p>
+              <a:r>
+                <a:rPr lang="nl-NL" dirty="0"/>
+                <a:t>&lt;|0-0|&gt; &lt;|occupied_wall|&gt; … &lt;|1-1|&gt; &lt;|origin|&gt;</a:t>
+              </a:r>
+            </a:p>
+            <a:p>
+              <a:r>
+                <a:rPr lang="nl-NL" dirty="0"/>
+                <a:t> &lt;|1-2|&gt; &lt;|occupied_wall|&gt; &lt;|1-3|&gt; &lt;|blank|&gt; …</a:t>
+              </a:r>
+            </a:p>
+            <a:p>
+              <a:r>
+                <a:rPr lang="nl-NL" dirty="0"/>
+                <a:t> &lt;|5-5|&gt; &lt;|target|&gt; … &lt;|6-6|&gt; &lt;|occupied_wall|&gt;</a:t>
+              </a:r>
+            </a:p>
+          </p:txBody>
+        </p:sp>
+        <p:sp>
+          <p:nvSpPr>
+            <p:cNvPr id="13" name="TextBox 12">
+              <a:extLst>
+                <a:ext uri="{FF2B5EF4-FFF2-40B4-BE49-F238E27FC236}">
+                  <a16:creationId xmlns:a16="http://schemas.microsoft.com/office/drawing/2014/main" id="{F8F086C1-8F8C-BA89-9784-CBE67C1D2F66}"/>
+                </a:ext>
+              </a:extLst>
+            </p:cNvPr>
+            <p:cNvSpPr txBox="1"/>
+            <p:nvPr/>
+          </p:nvSpPr>
+          <p:spPr>
+            <a:xfrm>
+              <a:off x="9561188" y="10521818"/>
+              <a:ext cx="3792868" cy="369332"/>
+            </a:xfrm>
+            <a:prstGeom prst="rect">
+              <a:avLst/>
+            </a:prstGeom>
+            <a:grpFill/>
+          </p:spPr>
+          <p:txBody>
+            <a:bodyPr wrap="square" rtlCol="0">
+              <a:spAutoFit/>
+            </a:bodyPr>
+            <a:lstStyle/>
+            <a:p>
+              <a:r>
+                <a:rPr lang="en-US" b="1" dirty="0"/>
+                <a:t>Tokenized – Occupancy grid maze</a:t>
+              </a:r>
+              <a:endParaRPr lang="nl-NL" b="1" dirty="0"/>
+            </a:p>
+          </p:txBody>
+        </p:sp>
+      </p:grpSp>
+      <p:pic>
+        <p:nvPicPr>
+          <p:cNvPr id="14" name="Picture 13" descr="A group of black symbols&#10;&#10;AI-generated content may be incorrect.">
+            <a:extLst>
+              <a:ext uri="{FF2B5EF4-FFF2-40B4-BE49-F238E27FC236}">
+                <a16:creationId xmlns:a16="http://schemas.microsoft.com/office/drawing/2014/main" id="{1BC7645F-9A46-24FA-4505-F57655F47ED5}"/>
+              </a:ext>
+            </a:extLst>
+          </p:cNvPr>
+          <p:cNvPicPr>
+            <a:picLocks noChangeAspect="1"/>
+          </p:cNvPicPr>
+          <p:nvPr/>
+        </p:nvPicPr>
+        <p:blipFill>
+          <a:blip r:embed="rId2"/>
+          <a:stretch>
+            <a:fillRect/>
+          </a:stretch>
+        </p:blipFill>
+        <p:spPr>
+          <a:xfrm>
+            <a:off x="13676922" y="5353592"/>
+            <a:ext cx="1224372" cy="2332137"/>
+          </a:xfrm>
+          <a:prstGeom prst="rect">
+            <a:avLst/>
+          </a:prstGeom>
+          <a:solidFill>
+            <a:schemeClr val="bg1"/>
+          </a:solidFill>
+        </p:spPr>
+      </p:pic>
+      <p:sp>
+        <p:nvSpPr>
+          <p:cNvPr id="15" name="TextBox 14">
+            <a:extLst>
+              <a:ext uri="{FF2B5EF4-FFF2-40B4-BE49-F238E27FC236}">
+                <a16:creationId xmlns:a16="http://schemas.microsoft.com/office/drawing/2014/main" id="{97644CB0-A6A8-5723-DA02-E68A8FBC115F}"/>
+              </a:ext>
+            </a:extLst>
+          </p:cNvPr>
+          <p:cNvSpPr txBox="1"/>
+          <p:nvPr/>
+        </p:nvSpPr>
+        <p:spPr>
+          <a:xfrm>
+            <a:off x="12380210" y="4984260"/>
+            <a:ext cx="3792868" cy="369332"/>
+          </a:xfrm>
+          <a:prstGeom prst="rect">
+            <a:avLst/>
+          </a:prstGeom>
+          <a:solidFill>
+            <a:schemeClr val="bg1"/>
+          </a:solidFill>
+        </p:spPr>
+        <p:txBody>
+          <a:bodyPr wrap="square" rtlCol="0">
+            <a:spAutoFit/>
+          </a:bodyPr>
+          <a:lstStyle/>
+          <a:p>
+            <a:r>
+              <a:rPr lang="en-US" b="1" dirty="0"/>
+              <a:t>ASCII – Occupancy grid maze</a:t>
+            </a:r>
+            <a:endParaRPr lang="nl-NL" b="1" dirty="0"/>
+          </a:p>
+        </p:txBody>
+      </p:sp>
+      <p:grpSp>
+        <p:nvGrpSpPr>
+          <p:cNvPr id="20" name="Group 19">
+            <a:extLst>
+              <a:ext uri="{FF2B5EF4-FFF2-40B4-BE49-F238E27FC236}">
+                <a16:creationId xmlns:a16="http://schemas.microsoft.com/office/drawing/2014/main" id="{7EF99C10-AF2E-7AF1-C886-5DE5D275A566}"/>
+              </a:ext>
+            </a:extLst>
+          </p:cNvPr>
+          <p:cNvGrpSpPr/>
+          <p:nvPr/>
+        </p:nvGrpSpPr>
+        <p:grpSpPr>
+          <a:xfrm>
+            <a:off x="11529104" y="25360"/>
+            <a:ext cx="5495081" cy="1294382"/>
+            <a:chOff x="11366940" y="28967"/>
+            <a:chExt cx="5495081" cy="1294382"/>
+          </a:xfrm>
+          <a:solidFill>
+            <a:schemeClr val="bg1"/>
+          </a:solidFill>
+        </p:grpSpPr>
+        <p:sp>
+          <p:nvSpPr>
+            <p:cNvPr id="16" name="TextBox 15">
+              <a:extLst>
+                <a:ext uri="{FF2B5EF4-FFF2-40B4-BE49-F238E27FC236}">
+                  <a16:creationId xmlns:a16="http://schemas.microsoft.com/office/drawing/2014/main" id="{5FA97FA0-A0D6-C3AD-B8D1-D2363E474672}"/>
+                </a:ext>
+              </a:extLst>
+            </p:cNvPr>
+            <p:cNvSpPr txBox="1"/>
+            <p:nvPr/>
+          </p:nvSpPr>
+          <p:spPr>
+            <a:xfrm>
+              <a:off x="11366940" y="400019"/>
+              <a:ext cx="5495081" cy="923330"/>
+            </a:xfrm>
+            <a:prstGeom prst="rect">
+              <a:avLst/>
+            </a:prstGeom>
+            <a:grpFill/>
+            <a:ln>
+              <a:solidFill>
+                <a:schemeClr val="tx1"/>
+              </a:solidFill>
+            </a:ln>
+          </p:spPr>
+          <p:txBody>
+            <a:bodyPr wrap="square">
+              <a:spAutoFit/>
+            </a:bodyPr>
+            <a:lstStyle/>
+            <a:p>
+              <a:r>
+                <a:rPr lang="nl-NL" dirty="0"/>
+                <a:t>&lt;ADJLIST_START&gt; (1,1) &lt;–&gt; (2,1) ; … (5,4) &lt;–&gt; (5,5) &lt;ADJLIST_END&gt; &lt;ORIGIN_START&gt;(1,1)&lt;ORIGIN_END&gt; &lt;TARGET_START&gt;(5,5)&lt;TARGET_END&gt; </a:t>
+              </a:r>
+            </a:p>
+          </p:txBody>
+        </p:sp>
+        <p:sp>
+          <p:nvSpPr>
+            <p:cNvPr id="17" name="TextBox 16">
+              <a:extLst>
+                <a:ext uri="{FF2B5EF4-FFF2-40B4-BE49-F238E27FC236}">
+                  <a16:creationId xmlns:a16="http://schemas.microsoft.com/office/drawing/2014/main" id="{9A85206C-30B9-8819-FD90-92127EEDC12B}"/>
+                </a:ext>
+              </a:extLst>
+            </p:cNvPr>
+            <p:cNvSpPr txBox="1"/>
+            <p:nvPr/>
+          </p:nvSpPr>
+          <p:spPr>
+            <a:xfrm>
+              <a:off x="11852708" y="28967"/>
+              <a:ext cx="4523544" cy="369332"/>
+            </a:xfrm>
+            <a:prstGeom prst="rect">
+              <a:avLst/>
+            </a:prstGeom>
+            <a:grpFill/>
+          </p:spPr>
+          <p:txBody>
+            <a:bodyPr wrap="square" rtlCol="0">
+              <a:spAutoFit/>
+            </a:bodyPr>
+            <a:lstStyle/>
+            <a:p>
+              <a:r>
+                <a:rPr lang="en-US" b="1" dirty="0"/>
+                <a:t>Adjacency list text – Both maze styles</a:t>
+              </a:r>
+              <a:endParaRPr lang="nl-NL" b="1" dirty="0"/>
+            </a:p>
+          </p:txBody>
+        </p:sp>
+      </p:grpSp>
+    </p:spTree>
+    <p:extLst>
+      <p:ext uri="{BB962C8B-B14F-4D97-AF65-F5344CB8AC3E}">
+        <p14:creationId xmlns:p14="http://schemas.microsoft.com/office/powerpoint/2010/main" val="3959107173"/>
+      </p:ext>
+    </p:extLst>
+  </p:cSld>
+  <p:clrMapOvr>
+    <a:masterClrMapping/>
+  </p:clrMapOvr>
+</p:sld>
+</file>
+
+<file path=ppt/slides/slide7.xml><?xml version="1.0" encoding="utf-8"?>
+<p:sld xmlns:a="http://schemas.openxmlformats.org/drawingml/2006/main" xmlns:r="http://schemas.openxmlformats.org/officeDocument/2006/relationships" xmlns:p="http://schemas.openxmlformats.org/presentationml/2006/main">
+  <p:cSld>
+    <p:spTree>
+      <p:nvGrpSpPr>
+        <p:cNvPr id="1" name=""/>
+        <p:cNvGrpSpPr/>
+        <p:nvPr/>
+      </p:nvGrpSpPr>
+      <p:grpSpPr>
+        <a:xfrm>
+          <a:off x="0" y="0"/>
+          <a:ext cx="0" cy="0"/>
+          <a:chOff x="0" y="0"/>
+          <a:chExt cx="0" cy="0"/>
+        </a:xfrm>
+      </p:grpSpPr>
+      <p:grpSp>
+        <p:nvGrpSpPr>
+          <p:cNvPr id="69" name="Group 68">
+            <a:extLst>
+              <a:ext uri="{FF2B5EF4-FFF2-40B4-BE49-F238E27FC236}">
+                <a16:creationId xmlns:a16="http://schemas.microsoft.com/office/drawing/2014/main" id="{A5D46F4C-9C97-1A89-9B8C-D42C2B47C0EA}"/>
+              </a:ext>
+            </a:extLst>
+          </p:cNvPr>
+          <p:cNvGrpSpPr/>
+          <p:nvPr/>
+        </p:nvGrpSpPr>
+        <p:grpSpPr>
+          <a:xfrm>
+            <a:off x="-2133599" y="-1099995"/>
+            <a:ext cx="21617351" cy="15174468"/>
+            <a:chOff x="-2133599" y="-1099995"/>
+            <a:chExt cx="21617351" cy="15174468"/>
+          </a:xfrm>
+        </p:grpSpPr>
+        <p:sp>
+          <p:nvSpPr>
+            <p:cNvPr id="4" name="Rectangle 3">
+              <a:extLst>
+                <a:ext uri="{FF2B5EF4-FFF2-40B4-BE49-F238E27FC236}">
+                  <a16:creationId xmlns:a16="http://schemas.microsoft.com/office/drawing/2014/main" id="{8185D54F-5517-1FC6-67B1-191F952A3C6D}"/>
+                </a:ext>
+              </a:extLst>
+            </p:cNvPr>
+            <p:cNvSpPr/>
+            <p:nvPr/>
+          </p:nvSpPr>
+          <p:spPr>
+            <a:xfrm>
+              <a:off x="-2133599" y="-1097280"/>
+              <a:ext cx="21617351" cy="15136808"/>
+            </a:xfrm>
+            <a:prstGeom prst="rect">
+              <a:avLst/>
+            </a:prstGeom>
+            <a:solidFill>
+              <a:schemeClr val="bg1"/>
+            </a:solidFill>
+            <a:ln>
+              <a:solidFill>
+                <a:schemeClr val="tx1"/>
+              </a:solidFill>
+            </a:ln>
+          </p:spPr>
+          <p:style>
+            <a:lnRef idx="2">
+              <a:schemeClr val="accent1">
+                <a:shade val="15000"/>
+              </a:schemeClr>
+            </a:lnRef>
+            <a:fillRef idx="1">
+              <a:schemeClr val="accent1"/>
+            </a:fillRef>
+            <a:effectRef idx="0">
+              <a:schemeClr val="accent1"/>
+            </a:effectRef>
+            <a:fontRef idx="minor">
+              <a:schemeClr val="lt1"/>
+            </a:fontRef>
+          </p:style>
+          <p:txBody>
+            <a:bodyPr rtlCol="0" anchor="ctr"/>
+            <a:lstStyle/>
+            <a:p>
+              <a:pPr algn="ctr"/>
+              <a:endParaRPr lang="nl-NL" dirty="0"/>
+            </a:p>
+          </p:txBody>
+        </p:sp>
+        <p:cxnSp>
+          <p:nvCxnSpPr>
+            <p:cNvPr id="6" name="Straight Connector 5">
+              <a:extLst>
+                <a:ext uri="{FF2B5EF4-FFF2-40B4-BE49-F238E27FC236}">
+                  <a16:creationId xmlns:a16="http://schemas.microsoft.com/office/drawing/2014/main" id="{6D152437-1E0A-54CB-4FB5-5A6FE7F33D07}"/>
+                </a:ext>
+              </a:extLst>
+            </p:cNvPr>
+            <p:cNvCxnSpPr>
+              <a:cxnSpLocks/>
+            </p:cNvCxnSpPr>
+            <p:nvPr/>
+          </p:nvCxnSpPr>
+          <p:spPr>
+            <a:xfrm>
+              <a:off x="-1508760" y="-1097280"/>
+              <a:ext cx="0" cy="15136808"/>
+            </a:xfrm>
+            <a:prstGeom prst="line">
+              <a:avLst/>
+            </a:prstGeom>
+          </p:spPr>
+          <p:style>
+            <a:lnRef idx="2">
+              <a:schemeClr val="dk1"/>
+            </a:lnRef>
+            <a:fillRef idx="0">
+              <a:schemeClr val="dk1"/>
+            </a:fillRef>
+            <a:effectRef idx="1">
+              <a:schemeClr val="dk1"/>
+            </a:effectRef>
+            <a:fontRef idx="minor">
+              <a:schemeClr val="tx1"/>
+            </a:fontRef>
+          </p:style>
+        </p:cxnSp>
+        <p:cxnSp>
+          <p:nvCxnSpPr>
+            <p:cNvPr id="8" name="Straight Connector 7">
+              <a:extLst>
+                <a:ext uri="{FF2B5EF4-FFF2-40B4-BE49-F238E27FC236}">
+                  <a16:creationId xmlns:a16="http://schemas.microsoft.com/office/drawing/2014/main" id="{0246E872-EB40-1CC1-C8FC-36906CAFD3A6}"/>
+                </a:ext>
+              </a:extLst>
+            </p:cNvPr>
+            <p:cNvCxnSpPr>
+              <a:cxnSpLocks/>
+            </p:cNvCxnSpPr>
+            <p:nvPr/>
+          </p:nvCxnSpPr>
+          <p:spPr>
+            <a:xfrm>
+              <a:off x="2614688" y="-1097280"/>
+              <a:ext cx="0" cy="15136808"/>
+            </a:xfrm>
+            <a:prstGeom prst="line">
+              <a:avLst/>
+            </a:prstGeom>
+          </p:spPr>
+          <p:style>
+            <a:lnRef idx="2">
+              <a:schemeClr val="dk1"/>
+            </a:lnRef>
+            <a:fillRef idx="0">
+              <a:schemeClr val="dk1"/>
+            </a:fillRef>
+            <a:effectRef idx="1">
+              <a:schemeClr val="dk1"/>
+            </a:effectRef>
+            <a:fontRef idx="minor">
+              <a:schemeClr val="tx1"/>
+            </a:fontRef>
+          </p:style>
+        </p:cxnSp>
+        <p:cxnSp>
+          <p:nvCxnSpPr>
+            <p:cNvPr id="9" name="Straight Connector 8">
+              <a:extLst>
+                <a:ext uri="{FF2B5EF4-FFF2-40B4-BE49-F238E27FC236}">
+                  <a16:creationId xmlns:a16="http://schemas.microsoft.com/office/drawing/2014/main" id="{70B46D49-F941-6691-D570-5EABD8DD171A}"/>
+                </a:ext>
+              </a:extLst>
+            </p:cNvPr>
+            <p:cNvCxnSpPr>
+              <a:cxnSpLocks/>
+            </p:cNvCxnSpPr>
+            <p:nvPr/>
+          </p:nvCxnSpPr>
+          <p:spPr>
+            <a:xfrm>
+              <a:off x="6242538" y="-1097280"/>
+              <a:ext cx="0" cy="15136808"/>
+            </a:xfrm>
+            <a:prstGeom prst="line">
+              <a:avLst/>
+            </a:prstGeom>
+          </p:spPr>
+          <p:style>
+            <a:lnRef idx="2">
+              <a:schemeClr val="dk1"/>
+            </a:lnRef>
+            <a:fillRef idx="0">
+              <a:schemeClr val="dk1"/>
+            </a:fillRef>
+            <a:effectRef idx="1">
+              <a:schemeClr val="dk1"/>
+            </a:effectRef>
+            <a:fontRef idx="minor">
+              <a:schemeClr val="tx1"/>
+            </a:fontRef>
+          </p:style>
+        </p:cxnSp>
+        <p:cxnSp>
+          <p:nvCxnSpPr>
+            <p:cNvPr id="10" name="Straight Connector 9">
+              <a:extLst>
+                <a:ext uri="{FF2B5EF4-FFF2-40B4-BE49-F238E27FC236}">
+                  <a16:creationId xmlns:a16="http://schemas.microsoft.com/office/drawing/2014/main" id="{C86C0388-1A55-7C1B-3018-D0192062912B}"/>
+                </a:ext>
+              </a:extLst>
+            </p:cNvPr>
+            <p:cNvCxnSpPr>
+              <a:cxnSpLocks/>
+            </p:cNvCxnSpPr>
+            <p:nvPr/>
+          </p:nvCxnSpPr>
+          <p:spPr>
+            <a:xfrm>
+              <a:off x="11848065" y="-1097280"/>
+              <a:ext cx="0" cy="15136808"/>
+            </a:xfrm>
+            <a:prstGeom prst="line">
+              <a:avLst/>
+            </a:prstGeom>
+          </p:spPr>
+          <p:style>
+            <a:lnRef idx="2">
+              <a:schemeClr val="dk1"/>
+            </a:lnRef>
+            <a:fillRef idx="0">
+              <a:schemeClr val="dk1"/>
+            </a:fillRef>
+            <a:effectRef idx="1">
+              <a:schemeClr val="dk1"/>
+            </a:effectRef>
+            <a:fontRef idx="minor">
+              <a:schemeClr val="tx1"/>
+            </a:fontRef>
+          </p:style>
+        </p:cxnSp>
+        <p:cxnSp>
+          <p:nvCxnSpPr>
+            <p:cNvPr id="11" name="Straight Connector 10">
+              <a:extLst>
+                <a:ext uri="{FF2B5EF4-FFF2-40B4-BE49-F238E27FC236}">
+                  <a16:creationId xmlns:a16="http://schemas.microsoft.com/office/drawing/2014/main" id="{08D5FC5A-0BDF-1C30-D8B0-1F4069A9F75B}"/>
+                </a:ext>
+              </a:extLst>
+            </p:cNvPr>
+            <p:cNvCxnSpPr>
+              <a:cxnSpLocks/>
+            </p:cNvCxnSpPr>
+            <p:nvPr/>
+          </p:nvCxnSpPr>
+          <p:spPr>
+            <a:xfrm>
+              <a:off x="16752276" y="-1062335"/>
+              <a:ext cx="0" cy="15136808"/>
+            </a:xfrm>
+            <a:prstGeom prst="line">
+              <a:avLst/>
+            </a:prstGeom>
+          </p:spPr>
+          <p:style>
+            <a:lnRef idx="2">
+              <a:schemeClr val="dk1"/>
+            </a:lnRef>
+            <a:fillRef idx="0">
+              <a:schemeClr val="dk1"/>
+            </a:fillRef>
+            <a:effectRef idx="1">
+              <a:schemeClr val="dk1"/>
+            </a:effectRef>
+            <a:fontRef idx="minor">
+              <a:schemeClr val="tx1"/>
+            </a:fontRef>
+          </p:style>
+        </p:cxnSp>
+        <p:cxnSp>
+          <p:nvCxnSpPr>
+            <p:cNvPr id="12" name="Straight Connector 11">
+              <a:extLst>
+                <a:ext uri="{FF2B5EF4-FFF2-40B4-BE49-F238E27FC236}">
+                  <a16:creationId xmlns:a16="http://schemas.microsoft.com/office/drawing/2014/main" id="{7F7A2DFE-222C-B811-FBF1-116306E3BFF5}"/>
+                </a:ext>
+              </a:extLst>
+            </p:cNvPr>
+            <p:cNvCxnSpPr>
+              <a:cxnSpLocks/>
+            </p:cNvCxnSpPr>
+            <p:nvPr/>
+          </p:nvCxnSpPr>
+          <p:spPr>
+            <a:xfrm flipV="1">
+              <a:off x="-2133599" y="-635615"/>
+              <a:ext cx="21617351" cy="8857"/>
+            </a:xfrm>
+            <a:prstGeom prst="line">
+              <a:avLst/>
+            </a:prstGeom>
+          </p:spPr>
+          <p:style>
+            <a:lnRef idx="2">
+              <a:schemeClr val="dk1"/>
+            </a:lnRef>
+            <a:fillRef idx="0">
+              <a:schemeClr val="dk1"/>
+            </a:fillRef>
+            <a:effectRef idx="1">
+              <a:schemeClr val="dk1"/>
+            </a:effectRef>
+            <a:fontRef idx="minor">
+              <a:schemeClr val="tx1"/>
+            </a:fontRef>
+          </p:style>
+        </p:cxnSp>
+        <p:cxnSp>
+          <p:nvCxnSpPr>
+            <p:cNvPr id="15" name="Straight Connector 14">
+              <a:extLst>
+                <a:ext uri="{FF2B5EF4-FFF2-40B4-BE49-F238E27FC236}">
+                  <a16:creationId xmlns:a16="http://schemas.microsoft.com/office/drawing/2014/main" id="{694C0817-FF3F-2811-201F-011612BCFD16}"/>
+                </a:ext>
+              </a:extLst>
+            </p:cNvPr>
+            <p:cNvCxnSpPr>
+              <a:cxnSpLocks/>
+            </p:cNvCxnSpPr>
+            <p:nvPr/>
+          </p:nvCxnSpPr>
+          <p:spPr>
+            <a:xfrm flipV="1">
+              <a:off x="-2133599" y="6702492"/>
+              <a:ext cx="21617351" cy="40521"/>
+            </a:xfrm>
+            <a:prstGeom prst="line">
+              <a:avLst/>
+            </a:prstGeom>
+          </p:spPr>
+          <p:style>
+            <a:lnRef idx="2">
+              <a:schemeClr val="dk1"/>
+            </a:lnRef>
+            <a:fillRef idx="0">
+              <a:schemeClr val="dk1"/>
+            </a:fillRef>
+            <a:effectRef idx="1">
+              <a:schemeClr val="dk1"/>
+            </a:effectRef>
+            <a:fontRef idx="minor">
+              <a:schemeClr val="tx1"/>
+            </a:fontRef>
+          </p:style>
+        </p:cxnSp>
+        <p:sp>
+          <p:nvSpPr>
+            <p:cNvPr id="17" name="TextBox 16">
+              <a:extLst>
+                <a:ext uri="{FF2B5EF4-FFF2-40B4-BE49-F238E27FC236}">
+                  <a16:creationId xmlns:a16="http://schemas.microsoft.com/office/drawing/2014/main" id="{D86D04D0-46CE-AB82-0FC0-6DCF2A04371B}"/>
+                </a:ext>
+              </a:extLst>
+            </p:cNvPr>
+            <p:cNvSpPr txBox="1"/>
+            <p:nvPr/>
+          </p:nvSpPr>
+          <p:spPr>
+            <a:xfrm rot="16200000">
+              <a:off x="-3453982" y="2380446"/>
+              <a:ext cx="3265605" cy="461665"/>
+            </a:xfrm>
+            <a:prstGeom prst="rect">
+              <a:avLst/>
+            </a:prstGeom>
+            <a:noFill/>
+          </p:spPr>
+          <p:txBody>
+            <a:bodyPr wrap="square" rtlCol="0">
+              <a:spAutoFit/>
+            </a:bodyPr>
+            <a:lstStyle/>
+            <a:p>
+              <a:r>
+                <a:rPr lang="en-US" sz="2400" b="1" dirty="0"/>
+                <a:t>Line-Walled Maze</a:t>
+              </a:r>
+              <a:endParaRPr lang="nl-NL" sz="2400" b="1" dirty="0"/>
+            </a:p>
+          </p:txBody>
+        </p:sp>
+        <p:sp>
+          <p:nvSpPr>
+            <p:cNvPr id="18" name="TextBox 17">
+              <a:extLst>
+                <a:ext uri="{FF2B5EF4-FFF2-40B4-BE49-F238E27FC236}">
+                  <a16:creationId xmlns:a16="http://schemas.microsoft.com/office/drawing/2014/main" id="{DF408063-1910-02CD-1480-CDBAE9CDCADD}"/>
+                </a:ext>
+              </a:extLst>
+            </p:cNvPr>
+            <p:cNvSpPr txBox="1"/>
+            <p:nvPr/>
+          </p:nvSpPr>
+          <p:spPr>
+            <a:xfrm rot="16200000">
+              <a:off x="-3666417" y="9888589"/>
+              <a:ext cx="3690479" cy="461665"/>
+            </a:xfrm>
+            <a:prstGeom prst="rect">
+              <a:avLst/>
+            </a:prstGeom>
+            <a:noFill/>
+          </p:spPr>
+          <p:txBody>
+            <a:bodyPr wrap="square" rtlCol="0">
+              <a:spAutoFit/>
+            </a:bodyPr>
+            <a:lstStyle/>
+            <a:p>
+              <a:r>
+                <a:rPr lang="en-US" sz="2400" b="1" dirty="0"/>
+                <a:t>Occupancy Grid Maze</a:t>
+              </a:r>
+              <a:endParaRPr lang="nl-NL" sz="2400" b="1" dirty="0"/>
+            </a:p>
+          </p:txBody>
+        </p:sp>
+        <p:sp>
+          <p:nvSpPr>
+            <p:cNvPr id="19" name="TextBox 18">
+              <a:extLst>
+                <a:ext uri="{FF2B5EF4-FFF2-40B4-BE49-F238E27FC236}">
+                  <a16:creationId xmlns:a16="http://schemas.microsoft.com/office/drawing/2014/main" id="{0C19CC43-F19C-ADAA-AC46-27E8A5F85F29}"/>
+                </a:ext>
+              </a:extLst>
+            </p:cNvPr>
+            <p:cNvSpPr txBox="1"/>
+            <p:nvPr/>
+          </p:nvSpPr>
+          <p:spPr>
+            <a:xfrm>
+              <a:off x="-262678" y="-1085232"/>
+              <a:ext cx="1011112" cy="461665"/>
+            </a:xfrm>
+            <a:prstGeom prst="rect">
+              <a:avLst/>
+            </a:prstGeom>
+            <a:noFill/>
+          </p:spPr>
+          <p:txBody>
+            <a:bodyPr wrap="square" rtlCol="0">
+              <a:spAutoFit/>
+            </a:bodyPr>
+            <a:lstStyle/>
+            <a:p>
+              <a:r>
+                <a:rPr lang="en-US" sz="2400" b="1" dirty="0"/>
+                <a:t>JSON</a:t>
+              </a:r>
+              <a:endParaRPr lang="nl-NL" sz="2400" b="1" dirty="0"/>
+            </a:p>
+          </p:txBody>
+        </p:sp>
+        <p:sp>
+          <p:nvSpPr>
+            <p:cNvPr id="20" name="TextBox 19">
+              <a:extLst>
+                <a:ext uri="{FF2B5EF4-FFF2-40B4-BE49-F238E27FC236}">
+                  <a16:creationId xmlns:a16="http://schemas.microsoft.com/office/drawing/2014/main" id="{1D91046D-136B-DED4-636F-27F90E2553B1}"/>
+                </a:ext>
+              </a:extLst>
+            </p:cNvPr>
+            <p:cNvSpPr txBox="1"/>
+            <p:nvPr/>
+          </p:nvSpPr>
+          <p:spPr>
+            <a:xfrm>
+              <a:off x="2887666" y="-1062335"/>
+              <a:ext cx="3078146" cy="461665"/>
+            </a:xfrm>
+            <a:prstGeom prst="rect">
+              <a:avLst/>
+            </a:prstGeom>
+            <a:noFill/>
+          </p:spPr>
+          <p:txBody>
+            <a:bodyPr wrap="square" rtlCol="0">
+              <a:spAutoFit/>
+            </a:bodyPr>
+            <a:lstStyle/>
+            <a:p>
+              <a:r>
+                <a:rPr lang="en-US" sz="2400" b="1" dirty="0"/>
+                <a:t>Adjacency List JSON</a:t>
+              </a:r>
+              <a:endParaRPr lang="nl-NL" sz="2400" b="1" dirty="0"/>
+            </a:p>
+          </p:txBody>
+        </p:sp>
+        <p:sp>
+          <p:nvSpPr>
+            <p:cNvPr id="21" name="TextBox 20">
+              <a:extLst>
+                <a:ext uri="{FF2B5EF4-FFF2-40B4-BE49-F238E27FC236}">
+                  <a16:creationId xmlns:a16="http://schemas.microsoft.com/office/drawing/2014/main" id="{2C0D92E9-F8A8-EA55-F46D-FD39110C625F}"/>
+                </a:ext>
+              </a:extLst>
+            </p:cNvPr>
+            <p:cNvSpPr txBox="1"/>
+            <p:nvPr/>
+          </p:nvSpPr>
+          <p:spPr>
+            <a:xfrm>
+              <a:off x="7189729" y="-1062335"/>
+              <a:ext cx="2970694" cy="461665"/>
+            </a:xfrm>
+            <a:prstGeom prst="rect">
+              <a:avLst/>
+            </a:prstGeom>
+            <a:noFill/>
+          </p:spPr>
+          <p:txBody>
+            <a:bodyPr wrap="square" rtlCol="0">
+              <a:spAutoFit/>
+            </a:bodyPr>
+            <a:lstStyle/>
+            <a:p>
+              <a:r>
+                <a:rPr lang="en-US" sz="2400" b="1" dirty="0"/>
+                <a:t>Adjacency List Text</a:t>
+              </a:r>
+              <a:endParaRPr lang="nl-NL" sz="2400" b="1" dirty="0"/>
+            </a:p>
+          </p:txBody>
+        </p:sp>
+        <p:sp>
+          <p:nvSpPr>
+            <p:cNvPr id="22" name="TextBox 21">
+              <a:extLst>
+                <a:ext uri="{FF2B5EF4-FFF2-40B4-BE49-F238E27FC236}">
+                  <a16:creationId xmlns:a16="http://schemas.microsoft.com/office/drawing/2014/main" id="{436373C8-B4EA-A7CC-297B-6590AB9D6E11}"/>
+                </a:ext>
+              </a:extLst>
+            </p:cNvPr>
+            <p:cNvSpPr txBox="1"/>
+            <p:nvPr/>
+          </p:nvSpPr>
+          <p:spPr>
+            <a:xfrm>
+              <a:off x="12945746" y="-1068646"/>
+              <a:ext cx="1962818" cy="461665"/>
+            </a:xfrm>
+            <a:prstGeom prst="rect">
+              <a:avLst/>
+            </a:prstGeom>
+            <a:noFill/>
+          </p:spPr>
+          <p:txBody>
+            <a:bodyPr wrap="square" rtlCol="0">
+              <a:spAutoFit/>
+            </a:bodyPr>
+            <a:lstStyle/>
+            <a:p>
+              <a:r>
+                <a:rPr lang="en-US" sz="2400" b="1" dirty="0"/>
+                <a:t>Tokenized</a:t>
+              </a:r>
+              <a:endParaRPr lang="nl-NL" sz="2400" b="1" dirty="0"/>
+            </a:p>
+          </p:txBody>
+        </p:sp>
+        <p:sp>
+          <p:nvSpPr>
+            <p:cNvPr id="23" name="TextBox 22">
+              <a:extLst>
+                <a:ext uri="{FF2B5EF4-FFF2-40B4-BE49-F238E27FC236}">
+                  <a16:creationId xmlns:a16="http://schemas.microsoft.com/office/drawing/2014/main" id="{92FB5FC7-D6C3-1846-FB9F-1E8E46B75B33}"/>
+                </a:ext>
+              </a:extLst>
+            </p:cNvPr>
+            <p:cNvSpPr txBox="1"/>
+            <p:nvPr/>
+          </p:nvSpPr>
+          <p:spPr>
+            <a:xfrm>
+              <a:off x="17542552" y="-1099995"/>
+              <a:ext cx="1150923" cy="461665"/>
+            </a:xfrm>
+            <a:prstGeom prst="rect">
+              <a:avLst/>
+            </a:prstGeom>
+            <a:noFill/>
+          </p:spPr>
+          <p:txBody>
+            <a:bodyPr wrap="square" rtlCol="0">
+              <a:spAutoFit/>
+            </a:bodyPr>
+            <a:lstStyle/>
+            <a:p>
+              <a:r>
+                <a:rPr lang="en-US" sz="2400" b="1" dirty="0"/>
+                <a:t>ASCII</a:t>
+              </a:r>
+              <a:endParaRPr lang="nl-NL" sz="2400" b="1" dirty="0"/>
+            </a:p>
+          </p:txBody>
+        </p:sp>
+        <p:sp>
+          <p:nvSpPr>
+            <p:cNvPr id="25" name="TextBox 24">
+              <a:extLst>
+                <a:ext uri="{FF2B5EF4-FFF2-40B4-BE49-F238E27FC236}">
+                  <a16:creationId xmlns:a16="http://schemas.microsoft.com/office/drawing/2014/main" id="{A8530156-43DD-B789-F69B-618A70AC31D6}"/>
+                </a:ext>
+              </a:extLst>
+            </p:cNvPr>
+            <p:cNvSpPr txBox="1"/>
+            <p:nvPr/>
+          </p:nvSpPr>
+          <p:spPr>
+            <a:xfrm>
+              <a:off x="-1470074" y="-620375"/>
+              <a:ext cx="4082889" cy="6463308"/>
+            </a:xfrm>
+            <a:prstGeom prst="rect">
+              <a:avLst/>
+            </a:prstGeom>
+            <a:noFill/>
+            <a:ln>
+              <a:noFill/>
+            </a:ln>
+          </p:spPr>
+          <p:txBody>
+            <a:bodyPr wrap="square">
+              <a:spAutoFit/>
+            </a:bodyPr>
+            <a:lstStyle/>
+            <a:p>
+              <a:r>
+                <a:rPr lang="nl-NL" sz="1800" dirty="0">
+                  <a:solidFill>
+                    <a:srgbClr val="000000"/>
+                  </a:solidFill>
+                  <a:latin typeface="Consolas" panose="020B0609020204030204" pitchFamily="49" charset="0"/>
+                </a:rPr>
+                <a:t>{</a:t>
+              </a:r>
+            </a:p>
+            <a:p>
+              <a:r>
+                <a:rPr lang="nl-NL" sz="1800" dirty="0">
+                  <a:solidFill>
+                    <a:srgbClr val="000000"/>
+                  </a:solidFill>
+                  <a:latin typeface="Consolas" panose="020B0609020204030204" pitchFamily="49" charset="0"/>
+                </a:rPr>
+                <a:t>    </a:t>
+              </a:r>
+              <a:r>
+                <a:rPr lang="nl-NL" sz="1800" dirty="0">
+                  <a:solidFill>
+                    <a:srgbClr val="2E75B6"/>
+                  </a:solidFill>
+                  <a:latin typeface="Consolas" panose="020B0609020204030204" pitchFamily="49" charset="0"/>
+                </a:rPr>
+                <a:t>"size"</a:t>
+              </a:r>
+              <a:r>
+                <a:rPr lang="nl-NL" sz="1800" dirty="0">
+                  <a:solidFill>
+                    <a:srgbClr val="000000"/>
+                  </a:solidFill>
+                  <a:latin typeface="Consolas" panose="020B0609020204030204" pitchFamily="49" charset="0"/>
+                </a:rPr>
+                <a:t>: {</a:t>
+              </a:r>
+            </a:p>
+            <a:p>
+              <a:r>
+                <a:rPr lang="nl-NL" sz="1800" dirty="0">
+                  <a:solidFill>
+                    <a:srgbClr val="000000"/>
+                  </a:solidFill>
+                  <a:latin typeface="Consolas" panose="020B0609020204030204" pitchFamily="49" charset="0"/>
+                </a:rPr>
+                <a:t>        </a:t>
+              </a:r>
+              <a:r>
+                <a:rPr lang="nl-NL" sz="1800" dirty="0">
+                  <a:solidFill>
+                    <a:srgbClr val="2E75B6"/>
+                  </a:solidFill>
+                  <a:latin typeface="Consolas" panose="020B0609020204030204" pitchFamily="49" charset="0"/>
+                </a:rPr>
+                <a:t>"columns"</a:t>
+              </a:r>
+              <a:r>
+                <a:rPr lang="nl-NL" sz="1800" dirty="0">
+                  <a:solidFill>
+                    <a:srgbClr val="000000"/>
+                  </a:solidFill>
+                  <a:latin typeface="Consolas" panose="020B0609020204030204" pitchFamily="49" charset="0"/>
+                </a:rPr>
+                <a:t>: 3,</a:t>
+              </a:r>
+            </a:p>
+            <a:p>
+              <a:r>
+                <a:rPr lang="nl-NL" sz="1800" dirty="0">
+                  <a:solidFill>
+                    <a:srgbClr val="000000"/>
+                  </a:solidFill>
+                  <a:latin typeface="Consolas" panose="020B0609020204030204" pitchFamily="49" charset="0"/>
+                </a:rPr>
+                <a:t>        </a:t>
+              </a:r>
+              <a:r>
+                <a:rPr lang="nl-NL" sz="1800" dirty="0">
+                  <a:solidFill>
+                    <a:srgbClr val="2E75B6"/>
+                  </a:solidFill>
+                  <a:latin typeface="Consolas" panose="020B0609020204030204" pitchFamily="49" charset="0"/>
+                </a:rPr>
+                <a:t>"rows"</a:t>
+              </a:r>
+              <a:r>
+                <a:rPr lang="nl-NL" sz="1800" dirty="0">
+                  <a:solidFill>
+                    <a:srgbClr val="000000"/>
+                  </a:solidFill>
+                  <a:latin typeface="Consolas" panose="020B0609020204030204" pitchFamily="49" charset="0"/>
+                </a:rPr>
+                <a:t>: 3</a:t>
+              </a:r>
+            </a:p>
+            <a:p>
+              <a:r>
+                <a:rPr lang="nl-NL" sz="1800" dirty="0">
+                  <a:solidFill>
+                    <a:srgbClr val="000000"/>
+                  </a:solidFill>
+                  <a:latin typeface="Consolas" panose="020B0609020204030204" pitchFamily="49" charset="0"/>
+                </a:rPr>
+                <a:t>    },</a:t>
+              </a:r>
+            </a:p>
+            <a:p>
+              <a:r>
+                <a:rPr lang="nl-NL" sz="1800" dirty="0">
+                  <a:solidFill>
+                    <a:srgbClr val="000000"/>
+                  </a:solidFill>
+                  <a:latin typeface="Consolas" panose="020B0609020204030204" pitchFamily="49" charset="0"/>
+                </a:rPr>
+                <a:t>    </a:t>
+              </a:r>
+              <a:r>
+                <a:rPr lang="nl-NL" sz="1800" dirty="0">
+                  <a:solidFill>
+                    <a:srgbClr val="2E75B6"/>
+                  </a:solidFill>
+                  <a:latin typeface="Consolas" panose="020B0609020204030204" pitchFamily="49" charset="0"/>
+                </a:rPr>
+                <a:t>"start"</a:t>
+              </a:r>
+              <a:r>
+                <a:rPr lang="nl-NL" sz="1800" dirty="0">
+                  <a:solidFill>
+                    <a:srgbClr val="000000"/>
+                  </a:solidFill>
+                  <a:latin typeface="Consolas" panose="020B0609020204030204" pitchFamily="49" charset="0"/>
+                </a:rPr>
+                <a:t>: [</a:t>
+              </a:r>
+            </a:p>
+            <a:p>
+              <a:r>
+                <a:rPr lang="nl-NL" sz="1800" dirty="0">
+                  <a:solidFill>
+                    <a:srgbClr val="000000"/>
+                  </a:solidFill>
+                  <a:latin typeface="Consolas" panose="020B0609020204030204" pitchFamily="49" charset="0"/>
+                </a:rPr>
+                <a:t>        0,</a:t>
+              </a:r>
+            </a:p>
+            <a:p>
+              <a:r>
+                <a:rPr lang="nl-NL" sz="1800" dirty="0">
+                  <a:solidFill>
+                    <a:srgbClr val="000000"/>
+                  </a:solidFill>
+                  <a:latin typeface="Consolas" panose="020B0609020204030204" pitchFamily="49" charset="0"/>
+                </a:rPr>
+                <a:t>        0</a:t>
+              </a:r>
+            </a:p>
+            <a:p>
+              <a:r>
+                <a:rPr lang="nl-NL" sz="1800" dirty="0">
+                  <a:solidFill>
+                    <a:srgbClr val="000000"/>
+                  </a:solidFill>
+                  <a:latin typeface="Consolas" panose="020B0609020204030204" pitchFamily="49" charset="0"/>
+                </a:rPr>
+                <a:t>    ],</a:t>
+              </a:r>
+            </a:p>
+            <a:p>
+              <a:r>
+                <a:rPr lang="nl-NL" sz="1800" dirty="0">
+                  <a:solidFill>
+                    <a:srgbClr val="000000"/>
+                  </a:solidFill>
+                  <a:latin typeface="Consolas" panose="020B0609020204030204" pitchFamily="49" charset="0"/>
+                </a:rPr>
+                <a:t>    </a:t>
+              </a:r>
+              <a:r>
+                <a:rPr lang="nl-NL" sz="1800" dirty="0">
+                  <a:solidFill>
+                    <a:srgbClr val="2E75B6"/>
+                  </a:solidFill>
+                  <a:latin typeface="Consolas" panose="020B0609020204030204" pitchFamily="49" charset="0"/>
+                </a:rPr>
+                <a:t>"end"</a:t>
+              </a:r>
+              <a:r>
+                <a:rPr lang="nl-NL" sz="1800" dirty="0">
+                  <a:solidFill>
+                    <a:srgbClr val="000000"/>
+                  </a:solidFill>
+                  <a:latin typeface="Consolas" panose="020B0609020204030204" pitchFamily="49" charset="0"/>
+                </a:rPr>
+                <a:t>: [</a:t>
+              </a:r>
+            </a:p>
+            <a:p>
+              <a:r>
+                <a:rPr lang="nl-NL" sz="1800" dirty="0">
+                  <a:solidFill>
+                    <a:srgbClr val="000000"/>
+                  </a:solidFill>
+                  <a:latin typeface="Consolas" panose="020B0609020204030204" pitchFamily="49" charset="0"/>
+                </a:rPr>
+                <a:t>        2,</a:t>
+              </a:r>
+            </a:p>
+            <a:p>
+              <a:r>
+                <a:rPr lang="nl-NL" sz="1800" dirty="0">
+                  <a:solidFill>
+                    <a:srgbClr val="000000"/>
+                  </a:solidFill>
+                  <a:latin typeface="Consolas" panose="020B0609020204030204" pitchFamily="49" charset="0"/>
+                </a:rPr>
+                <a:t>        2</a:t>
+              </a:r>
+            </a:p>
+            <a:p>
+              <a:r>
+                <a:rPr lang="nl-NL" sz="1800" dirty="0">
+                  <a:solidFill>
+                    <a:srgbClr val="000000"/>
+                  </a:solidFill>
+                  <a:latin typeface="Consolas" panose="020B0609020204030204" pitchFamily="49" charset="0"/>
+                </a:rPr>
+                <a:t>    ],</a:t>
+              </a:r>
+            </a:p>
+            <a:p>
+              <a:r>
+                <a:rPr lang="nl-NL" sz="1800" dirty="0">
+                  <a:solidFill>
+                    <a:srgbClr val="000000"/>
+                  </a:solidFill>
+                  <a:latin typeface="Consolas" panose="020B0609020204030204" pitchFamily="49" charset="0"/>
+                </a:rPr>
+                <a:t>    </a:t>
+              </a:r>
+              <a:r>
+                <a:rPr lang="nl-NL" sz="1800" dirty="0">
+                  <a:solidFill>
+                    <a:srgbClr val="2E75B6"/>
+                  </a:solidFill>
+                  <a:latin typeface="Consolas" panose="020B0609020204030204" pitchFamily="49" charset="0"/>
+                </a:rPr>
+                <a:t>"grid"</a:t>
+              </a:r>
+              <a:r>
+                <a:rPr lang="nl-NL" sz="1800" dirty="0">
+                  <a:solidFill>
+                    <a:srgbClr val="000000"/>
+                  </a:solidFill>
+                  <a:latin typeface="Consolas" panose="020B0609020204030204" pitchFamily="49" charset="0"/>
+                </a:rPr>
+                <a:t>: [</a:t>
+              </a:r>
+            </a:p>
+            <a:p>
+              <a:r>
+                <a:rPr lang="nl-NL" sz="1800" dirty="0">
+                  <a:solidFill>
+                    <a:srgbClr val="000000"/>
+                  </a:solidFill>
+                  <a:latin typeface="Consolas" panose="020B0609020204030204" pitchFamily="49" charset="0"/>
+                </a:rPr>
+                <a:t>        [</a:t>
+              </a:r>
+            </a:p>
+            <a:p>
+              <a:r>
+                <a:rPr lang="nl-NL" sz="1800" dirty="0">
+                  <a:solidFill>
+                    <a:srgbClr val="000000"/>
+                  </a:solidFill>
+                  <a:latin typeface="Consolas" panose="020B0609020204030204" pitchFamily="49" charset="0"/>
+                </a:rPr>
+                <a:t>            {</a:t>
+              </a:r>
+            </a:p>
+            <a:p>
+              <a:r>
+                <a:rPr lang="nl-NL" sz="1800" dirty="0">
+                  <a:solidFill>
+                    <a:srgbClr val="000000"/>
+                  </a:solidFill>
+                  <a:latin typeface="Consolas" panose="020B0609020204030204" pitchFamily="49" charset="0"/>
+                </a:rPr>
+                <a:t>                </a:t>
+              </a:r>
+              <a:r>
+                <a:rPr lang="nl-NL" sz="1800" dirty="0">
+                  <a:solidFill>
+                    <a:srgbClr val="2E75B6"/>
+                  </a:solidFill>
+                  <a:latin typeface="Consolas" panose="020B0609020204030204" pitchFamily="49" charset="0"/>
+                </a:rPr>
+                <a:t>"walls"</a:t>
+              </a:r>
+              <a:r>
+                <a:rPr lang="nl-NL" sz="1800" dirty="0">
+                  <a:solidFill>
+                    <a:srgbClr val="000000"/>
+                  </a:solidFill>
+                  <a:latin typeface="Consolas" panose="020B0609020204030204" pitchFamily="49" charset="0"/>
+                </a:rPr>
+                <a:t>: {</a:t>
+              </a:r>
+            </a:p>
+            <a:p>
+              <a:r>
+                <a:rPr lang="nl-NL" sz="1800" dirty="0">
+                  <a:solidFill>
+                    <a:srgbClr val="000000"/>
+                  </a:solidFill>
+                  <a:latin typeface="Consolas" panose="020B0609020204030204" pitchFamily="49" charset="0"/>
+                </a:rPr>
+                <a:t>                    </a:t>
+              </a:r>
+              <a:r>
+                <a:rPr lang="nl-NL" sz="1800" dirty="0">
+                  <a:solidFill>
+                    <a:srgbClr val="2E75B6"/>
+                  </a:solidFill>
+                  <a:latin typeface="Consolas" panose="020B0609020204030204" pitchFamily="49" charset="0"/>
+                </a:rPr>
+                <a:t>"N"</a:t>
+              </a:r>
+              <a:r>
+                <a:rPr lang="nl-NL" sz="1800" dirty="0">
+                  <a:solidFill>
+                    <a:srgbClr val="000000"/>
+                  </a:solidFill>
+                  <a:latin typeface="Consolas" panose="020B0609020204030204" pitchFamily="49" charset="0"/>
+                </a:rPr>
+                <a:t>: </a:t>
+              </a:r>
+              <a:r>
+                <a:rPr lang="nl-NL" sz="1800" dirty="0">
+                  <a:solidFill>
+                    <a:srgbClr val="0000FF"/>
+                  </a:solidFill>
+                  <a:latin typeface="Consolas" panose="020B0609020204030204" pitchFamily="49" charset="0"/>
+                </a:rPr>
+                <a:t>true</a:t>
+              </a:r>
+              <a:r>
+                <a:rPr lang="nl-NL" sz="1800" dirty="0">
+                  <a:solidFill>
+                    <a:srgbClr val="000000"/>
+                  </a:solidFill>
+                  <a:latin typeface="Consolas" panose="020B0609020204030204" pitchFamily="49" charset="0"/>
+                </a:rPr>
+                <a:t>,</a:t>
+              </a:r>
+            </a:p>
+            <a:p>
+              <a:r>
+                <a:rPr lang="nl-NL" sz="1800" dirty="0">
+                  <a:solidFill>
+                    <a:srgbClr val="000000"/>
+                  </a:solidFill>
+                  <a:latin typeface="Consolas" panose="020B0609020204030204" pitchFamily="49" charset="0"/>
+                </a:rPr>
+                <a:t>                    </a:t>
+              </a:r>
+              <a:r>
+                <a:rPr lang="nl-NL" sz="1800" dirty="0">
+                  <a:solidFill>
+                    <a:srgbClr val="2E75B6"/>
+                  </a:solidFill>
+                  <a:latin typeface="Consolas" panose="020B0609020204030204" pitchFamily="49" charset="0"/>
+                </a:rPr>
+                <a:t>"E"</a:t>
+              </a:r>
+              <a:r>
+                <a:rPr lang="nl-NL" sz="1800" dirty="0">
+                  <a:solidFill>
+                    <a:srgbClr val="000000"/>
+                  </a:solidFill>
+                  <a:latin typeface="Consolas" panose="020B0609020204030204" pitchFamily="49" charset="0"/>
+                </a:rPr>
+                <a:t>: </a:t>
+              </a:r>
+              <a:r>
+                <a:rPr lang="nl-NL" sz="1800" dirty="0">
+                  <a:solidFill>
+                    <a:srgbClr val="0000FF"/>
+                  </a:solidFill>
+                  <a:latin typeface="Consolas" panose="020B0609020204030204" pitchFamily="49" charset="0"/>
+                </a:rPr>
+                <a:t>true</a:t>
+              </a:r>
+              <a:r>
+                <a:rPr lang="nl-NL" sz="1800" dirty="0">
+                  <a:solidFill>
+                    <a:srgbClr val="000000"/>
+                  </a:solidFill>
+                  <a:latin typeface="Consolas" panose="020B0609020204030204" pitchFamily="49" charset="0"/>
+                </a:rPr>
+                <a:t>,</a:t>
+              </a:r>
+            </a:p>
+            <a:p>
+              <a:r>
+                <a:rPr lang="nl-NL" sz="1800" dirty="0">
+                  <a:solidFill>
+                    <a:srgbClr val="000000"/>
+                  </a:solidFill>
+                  <a:latin typeface="Consolas" panose="020B0609020204030204" pitchFamily="49" charset="0"/>
+                </a:rPr>
+                <a:t>                    </a:t>
+              </a:r>
+              <a:r>
+                <a:rPr lang="nl-NL" sz="1800" dirty="0">
+                  <a:solidFill>
+                    <a:srgbClr val="2E75B6"/>
+                  </a:solidFill>
+                  <a:latin typeface="Consolas" panose="020B0609020204030204" pitchFamily="49" charset="0"/>
+                </a:rPr>
+                <a:t>"S"</a:t>
+              </a:r>
+              <a:r>
+                <a:rPr lang="nl-NL" sz="1800" dirty="0">
+                  <a:solidFill>
+                    <a:srgbClr val="000000"/>
+                  </a:solidFill>
+                  <a:latin typeface="Consolas" panose="020B0609020204030204" pitchFamily="49" charset="0"/>
+                </a:rPr>
+                <a:t>: </a:t>
+              </a:r>
+              <a:r>
+                <a:rPr lang="nl-NL" sz="1800" dirty="0">
+                  <a:solidFill>
+                    <a:srgbClr val="0000FF"/>
+                  </a:solidFill>
+                  <a:latin typeface="Consolas" panose="020B0609020204030204" pitchFamily="49" charset="0"/>
+                </a:rPr>
+                <a:t>false</a:t>
+              </a:r>
+              <a:r>
+                <a:rPr lang="nl-NL" sz="1800" dirty="0">
+                  <a:solidFill>
+                    <a:srgbClr val="000000"/>
+                  </a:solidFill>
+                  <a:latin typeface="Consolas" panose="020B0609020204030204" pitchFamily="49" charset="0"/>
+                </a:rPr>
+                <a:t>,</a:t>
+              </a:r>
+            </a:p>
+            <a:p>
+              <a:r>
+                <a:rPr lang="nl-NL" sz="1800" dirty="0">
+                  <a:solidFill>
+                    <a:srgbClr val="000000"/>
+                  </a:solidFill>
+                  <a:latin typeface="Consolas" panose="020B0609020204030204" pitchFamily="49" charset="0"/>
+                </a:rPr>
+                <a:t>                    </a:t>
+              </a:r>
+              <a:r>
+                <a:rPr lang="nl-NL" sz="1800" dirty="0">
+                  <a:solidFill>
+                    <a:srgbClr val="2E75B6"/>
+                  </a:solidFill>
+                  <a:latin typeface="Consolas" panose="020B0609020204030204" pitchFamily="49" charset="0"/>
+                </a:rPr>
+                <a:t>"W"</a:t>
+              </a:r>
+              <a:r>
+                <a:rPr lang="nl-NL" sz="1800" dirty="0">
+                  <a:solidFill>
+                    <a:srgbClr val="000000"/>
+                  </a:solidFill>
+                  <a:latin typeface="Consolas" panose="020B0609020204030204" pitchFamily="49" charset="0"/>
+                </a:rPr>
+                <a:t>: </a:t>
+              </a:r>
+              <a:r>
+                <a:rPr lang="nl-NL" sz="1800" dirty="0">
+                  <a:solidFill>
+                    <a:srgbClr val="0000FF"/>
+                  </a:solidFill>
+                  <a:latin typeface="Consolas" panose="020B0609020204030204" pitchFamily="49" charset="0"/>
+                </a:rPr>
+                <a:t>true</a:t>
+              </a:r>
+              <a:endParaRPr lang="nl-NL" sz="1800" dirty="0">
+                <a:solidFill>
+                  <a:srgbClr val="000000"/>
+                </a:solidFill>
+                <a:latin typeface="Consolas" panose="020B0609020204030204" pitchFamily="49" charset="0"/>
+              </a:endParaRPr>
+            </a:p>
+            <a:p>
+              <a:r>
+                <a:rPr lang="nl-NL" sz="1800" dirty="0">
+                  <a:solidFill>
+                    <a:srgbClr val="000000"/>
+                  </a:solidFill>
+                  <a:latin typeface="Consolas" panose="020B0609020204030204" pitchFamily="49" charset="0"/>
+                </a:rPr>
+                <a:t>                }</a:t>
+              </a:r>
+            </a:p>
+            <a:p>
+              <a:r>
+                <a:rPr lang="nl-NL" sz="1800" dirty="0">
+                  <a:solidFill>
+                    <a:srgbClr val="000000"/>
+                  </a:solidFill>
+                  <a:latin typeface="Consolas" panose="020B0609020204030204" pitchFamily="49" charset="0"/>
+                </a:rPr>
+                <a:t>            },</a:t>
+              </a:r>
+            </a:p>
+          </p:txBody>
+        </p:sp>
+        <p:sp>
+          <p:nvSpPr>
+            <p:cNvPr id="33" name="TextBox 32">
+              <a:extLst>
+                <a:ext uri="{FF2B5EF4-FFF2-40B4-BE49-F238E27FC236}">
+                  <a16:creationId xmlns:a16="http://schemas.microsoft.com/office/drawing/2014/main" id="{5B7EB7A1-8AD3-035D-ADD1-31D00F496A7F}"/>
+                </a:ext>
+              </a:extLst>
+            </p:cNvPr>
+            <p:cNvSpPr txBox="1"/>
+            <p:nvPr/>
+          </p:nvSpPr>
+          <p:spPr>
+            <a:xfrm>
+              <a:off x="-1357077" y="6743016"/>
+              <a:ext cx="3199910" cy="6463308"/>
+            </a:xfrm>
+            <a:prstGeom prst="rect">
+              <a:avLst/>
+            </a:prstGeom>
+            <a:noFill/>
+            <a:ln>
+              <a:noFill/>
+            </a:ln>
+          </p:spPr>
+          <p:txBody>
+            <a:bodyPr wrap="square">
+              <a:spAutoFit/>
+            </a:bodyPr>
+            <a:lstStyle/>
+            <a:p>
+              <a:r>
+                <a:rPr lang="nl-NL" sz="1800" dirty="0">
+                  <a:solidFill>
+                    <a:srgbClr val="000000"/>
+                  </a:solidFill>
+                  <a:latin typeface="Consolas" panose="020B0609020204030204" pitchFamily="49" charset="0"/>
+                </a:rPr>
+                <a:t>{</a:t>
+              </a:r>
+            </a:p>
+            <a:p>
+              <a:r>
+                <a:rPr lang="nl-NL" sz="1800" dirty="0">
+                  <a:solidFill>
+                    <a:srgbClr val="000000"/>
+                  </a:solidFill>
+                  <a:latin typeface="Consolas" panose="020B0609020204030204" pitchFamily="49" charset="0"/>
+                </a:rPr>
+                <a:t>    </a:t>
+              </a:r>
+              <a:r>
+                <a:rPr lang="nl-NL" sz="1800" dirty="0">
+                  <a:solidFill>
+                    <a:srgbClr val="2E75B6"/>
+                  </a:solidFill>
+                  <a:latin typeface="Consolas" panose="020B0609020204030204" pitchFamily="49" charset="0"/>
+                </a:rPr>
+                <a:t>"size"</a:t>
+              </a:r>
+              <a:r>
+                <a:rPr lang="nl-NL" sz="1800" dirty="0">
+                  <a:solidFill>
+                    <a:srgbClr val="000000"/>
+                  </a:solidFill>
+                  <a:latin typeface="Consolas" panose="020B0609020204030204" pitchFamily="49" charset="0"/>
+                </a:rPr>
+                <a:t>: {</a:t>
+              </a:r>
+            </a:p>
+            <a:p>
+              <a:r>
+                <a:rPr lang="nl-NL" sz="1800" dirty="0">
+                  <a:solidFill>
+                    <a:srgbClr val="000000"/>
+                  </a:solidFill>
+                  <a:latin typeface="Consolas" panose="020B0609020204030204" pitchFamily="49" charset="0"/>
+                </a:rPr>
+                <a:t>        </a:t>
+              </a:r>
+              <a:r>
+                <a:rPr lang="nl-NL" sz="1800" dirty="0">
+                  <a:solidFill>
+                    <a:srgbClr val="2E75B6"/>
+                  </a:solidFill>
+                  <a:latin typeface="Consolas" panose="020B0609020204030204" pitchFamily="49" charset="0"/>
+                </a:rPr>
+                <a:t>"columns"</a:t>
+              </a:r>
+              <a:r>
+                <a:rPr lang="nl-NL" sz="1800" dirty="0">
+                  <a:solidFill>
+                    <a:srgbClr val="000000"/>
+                  </a:solidFill>
+                  <a:latin typeface="Consolas" panose="020B0609020204030204" pitchFamily="49" charset="0"/>
+                </a:rPr>
+                <a:t>: 7,</a:t>
+              </a:r>
+            </a:p>
+            <a:p>
+              <a:r>
+                <a:rPr lang="nl-NL" sz="1800" dirty="0">
+                  <a:solidFill>
+                    <a:srgbClr val="000000"/>
+                  </a:solidFill>
+                  <a:latin typeface="Consolas" panose="020B0609020204030204" pitchFamily="49" charset="0"/>
+                </a:rPr>
+                <a:t>        </a:t>
+              </a:r>
+              <a:r>
+                <a:rPr lang="nl-NL" sz="1800" dirty="0">
+                  <a:solidFill>
+                    <a:srgbClr val="2E75B6"/>
+                  </a:solidFill>
+                  <a:latin typeface="Consolas" panose="020B0609020204030204" pitchFamily="49" charset="0"/>
+                </a:rPr>
+                <a:t>"rows"</a:t>
+              </a:r>
+              <a:r>
+                <a:rPr lang="nl-NL" sz="1800" dirty="0">
+                  <a:solidFill>
+                    <a:srgbClr val="000000"/>
+                  </a:solidFill>
+                  <a:latin typeface="Consolas" panose="020B0609020204030204" pitchFamily="49" charset="0"/>
+                </a:rPr>
+                <a:t>: 7</a:t>
+              </a:r>
+            </a:p>
+            <a:p>
+              <a:r>
+                <a:rPr lang="nl-NL" sz="1800" dirty="0">
+                  <a:solidFill>
+                    <a:srgbClr val="000000"/>
+                  </a:solidFill>
+                  <a:latin typeface="Consolas" panose="020B0609020204030204" pitchFamily="49" charset="0"/>
+                </a:rPr>
+                <a:t>    },</a:t>
+              </a:r>
+            </a:p>
+            <a:p>
+              <a:r>
+                <a:rPr lang="nl-NL" sz="1800" dirty="0">
+                  <a:solidFill>
+                    <a:srgbClr val="000000"/>
+                  </a:solidFill>
+                  <a:latin typeface="Consolas" panose="020B0609020204030204" pitchFamily="49" charset="0"/>
+                </a:rPr>
+                <a:t>    </a:t>
+              </a:r>
+              <a:r>
+                <a:rPr lang="nl-NL" sz="1800" dirty="0">
+                  <a:solidFill>
+                    <a:srgbClr val="2E75B6"/>
+                  </a:solidFill>
+                  <a:latin typeface="Consolas" panose="020B0609020204030204" pitchFamily="49" charset="0"/>
+                </a:rPr>
+                <a:t>"start"</a:t>
+              </a:r>
+              <a:r>
+                <a:rPr lang="nl-NL" sz="1800" dirty="0">
+                  <a:solidFill>
+                    <a:srgbClr val="000000"/>
+                  </a:solidFill>
+                  <a:latin typeface="Consolas" panose="020B0609020204030204" pitchFamily="49" charset="0"/>
+                </a:rPr>
+                <a:t>: [</a:t>
+              </a:r>
+            </a:p>
+            <a:p>
+              <a:r>
+                <a:rPr lang="nl-NL" sz="1800" dirty="0">
+                  <a:solidFill>
+                    <a:srgbClr val="000000"/>
+                  </a:solidFill>
+                  <a:latin typeface="Consolas" panose="020B0609020204030204" pitchFamily="49" charset="0"/>
+                </a:rPr>
+                <a:t>        1,</a:t>
+              </a:r>
+            </a:p>
+            <a:p>
+              <a:r>
+                <a:rPr lang="nl-NL" sz="1800" dirty="0">
+                  <a:solidFill>
+                    <a:srgbClr val="000000"/>
+                  </a:solidFill>
+                  <a:latin typeface="Consolas" panose="020B0609020204030204" pitchFamily="49" charset="0"/>
+                </a:rPr>
+                <a:t>        1</a:t>
+              </a:r>
+            </a:p>
+            <a:p>
+              <a:r>
+                <a:rPr lang="nl-NL" sz="1800" dirty="0">
+                  <a:solidFill>
+                    <a:srgbClr val="000000"/>
+                  </a:solidFill>
+                  <a:latin typeface="Consolas" panose="020B0609020204030204" pitchFamily="49" charset="0"/>
+                </a:rPr>
+                <a:t>    ],</a:t>
+              </a:r>
+            </a:p>
+            <a:p>
+              <a:r>
+                <a:rPr lang="nl-NL" sz="1800" dirty="0">
+                  <a:solidFill>
+                    <a:srgbClr val="000000"/>
+                  </a:solidFill>
+                  <a:latin typeface="Consolas" panose="020B0609020204030204" pitchFamily="49" charset="0"/>
+                </a:rPr>
+                <a:t>    </a:t>
+              </a:r>
+              <a:r>
+                <a:rPr lang="nl-NL" sz="1800" dirty="0">
+                  <a:solidFill>
+                    <a:srgbClr val="2E75B6"/>
+                  </a:solidFill>
+                  <a:latin typeface="Consolas" panose="020B0609020204030204" pitchFamily="49" charset="0"/>
+                </a:rPr>
+                <a:t>"end"</a:t>
+              </a:r>
+              <a:r>
+                <a:rPr lang="nl-NL" sz="1800" dirty="0">
+                  <a:solidFill>
+                    <a:srgbClr val="000000"/>
+                  </a:solidFill>
+                  <a:latin typeface="Consolas" panose="020B0609020204030204" pitchFamily="49" charset="0"/>
+                </a:rPr>
+                <a:t>: [</a:t>
+              </a:r>
+            </a:p>
+            <a:p>
+              <a:r>
+                <a:rPr lang="nl-NL" sz="1800" dirty="0">
+                  <a:solidFill>
+                    <a:srgbClr val="000000"/>
+                  </a:solidFill>
+                  <a:latin typeface="Consolas" panose="020B0609020204030204" pitchFamily="49" charset="0"/>
+                </a:rPr>
+                <a:t>        5,</a:t>
+              </a:r>
+            </a:p>
+            <a:p>
+              <a:r>
+                <a:rPr lang="nl-NL" sz="1800" dirty="0">
+                  <a:solidFill>
+                    <a:srgbClr val="000000"/>
+                  </a:solidFill>
+                  <a:latin typeface="Consolas" panose="020B0609020204030204" pitchFamily="49" charset="0"/>
+                </a:rPr>
+                <a:t>        5</a:t>
+              </a:r>
+            </a:p>
+            <a:p>
+              <a:r>
+                <a:rPr lang="nl-NL" sz="1800" dirty="0">
+                  <a:solidFill>
+                    <a:srgbClr val="000000"/>
+                  </a:solidFill>
+                  <a:latin typeface="Consolas" panose="020B0609020204030204" pitchFamily="49" charset="0"/>
+                </a:rPr>
+                <a:t>    ],</a:t>
+              </a:r>
+            </a:p>
+            <a:p>
+              <a:r>
+                <a:rPr lang="nl-NL" sz="1800" dirty="0">
+                  <a:solidFill>
+                    <a:srgbClr val="000000"/>
+                  </a:solidFill>
+                  <a:latin typeface="Consolas" panose="020B0609020204030204" pitchFamily="49" charset="0"/>
+                </a:rPr>
+                <a:t>    </a:t>
+              </a:r>
+              <a:r>
+                <a:rPr lang="nl-NL" sz="1800" dirty="0">
+                  <a:solidFill>
+                    <a:srgbClr val="2E75B6"/>
+                  </a:solidFill>
+                  <a:latin typeface="Consolas" panose="020B0609020204030204" pitchFamily="49" charset="0"/>
+                </a:rPr>
+                <a:t>"grid"</a:t>
+              </a:r>
+              <a:r>
+                <a:rPr lang="nl-NL" sz="1800" dirty="0">
+                  <a:solidFill>
+                    <a:srgbClr val="000000"/>
+                  </a:solidFill>
+                  <a:latin typeface="Consolas" panose="020B0609020204030204" pitchFamily="49" charset="0"/>
+                </a:rPr>
+                <a:t>: [</a:t>
+              </a:r>
+            </a:p>
+            <a:p>
+              <a:r>
+                <a:rPr lang="nl-NL" sz="1800" dirty="0">
+                  <a:solidFill>
+                    <a:srgbClr val="000000"/>
+                  </a:solidFill>
+                  <a:latin typeface="Consolas" panose="020B0609020204030204" pitchFamily="49" charset="0"/>
+                </a:rPr>
+                <a:t>        [</a:t>
+              </a:r>
+            </a:p>
+            <a:p>
+              <a:r>
+                <a:rPr lang="nl-NL" sz="1800" dirty="0">
+                  <a:solidFill>
+                    <a:srgbClr val="000000"/>
+                  </a:solidFill>
+                  <a:latin typeface="Consolas" panose="020B0609020204030204" pitchFamily="49" charset="0"/>
+                </a:rPr>
+                <a:t>            1,</a:t>
+              </a:r>
+            </a:p>
+            <a:p>
+              <a:r>
+                <a:rPr lang="nl-NL" sz="1800" dirty="0">
+                  <a:solidFill>
+                    <a:srgbClr val="000000"/>
+                  </a:solidFill>
+                  <a:latin typeface="Consolas" panose="020B0609020204030204" pitchFamily="49" charset="0"/>
+                </a:rPr>
+                <a:t>            1,</a:t>
+              </a:r>
+            </a:p>
+            <a:p>
+              <a:r>
+                <a:rPr lang="nl-NL" sz="1800" dirty="0">
+                  <a:solidFill>
+                    <a:srgbClr val="000000"/>
+                  </a:solidFill>
+                  <a:latin typeface="Consolas" panose="020B0609020204030204" pitchFamily="49" charset="0"/>
+                </a:rPr>
+                <a:t>            1,</a:t>
+              </a:r>
+            </a:p>
+            <a:p>
+              <a:r>
+                <a:rPr lang="nl-NL" sz="1800" dirty="0">
+                  <a:solidFill>
+                    <a:srgbClr val="000000"/>
+                  </a:solidFill>
+                  <a:latin typeface="Consolas" panose="020B0609020204030204" pitchFamily="49" charset="0"/>
+                </a:rPr>
+                <a:t>            1,</a:t>
+              </a:r>
+            </a:p>
+            <a:p>
+              <a:r>
+                <a:rPr lang="nl-NL" sz="1800" dirty="0">
+                  <a:solidFill>
+                    <a:srgbClr val="000000"/>
+                  </a:solidFill>
+                  <a:latin typeface="Consolas" panose="020B0609020204030204" pitchFamily="49" charset="0"/>
+                </a:rPr>
+                <a:t>            1,</a:t>
+              </a:r>
+            </a:p>
+            <a:p>
+              <a:r>
+                <a:rPr lang="nl-NL" sz="1800" dirty="0">
+                  <a:solidFill>
+                    <a:srgbClr val="000000"/>
+                  </a:solidFill>
+                  <a:latin typeface="Consolas" panose="020B0609020204030204" pitchFamily="49" charset="0"/>
+                </a:rPr>
+                <a:t>            1,</a:t>
+              </a:r>
+            </a:p>
+            <a:p>
+              <a:r>
+                <a:rPr lang="nl-NL" sz="1800" dirty="0">
+                  <a:solidFill>
+                    <a:srgbClr val="000000"/>
+                  </a:solidFill>
+                  <a:latin typeface="Consolas" panose="020B0609020204030204" pitchFamily="49" charset="0"/>
+                </a:rPr>
+                <a:t>            1</a:t>
+              </a:r>
+            </a:p>
+            <a:p>
+              <a:r>
+                <a:rPr lang="nl-NL" sz="1800" dirty="0">
+                  <a:solidFill>
+                    <a:srgbClr val="000000"/>
+                  </a:solidFill>
+                  <a:latin typeface="Consolas" panose="020B0609020204030204" pitchFamily="49" charset="0"/>
+                </a:rPr>
+                <a:t>        ],</a:t>
+              </a:r>
+            </a:p>
+          </p:txBody>
+        </p:sp>
+        <p:sp>
+          <p:nvSpPr>
+            <p:cNvPr id="48" name="TextBox 47">
+              <a:extLst>
+                <a:ext uri="{FF2B5EF4-FFF2-40B4-BE49-F238E27FC236}">
+                  <a16:creationId xmlns:a16="http://schemas.microsoft.com/office/drawing/2014/main" id="{1DB475F0-21D2-CF7F-04E7-AF2793E25D3E}"/>
+                </a:ext>
+              </a:extLst>
+            </p:cNvPr>
+            <p:cNvSpPr txBox="1"/>
+            <p:nvPr/>
+          </p:nvSpPr>
+          <p:spPr>
+            <a:xfrm>
+              <a:off x="2672738" y="-591813"/>
+              <a:ext cx="3524250" cy="7294305"/>
+            </a:xfrm>
+            <a:prstGeom prst="rect">
+              <a:avLst/>
+            </a:prstGeom>
+            <a:solidFill>
+              <a:schemeClr val="bg1"/>
+            </a:solidFill>
+            <a:ln>
+              <a:noFill/>
+            </a:ln>
+          </p:spPr>
+          <p:txBody>
+            <a:bodyPr wrap="square">
+              <a:spAutoFit/>
+            </a:bodyPr>
+            <a:lstStyle/>
+            <a:p>
+              <a:r>
+                <a:rPr lang="nl-NL" sz="1800" dirty="0">
+                  <a:solidFill>
+                    <a:srgbClr val="000000"/>
+                  </a:solidFill>
+                  <a:latin typeface="Consolas" panose="020B0609020204030204" pitchFamily="49" charset="0"/>
+                </a:rPr>
+                <a:t>{</a:t>
+              </a:r>
+            </a:p>
+            <a:p>
+              <a:r>
+                <a:rPr lang="nl-NL" sz="1800" dirty="0">
+                  <a:solidFill>
+                    <a:srgbClr val="000000"/>
+                  </a:solidFill>
+                  <a:latin typeface="Consolas" panose="020B0609020204030204" pitchFamily="49" charset="0"/>
+                </a:rPr>
+                <a:t>    </a:t>
+              </a:r>
+              <a:r>
+                <a:rPr lang="nl-NL" sz="1800" dirty="0">
+                  <a:solidFill>
+                    <a:srgbClr val="2E75B6"/>
+                  </a:solidFill>
+                  <a:latin typeface="Consolas" panose="020B0609020204030204" pitchFamily="49" charset="0"/>
+                </a:rPr>
+                <a:t>"size"</a:t>
+              </a:r>
+              <a:r>
+                <a:rPr lang="nl-NL" sz="1800" dirty="0">
+                  <a:solidFill>
+                    <a:srgbClr val="000000"/>
+                  </a:solidFill>
+                  <a:latin typeface="Consolas" panose="020B0609020204030204" pitchFamily="49" charset="0"/>
+                </a:rPr>
+                <a:t>: {</a:t>
+              </a:r>
+            </a:p>
+            <a:p>
+              <a:r>
+                <a:rPr lang="nl-NL" sz="1800" dirty="0">
+                  <a:solidFill>
+                    <a:srgbClr val="000000"/>
+                  </a:solidFill>
+                  <a:latin typeface="Consolas" panose="020B0609020204030204" pitchFamily="49" charset="0"/>
+                </a:rPr>
+                <a:t>        </a:t>
+              </a:r>
+              <a:r>
+                <a:rPr lang="nl-NL" sz="1800" dirty="0">
+                  <a:solidFill>
+                    <a:srgbClr val="2E75B6"/>
+                  </a:solidFill>
+                  <a:latin typeface="Consolas" panose="020B0609020204030204" pitchFamily="49" charset="0"/>
+                </a:rPr>
+                <a:t>"columns"</a:t>
+              </a:r>
+              <a:r>
+                <a:rPr lang="nl-NL" sz="1800" dirty="0">
+                  <a:solidFill>
+                    <a:srgbClr val="000000"/>
+                  </a:solidFill>
+                  <a:latin typeface="Consolas" panose="020B0609020204030204" pitchFamily="49" charset="0"/>
+                </a:rPr>
+                <a:t>: 3,</a:t>
+              </a:r>
+            </a:p>
+            <a:p>
+              <a:r>
+                <a:rPr lang="nl-NL" sz="1800" dirty="0">
+                  <a:solidFill>
+                    <a:srgbClr val="000000"/>
+                  </a:solidFill>
+                  <a:latin typeface="Consolas" panose="020B0609020204030204" pitchFamily="49" charset="0"/>
+                </a:rPr>
+                <a:t>        </a:t>
+              </a:r>
+              <a:r>
+                <a:rPr lang="nl-NL" sz="1800" dirty="0">
+                  <a:solidFill>
+                    <a:srgbClr val="2E75B6"/>
+                  </a:solidFill>
+                  <a:latin typeface="Consolas" panose="020B0609020204030204" pitchFamily="49" charset="0"/>
+                </a:rPr>
+                <a:t>"rows"</a:t>
+              </a:r>
+              <a:r>
+                <a:rPr lang="nl-NL" sz="1800" dirty="0">
+                  <a:solidFill>
+                    <a:srgbClr val="000000"/>
+                  </a:solidFill>
+                  <a:latin typeface="Consolas" panose="020B0609020204030204" pitchFamily="49" charset="0"/>
+                </a:rPr>
+                <a:t>: 3</a:t>
+              </a:r>
+            </a:p>
+            <a:p>
+              <a:r>
+                <a:rPr lang="nl-NL" sz="1800" dirty="0">
+                  <a:solidFill>
+                    <a:srgbClr val="000000"/>
+                  </a:solidFill>
+                  <a:latin typeface="Consolas" panose="020B0609020204030204" pitchFamily="49" charset="0"/>
+                </a:rPr>
+                <a:t>    },</a:t>
+              </a:r>
+            </a:p>
+            <a:p>
+              <a:r>
+                <a:rPr lang="nl-NL" sz="1800" dirty="0">
+                  <a:solidFill>
+                    <a:srgbClr val="000000"/>
+                  </a:solidFill>
+                  <a:latin typeface="Consolas" panose="020B0609020204030204" pitchFamily="49" charset="0"/>
+                </a:rPr>
+                <a:t>    </a:t>
+              </a:r>
+              <a:r>
+                <a:rPr lang="nl-NL" sz="1800" dirty="0">
+                  <a:solidFill>
+                    <a:srgbClr val="2E75B6"/>
+                  </a:solidFill>
+                  <a:latin typeface="Consolas" panose="020B0609020204030204" pitchFamily="49" charset="0"/>
+                </a:rPr>
+                <a:t>"start"</a:t>
+              </a:r>
+              <a:r>
+                <a:rPr lang="nl-NL" sz="1800" dirty="0">
+                  <a:solidFill>
+                    <a:srgbClr val="000000"/>
+                  </a:solidFill>
+                  <a:latin typeface="Consolas" panose="020B0609020204030204" pitchFamily="49" charset="0"/>
+                </a:rPr>
+                <a:t>: [</a:t>
+              </a:r>
+            </a:p>
+            <a:p>
+              <a:r>
+                <a:rPr lang="nl-NL" sz="1800" dirty="0">
+                  <a:solidFill>
+                    <a:srgbClr val="000000"/>
+                  </a:solidFill>
+                  <a:latin typeface="Consolas" panose="020B0609020204030204" pitchFamily="49" charset="0"/>
+                </a:rPr>
+                <a:t>        0,</a:t>
+              </a:r>
+            </a:p>
+            <a:p>
+              <a:r>
+                <a:rPr lang="nl-NL" sz="1800" dirty="0">
+                  <a:solidFill>
+                    <a:srgbClr val="000000"/>
+                  </a:solidFill>
+                  <a:latin typeface="Consolas" panose="020B0609020204030204" pitchFamily="49" charset="0"/>
+                </a:rPr>
+                <a:t>        0</a:t>
+              </a:r>
+            </a:p>
+            <a:p>
+              <a:r>
+                <a:rPr lang="nl-NL" sz="1800" dirty="0">
+                  <a:solidFill>
+                    <a:srgbClr val="000000"/>
+                  </a:solidFill>
+                  <a:latin typeface="Consolas" panose="020B0609020204030204" pitchFamily="49" charset="0"/>
+                </a:rPr>
+                <a:t>    ],</a:t>
+              </a:r>
+            </a:p>
+            <a:p>
+              <a:r>
+                <a:rPr lang="nl-NL" sz="1800" dirty="0">
+                  <a:solidFill>
+                    <a:srgbClr val="000000"/>
+                  </a:solidFill>
+                  <a:latin typeface="Consolas" panose="020B0609020204030204" pitchFamily="49" charset="0"/>
+                </a:rPr>
+                <a:t>    </a:t>
+              </a:r>
+              <a:r>
+                <a:rPr lang="nl-NL" sz="1800" dirty="0">
+                  <a:solidFill>
+                    <a:srgbClr val="2E75B6"/>
+                  </a:solidFill>
+                  <a:latin typeface="Consolas" panose="020B0609020204030204" pitchFamily="49" charset="0"/>
+                </a:rPr>
+                <a:t>"end"</a:t>
+              </a:r>
+              <a:r>
+                <a:rPr lang="nl-NL" sz="1800" dirty="0">
+                  <a:solidFill>
+                    <a:srgbClr val="000000"/>
+                  </a:solidFill>
+                  <a:latin typeface="Consolas" panose="020B0609020204030204" pitchFamily="49" charset="0"/>
+                </a:rPr>
+                <a:t>: [</a:t>
+              </a:r>
+            </a:p>
+            <a:p>
+              <a:r>
+                <a:rPr lang="nl-NL" sz="1800" dirty="0">
+                  <a:solidFill>
+                    <a:srgbClr val="000000"/>
+                  </a:solidFill>
+                  <a:latin typeface="Consolas" panose="020B0609020204030204" pitchFamily="49" charset="0"/>
+                </a:rPr>
+                <a:t>        2,</a:t>
+              </a:r>
+            </a:p>
+            <a:p>
+              <a:r>
+                <a:rPr lang="nl-NL" sz="1800" dirty="0">
+                  <a:solidFill>
+                    <a:srgbClr val="000000"/>
+                  </a:solidFill>
+                  <a:latin typeface="Consolas" panose="020B0609020204030204" pitchFamily="49" charset="0"/>
+                </a:rPr>
+                <a:t>        2</a:t>
+              </a:r>
+            </a:p>
+            <a:p>
+              <a:r>
+                <a:rPr lang="nl-NL" sz="1800" dirty="0">
+                  <a:solidFill>
+                    <a:srgbClr val="000000"/>
+                  </a:solidFill>
+                  <a:latin typeface="Consolas" panose="020B0609020204030204" pitchFamily="49" charset="0"/>
+                </a:rPr>
+                <a:t>    ],</a:t>
+              </a:r>
+            </a:p>
+            <a:p>
+              <a:r>
+                <a:rPr lang="nl-NL" sz="1800" dirty="0">
+                  <a:solidFill>
+                    <a:srgbClr val="000000"/>
+                  </a:solidFill>
+                  <a:latin typeface="Consolas" panose="020B0609020204030204" pitchFamily="49" charset="0"/>
+                </a:rPr>
+                <a:t>    </a:t>
+              </a:r>
+              <a:r>
+                <a:rPr lang="nl-NL" sz="1800" dirty="0">
+                  <a:solidFill>
+                    <a:srgbClr val="2E75B6"/>
+                  </a:solidFill>
+                  <a:latin typeface="Consolas" panose="020B0609020204030204" pitchFamily="49" charset="0"/>
+                </a:rPr>
+                <a:t>"grid"</a:t>
+              </a:r>
+              <a:r>
+                <a:rPr lang="nl-NL" sz="1800" dirty="0">
+                  <a:solidFill>
+                    <a:srgbClr val="000000"/>
+                  </a:solidFill>
+                  <a:latin typeface="Consolas" panose="020B0609020204030204" pitchFamily="49" charset="0"/>
+                </a:rPr>
+                <a:t>: [</a:t>
+              </a:r>
+            </a:p>
+            <a:p>
+              <a:r>
+                <a:rPr lang="nl-NL" sz="1800" dirty="0">
+                  <a:solidFill>
+                    <a:srgbClr val="000000"/>
+                  </a:solidFill>
+                  <a:latin typeface="Consolas" panose="020B0609020204030204" pitchFamily="49" charset="0"/>
+                </a:rPr>
+                <a:t>        {</a:t>
+              </a:r>
+            </a:p>
+            <a:p>
+              <a:r>
+                <a:rPr lang="nl-NL" sz="1800" dirty="0">
+                  <a:solidFill>
+                    <a:srgbClr val="000000"/>
+                  </a:solidFill>
+                  <a:latin typeface="Consolas" panose="020B0609020204030204" pitchFamily="49" charset="0"/>
+                </a:rPr>
+                <a:t>            </a:t>
+              </a:r>
+              <a:r>
+                <a:rPr lang="nl-NL" sz="1800" dirty="0">
+                  <a:solidFill>
+                    <a:srgbClr val="2E75B6"/>
+                  </a:solidFill>
+                  <a:latin typeface="Consolas" panose="020B0609020204030204" pitchFamily="49" charset="0"/>
+                </a:rPr>
+                <a:t>"node"</a:t>
+              </a:r>
+              <a:r>
+                <a:rPr lang="nl-NL" sz="1800" dirty="0">
+                  <a:solidFill>
+                    <a:srgbClr val="000000"/>
+                  </a:solidFill>
+                  <a:latin typeface="Consolas" panose="020B0609020204030204" pitchFamily="49" charset="0"/>
+                </a:rPr>
+                <a:t>: [</a:t>
+              </a:r>
+            </a:p>
+            <a:p>
+              <a:r>
+                <a:rPr lang="nl-NL" sz="1800" dirty="0">
+                  <a:solidFill>
+                    <a:srgbClr val="000000"/>
+                  </a:solidFill>
+                  <a:latin typeface="Consolas" panose="020B0609020204030204" pitchFamily="49" charset="0"/>
+                </a:rPr>
+                <a:t>                0,</a:t>
+              </a:r>
+            </a:p>
+            <a:p>
+              <a:r>
+                <a:rPr lang="nl-NL" sz="1800" dirty="0">
+                  <a:solidFill>
+                    <a:srgbClr val="000000"/>
+                  </a:solidFill>
+                  <a:latin typeface="Consolas" panose="020B0609020204030204" pitchFamily="49" charset="0"/>
+                </a:rPr>
+                <a:t>                0</a:t>
+              </a:r>
+            </a:p>
+            <a:p>
+              <a:r>
+                <a:rPr lang="nl-NL" sz="1800" dirty="0">
+                  <a:solidFill>
+                    <a:srgbClr val="000000"/>
+                  </a:solidFill>
+                  <a:latin typeface="Consolas" panose="020B0609020204030204" pitchFamily="49" charset="0"/>
+                </a:rPr>
+                <a:t>            ],</a:t>
+              </a:r>
+            </a:p>
+            <a:p>
+              <a:r>
+                <a:rPr lang="nl-NL" sz="1800" dirty="0">
+                  <a:solidFill>
+                    <a:srgbClr val="000000"/>
+                  </a:solidFill>
+                  <a:latin typeface="Consolas" panose="020B0609020204030204" pitchFamily="49" charset="0"/>
+                </a:rPr>
+                <a:t>            </a:t>
+              </a:r>
+              <a:r>
+                <a:rPr lang="nl-NL" sz="1800" dirty="0">
+                  <a:solidFill>
+                    <a:srgbClr val="2E75B6"/>
+                  </a:solidFill>
+                  <a:latin typeface="Consolas" panose="020B0609020204030204" pitchFamily="49" charset="0"/>
+                </a:rPr>
+                <a:t>"neighbors"</a:t>
+              </a:r>
+              <a:r>
+                <a:rPr lang="nl-NL" sz="1800" dirty="0">
+                  <a:solidFill>
+                    <a:srgbClr val="000000"/>
+                  </a:solidFill>
+                  <a:latin typeface="Consolas" panose="020B0609020204030204" pitchFamily="49" charset="0"/>
+                </a:rPr>
+                <a:t>: [</a:t>
+              </a:r>
+            </a:p>
+            <a:p>
+              <a:r>
+                <a:rPr lang="nl-NL" sz="1800" dirty="0">
+                  <a:solidFill>
+                    <a:srgbClr val="000000"/>
+                  </a:solidFill>
+                  <a:latin typeface="Consolas" panose="020B0609020204030204" pitchFamily="49" charset="0"/>
+                </a:rPr>
+                <a:t>                [</a:t>
+              </a:r>
+            </a:p>
+            <a:p>
+              <a:r>
+                <a:rPr lang="nl-NL" sz="1800" dirty="0">
+                  <a:solidFill>
+                    <a:srgbClr val="000000"/>
+                  </a:solidFill>
+                  <a:latin typeface="Consolas" panose="020B0609020204030204" pitchFamily="49" charset="0"/>
+                </a:rPr>
+                <a:t>                    1,</a:t>
+              </a:r>
+            </a:p>
+            <a:p>
+              <a:r>
+                <a:rPr lang="nl-NL" sz="1800" dirty="0">
+                  <a:solidFill>
+                    <a:srgbClr val="000000"/>
+                  </a:solidFill>
+                  <a:latin typeface="Consolas" panose="020B0609020204030204" pitchFamily="49" charset="0"/>
+                </a:rPr>
+                <a:t>                    0</a:t>
+              </a:r>
+            </a:p>
+            <a:p>
+              <a:r>
+                <a:rPr lang="nl-NL" sz="1800" dirty="0">
+                  <a:solidFill>
+                    <a:srgbClr val="000000"/>
+                  </a:solidFill>
+                  <a:latin typeface="Consolas" panose="020B0609020204030204" pitchFamily="49" charset="0"/>
+                </a:rPr>
+                <a:t>                ]</a:t>
+              </a:r>
+            </a:p>
+            <a:p>
+              <a:r>
+                <a:rPr lang="nl-NL" sz="1800" dirty="0">
+                  <a:solidFill>
+                    <a:srgbClr val="000000"/>
+                  </a:solidFill>
+                  <a:latin typeface="Consolas" panose="020B0609020204030204" pitchFamily="49" charset="0"/>
+                </a:rPr>
+                <a:t>            ]</a:t>
+              </a:r>
+            </a:p>
+            <a:p>
+              <a:r>
+                <a:rPr lang="nl-NL" sz="1800" dirty="0">
+                  <a:solidFill>
+                    <a:srgbClr val="000000"/>
+                  </a:solidFill>
+                  <a:latin typeface="Consolas" panose="020B0609020204030204" pitchFamily="49" charset="0"/>
+                </a:rPr>
+                <a:t>        },</a:t>
+              </a:r>
+              <a:endParaRPr lang="nl-NL" dirty="0"/>
+            </a:p>
+          </p:txBody>
+        </p:sp>
+        <p:sp>
+          <p:nvSpPr>
+            <p:cNvPr id="50" name="TextBox 49">
+              <a:extLst>
+                <a:ext uri="{FF2B5EF4-FFF2-40B4-BE49-F238E27FC236}">
+                  <a16:creationId xmlns:a16="http://schemas.microsoft.com/office/drawing/2014/main" id="{1CC9AC4B-5E26-AAFB-F5A3-FD191A71CE50}"/>
+                </a:ext>
+              </a:extLst>
+            </p:cNvPr>
+            <p:cNvSpPr txBox="1"/>
+            <p:nvPr/>
+          </p:nvSpPr>
+          <p:spPr>
+            <a:xfrm>
+              <a:off x="2672738" y="6745226"/>
+              <a:ext cx="3524250" cy="7294305"/>
+            </a:xfrm>
+            <a:prstGeom prst="rect">
+              <a:avLst/>
+            </a:prstGeom>
+            <a:solidFill>
+              <a:schemeClr val="bg1"/>
+            </a:solidFill>
+            <a:ln>
+              <a:noFill/>
+            </a:ln>
+          </p:spPr>
+          <p:txBody>
+            <a:bodyPr wrap="square">
+              <a:spAutoFit/>
+            </a:bodyPr>
+            <a:lstStyle/>
+            <a:p>
+              <a:r>
+                <a:rPr lang="nl-NL" sz="1800" dirty="0">
+                  <a:solidFill>
+                    <a:srgbClr val="000000"/>
+                  </a:solidFill>
+                  <a:latin typeface="Consolas" panose="020B0609020204030204" pitchFamily="49" charset="0"/>
+                </a:rPr>
+                <a:t>{</a:t>
+              </a:r>
+            </a:p>
+            <a:p>
+              <a:r>
+                <a:rPr lang="nl-NL" sz="1800" dirty="0">
+                  <a:solidFill>
+                    <a:srgbClr val="000000"/>
+                  </a:solidFill>
+                  <a:latin typeface="Consolas" panose="020B0609020204030204" pitchFamily="49" charset="0"/>
+                </a:rPr>
+                <a:t>    </a:t>
+              </a:r>
+              <a:r>
+                <a:rPr lang="nl-NL" sz="1800" dirty="0">
+                  <a:solidFill>
+                    <a:srgbClr val="2E75B6"/>
+                  </a:solidFill>
+                  <a:latin typeface="Consolas" panose="020B0609020204030204" pitchFamily="49" charset="0"/>
+                </a:rPr>
+                <a:t>"size"</a:t>
+              </a:r>
+              <a:r>
+                <a:rPr lang="nl-NL" sz="1800" dirty="0">
+                  <a:solidFill>
+                    <a:srgbClr val="000000"/>
+                  </a:solidFill>
+                  <a:latin typeface="Consolas" panose="020B0609020204030204" pitchFamily="49" charset="0"/>
+                </a:rPr>
+                <a:t>: {</a:t>
+              </a:r>
+            </a:p>
+            <a:p>
+              <a:r>
+                <a:rPr lang="nl-NL" sz="1800" dirty="0">
+                  <a:solidFill>
+                    <a:srgbClr val="000000"/>
+                  </a:solidFill>
+                  <a:latin typeface="Consolas" panose="020B0609020204030204" pitchFamily="49" charset="0"/>
+                </a:rPr>
+                <a:t>        </a:t>
+              </a:r>
+              <a:r>
+                <a:rPr lang="nl-NL" sz="1800" dirty="0">
+                  <a:solidFill>
+                    <a:srgbClr val="2E75B6"/>
+                  </a:solidFill>
+                  <a:latin typeface="Consolas" panose="020B0609020204030204" pitchFamily="49" charset="0"/>
+                </a:rPr>
+                <a:t>"columns"</a:t>
+              </a:r>
+              <a:r>
+                <a:rPr lang="nl-NL" sz="1800" dirty="0">
+                  <a:solidFill>
+                    <a:srgbClr val="000000"/>
+                  </a:solidFill>
+                  <a:latin typeface="Consolas" panose="020B0609020204030204" pitchFamily="49" charset="0"/>
+                </a:rPr>
+                <a:t>: 3,</a:t>
+              </a:r>
+            </a:p>
+            <a:p>
+              <a:r>
+                <a:rPr lang="nl-NL" sz="1800" dirty="0">
+                  <a:solidFill>
+                    <a:srgbClr val="000000"/>
+                  </a:solidFill>
+                  <a:latin typeface="Consolas" panose="020B0609020204030204" pitchFamily="49" charset="0"/>
+                </a:rPr>
+                <a:t>        </a:t>
+              </a:r>
+              <a:r>
+                <a:rPr lang="nl-NL" sz="1800" dirty="0">
+                  <a:solidFill>
+                    <a:srgbClr val="2E75B6"/>
+                  </a:solidFill>
+                  <a:latin typeface="Consolas" panose="020B0609020204030204" pitchFamily="49" charset="0"/>
+                </a:rPr>
+                <a:t>"rows"</a:t>
+              </a:r>
+              <a:r>
+                <a:rPr lang="nl-NL" sz="1800" dirty="0">
+                  <a:solidFill>
+                    <a:srgbClr val="000000"/>
+                  </a:solidFill>
+                  <a:latin typeface="Consolas" panose="020B0609020204030204" pitchFamily="49" charset="0"/>
+                </a:rPr>
+                <a:t>: 3</a:t>
+              </a:r>
+            </a:p>
+            <a:p>
+              <a:r>
+                <a:rPr lang="nl-NL" sz="1800" dirty="0">
+                  <a:solidFill>
+                    <a:srgbClr val="000000"/>
+                  </a:solidFill>
+                  <a:latin typeface="Consolas" panose="020B0609020204030204" pitchFamily="49" charset="0"/>
+                </a:rPr>
+                <a:t>    },</a:t>
+              </a:r>
+            </a:p>
+            <a:p>
+              <a:r>
+                <a:rPr lang="nl-NL" sz="1800" dirty="0">
+                  <a:solidFill>
+                    <a:srgbClr val="000000"/>
+                  </a:solidFill>
+                  <a:latin typeface="Consolas" panose="020B0609020204030204" pitchFamily="49" charset="0"/>
+                </a:rPr>
+                <a:t>    </a:t>
+              </a:r>
+              <a:r>
+                <a:rPr lang="nl-NL" sz="1800" dirty="0">
+                  <a:solidFill>
+                    <a:srgbClr val="2E75B6"/>
+                  </a:solidFill>
+                  <a:latin typeface="Consolas" panose="020B0609020204030204" pitchFamily="49" charset="0"/>
+                </a:rPr>
+                <a:t>"start"</a:t>
+              </a:r>
+              <a:r>
+                <a:rPr lang="nl-NL" sz="1800" dirty="0">
+                  <a:solidFill>
+                    <a:srgbClr val="000000"/>
+                  </a:solidFill>
+                  <a:latin typeface="Consolas" panose="020B0609020204030204" pitchFamily="49" charset="0"/>
+                </a:rPr>
+                <a:t>: [</a:t>
+              </a:r>
+            </a:p>
+            <a:p>
+              <a:r>
+                <a:rPr lang="nl-NL" sz="1800" dirty="0">
+                  <a:solidFill>
+                    <a:srgbClr val="000000"/>
+                  </a:solidFill>
+                  <a:latin typeface="Consolas" panose="020B0609020204030204" pitchFamily="49" charset="0"/>
+                </a:rPr>
+                <a:t>        0,</a:t>
+              </a:r>
+            </a:p>
+            <a:p>
+              <a:r>
+                <a:rPr lang="nl-NL" sz="1800" dirty="0">
+                  <a:solidFill>
+                    <a:srgbClr val="000000"/>
+                  </a:solidFill>
+                  <a:latin typeface="Consolas" panose="020B0609020204030204" pitchFamily="49" charset="0"/>
+                </a:rPr>
+                <a:t>        0</a:t>
+              </a:r>
+            </a:p>
+            <a:p>
+              <a:r>
+                <a:rPr lang="nl-NL" sz="1800" dirty="0">
+                  <a:solidFill>
+                    <a:srgbClr val="000000"/>
+                  </a:solidFill>
+                  <a:latin typeface="Consolas" panose="020B0609020204030204" pitchFamily="49" charset="0"/>
+                </a:rPr>
+                <a:t>    ],</a:t>
+              </a:r>
+            </a:p>
+            <a:p>
+              <a:r>
+                <a:rPr lang="nl-NL" sz="1800" dirty="0">
+                  <a:solidFill>
+                    <a:srgbClr val="000000"/>
+                  </a:solidFill>
+                  <a:latin typeface="Consolas" panose="020B0609020204030204" pitchFamily="49" charset="0"/>
+                </a:rPr>
+                <a:t>    </a:t>
+              </a:r>
+              <a:r>
+                <a:rPr lang="nl-NL" sz="1800" dirty="0">
+                  <a:solidFill>
+                    <a:srgbClr val="2E75B6"/>
+                  </a:solidFill>
+                  <a:latin typeface="Consolas" panose="020B0609020204030204" pitchFamily="49" charset="0"/>
+                </a:rPr>
+                <a:t>"end"</a:t>
+              </a:r>
+              <a:r>
+                <a:rPr lang="nl-NL" sz="1800" dirty="0">
+                  <a:solidFill>
+                    <a:srgbClr val="000000"/>
+                  </a:solidFill>
+                  <a:latin typeface="Consolas" panose="020B0609020204030204" pitchFamily="49" charset="0"/>
+                </a:rPr>
+                <a:t>: [</a:t>
+              </a:r>
+            </a:p>
+            <a:p>
+              <a:r>
+                <a:rPr lang="nl-NL" sz="1800" dirty="0">
+                  <a:solidFill>
+                    <a:srgbClr val="000000"/>
+                  </a:solidFill>
+                  <a:latin typeface="Consolas" panose="020B0609020204030204" pitchFamily="49" charset="0"/>
+                </a:rPr>
+                <a:t>        2,</a:t>
+              </a:r>
+            </a:p>
+            <a:p>
+              <a:r>
+                <a:rPr lang="nl-NL" sz="1800" dirty="0">
+                  <a:solidFill>
+                    <a:srgbClr val="000000"/>
+                  </a:solidFill>
+                  <a:latin typeface="Consolas" panose="020B0609020204030204" pitchFamily="49" charset="0"/>
+                </a:rPr>
+                <a:t>        2</a:t>
+              </a:r>
+            </a:p>
+            <a:p>
+              <a:r>
+                <a:rPr lang="nl-NL" sz="1800" dirty="0">
+                  <a:solidFill>
+                    <a:srgbClr val="000000"/>
+                  </a:solidFill>
+                  <a:latin typeface="Consolas" panose="020B0609020204030204" pitchFamily="49" charset="0"/>
+                </a:rPr>
+                <a:t>    ],</a:t>
+              </a:r>
+            </a:p>
+            <a:p>
+              <a:r>
+                <a:rPr lang="nl-NL" sz="1800" dirty="0">
+                  <a:solidFill>
+                    <a:srgbClr val="000000"/>
+                  </a:solidFill>
+                  <a:latin typeface="Consolas" panose="020B0609020204030204" pitchFamily="49" charset="0"/>
+                </a:rPr>
+                <a:t>    </a:t>
+              </a:r>
+              <a:r>
+                <a:rPr lang="nl-NL" sz="1800" dirty="0">
+                  <a:solidFill>
+                    <a:srgbClr val="2E75B6"/>
+                  </a:solidFill>
+                  <a:latin typeface="Consolas" panose="020B0609020204030204" pitchFamily="49" charset="0"/>
+                </a:rPr>
+                <a:t>"grid"</a:t>
+              </a:r>
+              <a:r>
+                <a:rPr lang="nl-NL" sz="1800" dirty="0">
+                  <a:solidFill>
+                    <a:srgbClr val="000000"/>
+                  </a:solidFill>
+                  <a:latin typeface="Consolas" panose="020B0609020204030204" pitchFamily="49" charset="0"/>
+                </a:rPr>
+                <a:t>: [</a:t>
+              </a:r>
+            </a:p>
+            <a:p>
+              <a:r>
+                <a:rPr lang="nl-NL" sz="1800" dirty="0">
+                  <a:solidFill>
+                    <a:srgbClr val="000000"/>
+                  </a:solidFill>
+                  <a:latin typeface="Consolas" panose="020B0609020204030204" pitchFamily="49" charset="0"/>
+                </a:rPr>
+                <a:t>        {</a:t>
+              </a:r>
+            </a:p>
+            <a:p>
+              <a:r>
+                <a:rPr lang="nl-NL" sz="1800" dirty="0">
+                  <a:solidFill>
+                    <a:srgbClr val="000000"/>
+                  </a:solidFill>
+                  <a:latin typeface="Consolas" panose="020B0609020204030204" pitchFamily="49" charset="0"/>
+                </a:rPr>
+                <a:t>            </a:t>
+              </a:r>
+              <a:r>
+                <a:rPr lang="nl-NL" sz="1800" dirty="0">
+                  <a:solidFill>
+                    <a:srgbClr val="2E75B6"/>
+                  </a:solidFill>
+                  <a:latin typeface="Consolas" panose="020B0609020204030204" pitchFamily="49" charset="0"/>
+                </a:rPr>
+                <a:t>"node"</a:t>
+              </a:r>
+              <a:r>
+                <a:rPr lang="nl-NL" sz="1800" dirty="0">
+                  <a:solidFill>
+                    <a:srgbClr val="000000"/>
+                  </a:solidFill>
+                  <a:latin typeface="Consolas" panose="020B0609020204030204" pitchFamily="49" charset="0"/>
+                </a:rPr>
+                <a:t>: [</a:t>
+              </a:r>
+            </a:p>
+            <a:p>
+              <a:r>
+                <a:rPr lang="nl-NL" sz="1800" dirty="0">
+                  <a:solidFill>
+                    <a:srgbClr val="000000"/>
+                  </a:solidFill>
+                  <a:latin typeface="Consolas" panose="020B0609020204030204" pitchFamily="49" charset="0"/>
+                </a:rPr>
+                <a:t>                0,</a:t>
+              </a:r>
+            </a:p>
+            <a:p>
+              <a:r>
+                <a:rPr lang="nl-NL" sz="1800" dirty="0">
+                  <a:solidFill>
+                    <a:srgbClr val="000000"/>
+                  </a:solidFill>
+                  <a:latin typeface="Consolas" panose="020B0609020204030204" pitchFamily="49" charset="0"/>
+                </a:rPr>
+                <a:t>                0</a:t>
+              </a:r>
+            </a:p>
+            <a:p>
+              <a:r>
+                <a:rPr lang="nl-NL" sz="1800" dirty="0">
+                  <a:solidFill>
+                    <a:srgbClr val="000000"/>
+                  </a:solidFill>
+                  <a:latin typeface="Consolas" panose="020B0609020204030204" pitchFamily="49" charset="0"/>
+                </a:rPr>
+                <a:t>            ],</a:t>
+              </a:r>
+            </a:p>
+            <a:p>
+              <a:r>
+                <a:rPr lang="nl-NL" sz="1800" dirty="0">
+                  <a:solidFill>
+                    <a:srgbClr val="000000"/>
+                  </a:solidFill>
+                  <a:latin typeface="Consolas" panose="020B0609020204030204" pitchFamily="49" charset="0"/>
+                </a:rPr>
+                <a:t>            </a:t>
+              </a:r>
+              <a:r>
+                <a:rPr lang="nl-NL" sz="1800" dirty="0">
+                  <a:solidFill>
+                    <a:srgbClr val="2E75B6"/>
+                  </a:solidFill>
+                  <a:latin typeface="Consolas" panose="020B0609020204030204" pitchFamily="49" charset="0"/>
+                </a:rPr>
+                <a:t>"neighbors"</a:t>
+              </a:r>
+              <a:r>
+                <a:rPr lang="nl-NL" sz="1800" dirty="0">
+                  <a:solidFill>
+                    <a:srgbClr val="000000"/>
+                  </a:solidFill>
+                  <a:latin typeface="Consolas" panose="020B0609020204030204" pitchFamily="49" charset="0"/>
+                </a:rPr>
+                <a:t>: [</a:t>
+              </a:r>
+            </a:p>
+            <a:p>
+              <a:r>
+                <a:rPr lang="nl-NL" sz="1800" dirty="0">
+                  <a:solidFill>
+                    <a:srgbClr val="000000"/>
+                  </a:solidFill>
+                  <a:latin typeface="Consolas" panose="020B0609020204030204" pitchFamily="49" charset="0"/>
+                </a:rPr>
+                <a:t>                [</a:t>
+              </a:r>
+            </a:p>
+            <a:p>
+              <a:r>
+                <a:rPr lang="nl-NL" sz="1800" dirty="0">
+                  <a:solidFill>
+                    <a:srgbClr val="000000"/>
+                  </a:solidFill>
+                  <a:latin typeface="Consolas" panose="020B0609020204030204" pitchFamily="49" charset="0"/>
+                </a:rPr>
+                <a:t>                    1,</a:t>
+              </a:r>
+            </a:p>
+            <a:p>
+              <a:r>
+                <a:rPr lang="nl-NL" sz="1800" dirty="0">
+                  <a:solidFill>
+                    <a:srgbClr val="000000"/>
+                  </a:solidFill>
+                  <a:latin typeface="Consolas" panose="020B0609020204030204" pitchFamily="49" charset="0"/>
+                </a:rPr>
+                <a:t>                    0</a:t>
+              </a:r>
+            </a:p>
+            <a:p>
+              <a:r>
+                <a:rPr lang="nl-NL" sz="1800" dirty="0">
+                  <a:solidFill>
+                    <a:srgbClr val="000000"/>
+                  </a:solidFill>
+                  <a:latin typeface="Consolas" panose="020B0609020204030204" pitchFamily="49" charset="0"/>
+                </a:rPr>
+                <a:t>                ]</a:t>
+              </a:r>
+            </a:p>
+            <a:p>
+              <a:r>
+                <a:rPr lang="nl-NL" sz="1800" dirty="0">
+                  <a:solidFill>
+                    <a:srgbClr val="000000"/>
+                  </a:solidFill>
+                  <a:latin typeface="Consolas" panose="020B0609020204030204" pitchFamily="49" charset="0"/>
+                </a:rPr>
+                <a:t>            ]</a:t>
+              </a:r>
+            </a:p>
+            <a:p>
+              <a:r>
+                <a:rPr lang="nl-NL" sz="1800" dirty="0">
+                  <a:solidFill>
+                    <a:srgbClr val="000000"/>
+                  </a:solidFill>
+                  <a:latin typeface="Consolas" panose="020B0609020204030204" pitchFamily="49" charset="0"/>
+                </a:rPr>
+                <a:t>        },</a:t>
+              </a:r>
+              <a:endParaRPr lang="nl-NL" dirty="0"/>
+            </a:p>
+          </p:txBody>
+        </p:sp>
+        <p:sp>
+          <p:nvSpPr>
+            <p:cNvPr id="56" name="TextBox 55">
+              <a:extLst>
+                <a:ext uri="{FF2B5EF4-FFF2-40B4-BE49-F238E27FC236}">
+                  <a16:creationId xmlns:a16="http://schemas.microsoft.com/office/drawing/2014/main" id="{DB90BCC3-4EBF-5B6A-8BB0-60922A6DE331}"/>
+                </a:ext>
+              </a:extLst>
+            </p:cNvPr>
+            <p:cNvSpPr txBox="1"/>
+            <p:nvPr/>
+          </p:nvSpPr>
+          <p:spPr>
+            <a:xfrm>
+              <a:off x="6288089" y="-489425"/>
+              <a:ext cx="5495081" cy="923330"/>
+            </a:xfrm>
+            <a:prstGeom prst="rect">
+              <a:avLst/>
+            </a:prstGeom>
+            <a:solidFill>
+              <a:schemeClr val="bg1"/>
+            </a:solidFill>
+            <a:ln>
+              <a:noFill/>
+            </a:ln>
+          </p:spPr>
+          <p:txBody>
+            <a:bodyPr wrap="square">
+              <a:spAutoFit/>
+            </a:bodyPr>
+            <a:lstStyle/>
+            <a:p>
+              <a:r>
+                <a:rPr lang="nl-NL" dirty="0"/>
+                <a:t>&lt;ADJLIST_START&gt; (1,1) &lt;–&gt; (2,1) ; … (5,4) &lt;–&gt; (5,5) &lt;ADJLIST_END&gt; &lt;ORIGIN_START&gt;(1,1)&lt;ORIGIN_END&gt; &lt;TARGET_START&gt;(5,5)&lt;TARGET_END&gt; </a:t>
+              </a:r>
+            </a:p>
+          </p:txBody>
+        </p:sp>
+        <p:sp>
+          <p:nvSpPr>
+            <p:cNvPr id="57" name="TextBox 56">
+              <a:extLst>
+                <a:ext uri="{FF2B5EF4-FFF2-40B4-BE49-F238E27FC236}">
+                  <a16:creationId xmlns:a16="http://schemas.microsoft.com/office/drawing/2014/main" id="{CFA0966B-9554-AC0D-A14F-F3D4A18603BE}"/>
+                </a:ext>
+              </a:extLst>
+            </p:cNvPr>
+            <p:cNvSpPr txBox="1"/>
+            <p:nvPr/>
+          </p:nvSpPr>
+          <p:spPr>
+            <a:xfrm>
+              <a:off x="6333640" y="6858000"/>
+              <a:ext cx="5495081" cy="923330"/>
+            </a:xfrm>
+            <a:prstGeom prst="rect">
+              <a:avLst/>
+            </a:prstGeom>
+            <a:solidFill>
+              <a:schemeClr val="bg1"/>
+            </a:solidFill>
+            <a:ln>
+              <a:noFill/>
+            </a:ln>
+          </p:spPr>
+          <p:txBody>
+            <a:bodyPr wrap="square">
+              <a:spAutoFit/>
+            </a:bodyPr>
+            <a:lstStyle/>
+            <a:p>
+              <a:r>
+                <a:rPr lang="nl-NL" dirty="0"/>
+                <a:t>&lt;ADJLIST_START&gt; (1,1) &lt;–&gt; (2,1) ; … (5,4) &lt;–&gt; (5,5) &lt;ADJLIST_END&gt; &lt;ORIGIN_START&gt;(1,1)&lt;ORIGIN_END&gt; &lt;TARGET_START&gt;(5,5)&lt;TARGET_END&gt; </a:t>
+              </a:r>
+            </a:p>
+          </p:txBody>
+        </p:sp>
+        <p:sp>
+          <p:nvSpPr>
+            <p:cNvPr id="58" name="TextBox 57">
+              <a:extLst>
+                <a:ext uri="{FF2B5EF4-FFF2-40B4-BE49-F238E27FC236}">
+                  <a16:creationId xmlns:a16="http://schemas.microsoft.com/office/drawing/2014/main" id="{0D81E1E2-695D-6B34-B08D-BE1F3D30CAF6}"/>
+                </a:ext>
+              </a:extLst>
+            </p:cNvPr>
+            <p:cNvSpPr txBox="1"/>
+            <p:nvPr/>
+          </p:nvSpPr>
+          <p:spPr>
+            <a:xfrm>
+              <a:off x="11953575" y="-489425"/>
+              <a:ext cx="3947160" cy="923330"/>
+            </a:xfrm>
+            <a:prstGeom prst="rect">
+              <a:avLst/>
+            </a:prstGeom>
+            <a:solidFill>
+              <a:schemeClr val="bg1"/>
+            </a:solidFill>
+            <a:ln>
+              <a:noFill/>
+            </a:ln>
+          </p:spPr>
+          <p:txBody>
+            <a:bodyPr wrap="square">
+              <a:spAutoFit/>
+            </a:bodyPr>
+            <a:lstStyle/>
+            <a:p>
+              <a:r>
+                <a:rPr lang="nl-NL" dirty="0"/>
+                <a:t>&lt;|0-0|&gt; &lt;|uprightleft_wall|&gt; &lt;|origin|&gt;</a:t>
+              </a:r>
+            </a:p>
+            <a:p>
+              <a:r>
+                <a:rPr lang="nl-NL" dirty="0"/>
+                <a:t>&lt;|0-1|&gt; &lt;|updownleft_wall|&gt; …</a:t>
+              </a:r>
+            </a:p>
+            <a:p>
+              <a:r>
+                <a:rPr lang="nl-NL" dirty="0"/>
+                <a:t>&lt;|2-2|&gt; &lt;|downright_wall|&gt; &lt;|target|&gt;</a:t>
+              </a:r>
+            </a:p>
+          </p:txBody>
+        </p:sp>
+        <p:sp>
+          <p:nvSpPr>
+            <p:cNvPr id="59" name="TextBox 58">
+              <a:extLst>
+                <a:ext uri="{FF2B5EF4-FFF2-40B4-BE49-F238E27FC236}">
+                  <a16:creationId xmlns:a16="http://schemas.microsoft.com/office/drawing/2014/main" id="{903C0DDA-35F5-5FFB-DC2D-5A8043A29F66}"/>
+                </a:ext>
+              </a:extLst>
+            </p:cNvPr>
+            <p:cNvSpPr txBox="1"/>
+            <p:nvPr/>
+          </p:nvSpPr>
+          <p:spPr>
+            <a:xfrm>
+              <a:off x="11953575" y="6858000"/>
+              <a:ext cx="4764405" cy="923330"/>
+            </a:xfrm>
+            <a:prstGeom prst="rect">
+              <a:avLst/>
+            </a:prstGeom>
+            <a:solidFill>
+              <a:schemeClr val="bg1"/>
+            </a:solidFill>
+            <a:ln>
+              <a:noFill/>
+            </a:ln>
+          </p:spPr>
+          <p:txBody>
+            <a:bodyPr wrap="square">
+              <a:spAutoFit/>
+            </a:bodyPr>
+            <a:lstStyle/>
+            <a:p>
+              <a:r>
+                <a:rPr lang="nl-NL" dirty="0"/>
+                <a:t>&lt;|0-0|&gt; &lt;|occupied_wall|&gt; … &lt;|1-1|&gt; &lt;|origin|&gt;</a:t>
+              </a:r>
+            </a:p>
+            <a:p>
+              <a:r>
+                <a:rPr lang="nl-NL" dirty="0"/>
+                <a:t> &lt;|1-2|&gt; &lt;|occupied_wall|&gt; &lt;|1-3|&gt; &lt;|blank|&gt; …</a:t>
+              </a:r>
+            </a:p>
+            <a:p>
+              <a:r>
+                <a:rPr lang="nl-NL" dirty="0"/>
+                <a:t> &lt;|5-5|&gt; &lt;|target|&gt; … &lt;|6-6|&gt; &lt;|occupied_wall|&gt;</a:t>
+              </a:r>
+            </a:p>
+          </p:txBody>
+        </p:sp>
+        <p:pic>
+          <p:nvPicPr>
+            <p:cNvPr id="67" name="Picture 66" descr="A group of black symbols&#10;&#10;AI-generated content may be incorrect.">
+              <a:extLst>
+                <a:ext uri="{FF2B5EF4-FFF2-40B4-BE49-F238E27FC236}">
+                  <a16:creationId xmlns:a16="http://schemas.microsoft.com/office/drawing/2014/main" id="{67B5820D-6267-0491-66F9-52FEF3E767C4}"/>
+                </a:ext>
+              </a:extLst>
+            </p:cNvPr>
+            <p:cNvPicPr>
+              <a:picLocks noChangeAspect="1"/>
+            </p:cNvPicPr>
+            <p:nvPr/>
+          </p:nvPicPr>
+          <p:blipFill>
+            <a:blip r:embed="rId2"/>
+            <a:stretch>
+              <a:fillRect/>
+            </a:stretch>
+          </p:blipFill>
+          <p:spPr>
+            <a:xfrm>
+              <a:off x="17005961" y="8274182"/>
+              <a:ext cx="2224106" cy="4236392"/>
+            </a:xfrm>
+            <a:prstGeom prst="rect">
+              <a:avLst/>
+            </a:prstGeom>
+            <a:solidFill>
+              <a:schemeClr val="bg1"/>
+            </a:solidFill>
+          </p:spPr>
+        </p:pic>
+        <p:sp>
+          <p:nvSpPr>
+            <p:cNvPr id="68" name="TextBox 67">
+              <a:extLst>
+                <a:ext uri="{FF2B5EF4-FFF2-40B4-BE49-F238E27FC236}">
+                  <a16:creationId xmlns:a16="http://schemas.microsoft.com/office/drawing/2014/main" id="{CB99F56F-0D81-00BE-8535-79EB376C41A9}"/>
+                </a:ext>
+              </a:extLst>
+            </p:cNvPr>
+            <p:cNvSpPr txBox="1"/>
+            <p:nvPr/>
+          </p:nvSpPr>
+          <p:spPr>
+            <a:xfrm>
+              <a:off x="17542551" y="2349668"/>
+              <a:ext cx="1150923" cy="523220"/>
+            </a:xfrm>
+            <a:prstGeom prst="rect">
+              <a:avLst/>
+            </a:prstGeom>
+            <a:noFill/>
+          </p:spPr>
+          <p:txBody>
+            <a:bodyPr wrap="square" rtlCol="0">
+              <a:spAutoFit/>
+            </a:bodyPr>
+            <a:lstStyle/>
+            <a:p>
+              <a:r>
+                <a:rPr lang="en-US" sz="2800" dirty="0"/>
+                <a:t>None</a:t>
+              </a:r>
+              <a:endParaRPr lang="nl-NL" sz="2800" dirty="0"/>
+            </a:p>
+          </p:txBody>
+        </p:sp>
+      </p:grpSp>
     </p:spTree>
     <p:extLst>
       <p:ext uri="{BB962C8B-B14F-4D97-AF65-F5344CB8AC3E}">

</xml_diff>

<commit_message>
removed all 110%, recreated all images for paper, and ran more explorative charts.
</commit_message>
<xml_diff>
--- a/representations image.pptx
+++ b/representations image.pptx
@@ -5,16 +5,17 @@
     <p:sldMasterId id="2147483648" r:id="rId1"/>
   </p:sldMasterIdLst>
   <p:notesMasterIdLst>
-    <p:notesMasterId r:id="rId9"/>
+    <p:notesMasterId r:id="rId10"/>
   </p:notesMasterIdLst>
   <p:sldIdLst>
     <p:sldId id="256" r:id="rId2"/>
-    <p:sldId id="257" r:id="rId3"/>
-    <p:sldId id="258" r:id="rId4"/>
-    <p:sldId id="259" r:id="rId5"/>
-    <p:sldId id="260" r:id="rId6"/>
-    <p:sldId id="262" r:id="rId7"/>
-    <p:sldId id="261" r:id="rId8"/>
+    <p:sldId id="263" r:id="rId3"/>
+    <p:sldId id="257" r:id="rId4"/>
+    <p:sldId id="258" r:id="rId5"/>
+    <p:sldId id="259" r:id="rId6"/>
+    <p:sldId id="260" r:id="rId7"/>
+    <p:sldId id="262" r:id="rId8"/>
+    <p:sldId id="261" r:id="rId9"/>
   </p:sldIdLst>
   <p:sldSz cx="12192000" cy="6858000"/>
   <p:notesSz cx="6858000" cy="9144000"/>
@@ -203,7 +204,7 @@
           <a:p>
             <a:fld id="{D94C1F51-8E4F-4E5B-B98C-042184E4D3EC}" type="datetimeFigureOut">
               <a:rPr lang="nl-NL" smtClean="0"/>
-              <a:t>9-3-2026</a:t>
+              <a:t>16-3-2026</a:t>
             </a:fld>
             <a:endParaRPr lang="nl-NL"/>
           </a:p>
@@ -536,7 +537,7 @@
           <a:p>
             <a:fld id="{6167083C-E1A1-4EE3-8924-0DC9FD7DE75D}" type="slidenum">
               <a:rPr lang="nl-NL" smtClean="0"/>
-              <a:t>7</a:t>
+              <a:t>8</a:t>
             </a:fld>
             <a:endParaRPr lang="nl-NL"/>
           </a:p>
@@ -704,7 +705,7 @@
           <a:p>
             <a:fld id="{170662DF-287D-431E-B338-DA766D8B3B6C}" type="datetimeFigureOut">
               <a:rPr lang="nl-NL" smtClean="0"/>
-              <a:t>9-3-2026</a:t>
+              <a:t>16-3-2026</a:t>
             </a:fld>
             <a:endParaRPr lang="nl-NL"/>
           </a:p>
@@ -904,7 +905,7 @@
           <a:p>
             <a:fld id="{170662DF-287D-431E-B338-DA766D8B3B6C}" type="datetimeFigureOut">
               <a:rPr lang="nl-NL" smtClean="0"/>
-              <a:t>9-3-2026</a:t>
+              <a:t>16-3-2026</a:t>
             </a:fld>
             <a:endParaRPr lang="nl-NL"/>
           </a:p>
@@ -1114,7 +1115,7 @@
           <a:p>
             <a:fld id="{170662DF-287D-431E-B338-DA766D8B3B6C}" type="datetimeFigureOut">
               <a:rPr lang="nl-NL" smtClean="0"/>
-              <a:t>9-3-2026</a:t>
+              <a:t>16-3-2026</a:t>
             </a:fld>
             <a:endParaRPr lang="nl-NL"/>
           </a:p>
@@ -1314,7 +1315,7 @@
           <a:p>
             <a:fld id="{170662DF-287D-431E-B338-DA766D8B3B6C}" type="datetimeFigureOut">
               <a:rPr lang="nl-NL" smtClean="0"/>
-              <a:t>9-3-2026</a:t>
+              <a:t>16-3-2026</a:t>
             </a:fld>
             <a:endParaRPr lang="nl-NL"/>
           </a:p>
@@ -1590,7 +1591,7 @@
           <a:p>
             <a:fld id="{170662DF-287D-431E-B338-DA766D8B3B6C}" type="datetimeFigureOut">
               <a:rPr lang="nl-NL" smtClean="0"/>
-              <a:t>9-3-2026</a:t>
+              <a:t>16-3-2026</a:t>
             </a:fld>
             <a:endParaRPr lang="nl-NL"/>
           </a:p>
@@ -1858,7 +1859,7 @@
           <a:p>
             <a:fld id="{170662DF-287D-431E-B338-DA766D8B3B6C}" type="datetimeFigureOut">
               <a:rPr lang="nl-NL" smtClean="0"/>
-              <a:t>9-3-2026</a:t>
+              <a:t>16-3-2026</a:t>
             </a:fld>
             <a:endParaRPr lang="nl-NL"/>
           </a:p>
@@ -2273,7 +2274,7 @@
           <a:p>
             <a:fld id="{170662DF-287D-431E-B338-DA766D8B3B6C}" type="datetimeFigureOut">
               <a:rPr lang="nl-NL" smtClean="0"/>
-              <a:t>9-3-2026</a:t>
+              <a:t>16-3-2026</a:t>
             </a:fld>
             <a:endParaRPr lang="nl-NL"/>
           </a:p>
@@ -2415,7 +2416,7 @@
           <a:p>
             <a:fld id="{170662DF-287D-431E-B338-DA766D8B3B6C}" type="datetimeFigureOut">
               <a:rPr lang="nl-NL" smtClean="0"/>
-              <a:t>9-3-2026</a:t>
+              <a:t>16-3-2026</a:t>
             </a:fld>
             <a:endParaRPr lang="nl-NL"/>
           </a:p>
@@ -2528,7 +2529,7 @@
           <a:p>
             <a:fld id="{170662DF-287D-431E-B338-DA766D8B3B6C}" type="datetimeFigureOut">
               <a:rPr lang="nl-NL" smtClean="0"/>
-              <a:t>9-3-2026</a:t>
+              <a:t>16-3-2026</a:t>
             </a:fld>
             <a:endParaRPr lang="nl-NL"/>
           </a:p>
@@ -2841,7 +2842,7 @@
           <a:p>
             <a:fld id="{170662DF-287D-431E-B338-DA766D8B3B6C}" type="datetimeFigureOut">
               <a:rPr lang="nl-NL" smtClean="0"/>
-              <a:t>9-3-2026</a:t>
+              <a:t>16-3-2026</a:t>
             </a:fld>
             <a:endParaRPr lang="nl-NL"/>
           </a:p>
@@ -3130,7 +3131,7 @@
           <a:p>
             <a:fld id="{170662DF-287D-431E-B338-DA766D8B3B6C}" type="datetimeFigureOut">
               <a:rPr lang="nl-NL" smtClean="0"/>
-              <a:t>9-3-2026</a:t>
+              <a:t>16-3-2026</a:t>
             </a:fld>
             <a:endParaRPr lang="nl-NL"/>
           </a:p>
@@ -3373,7 +3374,7 @@
           <a:p>
             <a:fld id="{170662DF-287D-431E-B338-DA766D8B3B6C}" type="datetimeFigureOut">
               <a:rPr lang="nl-NL" smtClean="0"/>
-              <a:t>9-3-2026</a:t>
+              <a:t>16-3-2026</a:t>
             </a:fld>
             <a:endParaRPr lang="nl-NL"/>
           </a:p>
@@ -5399,6 +5400,2182 @@
       </p:grpSpPr>
       <p:sp>
         <p:nvSpPr>
+          <p:cNvPr id="17" name="Left Brace 16">
+            <a:extLst>
+              <a:ext uri="{FF2B5EF4-FFF2-40B4-BE49-F238E27FC236}">
+                <a16:creationId xmlns:a16="http://schemas.microsoft.com/office/drawing/2014/main" id="{632FECBC-085E-C969-3D74-BE462D922B81}"/>
+              </a:ext>
+            </a:extLst>
+          </p:cNvPr>
+          <p:cNvSpPr/>
+          <p:nvPr/>
+        </p:nvSpPr>
+        <p:spPr>
+          <a:xfrm>
+            <a:off x="10791915" y="2873261"/>
+            <a:ext cx="538485" cy="3435754"/>
+          </a:xfrm>
+          <a:prstGeom prst="leftBrace">
+            <a:avLst>
+              <a:gd name="adj1" fmla="val 30914"/>
+              <a:gd name="adj2" fmla="val 50683"/>
+            </a:avLst>
+          </a:prstGeom>
+          <a:ln>
+            <a:solidFill>
+              <a:schemeClr val="bg2">
+                <a:lumMod val="50000"/>
+              </a:schemeClr>
+            </a:solidFill>
+          </a:ln>
+        </p:spPr>
+        <p:style>
+          <a:lnRef idx="2">
+            <a:schemeClr val="accent1"/>
+          </a:lnRef>
+          <a:fillRef idx="0">
+            <a:schemeClr val="accent1"/>
+          </a:fillRef>
+          <a:effectRef idx="1">
+            <a:schemeClr val="accent1"/>
+          </a:effectRef>
+          <a:fontRef idx="minor">
+            <a:schemeClr val="tx1"/>
+          </a:fontRef>
+        </p:style>
+        <p:txBody>
+          <a:bodyPr rtlCol="0" anchor="ctr"/>
+          <a:lstStyle/>
+          <a:p>
+            <a:pPr algn="ctr"/>
+            <a:endParaRPr lang="nl-NL"/>
+          </a:p>
+        </p:txBody>
+      </p:sp>
+      <p:sp>
+        <p:nvSpPr>
+          <p:cNvPr id="18" name="TextBox 17">
+            <a:extLst>
+              <a:ext uri="{FF2B5EF4-FFF2-40B4-BE49-F238E27FC236}">
+                <a16:creationId xmlns:a16="http://schemas.microsoft.com/office/drawing/2014/main" id="{C6976D8B-D46E-CDBC-60BD-31304A7B6DC9}"/>
+              </a:ext>
+            </a:extLst>
+          </p:cNvPr>
+          <p:cNvSpPr txBox="1"/>
+          <p:nvPr/>
+        </p:nvSpPr>
+        <p:spPr>
+          <a:xfrm>
+            <a:off x="9572926" y="4167071"/>
+            <a:ext cx="1838632" cy="923330"/>
+          </a:xfrm>
+          <a:prstGeom prst="rect">
+            <a:avLst/>
+          </a:prstGeom>
+          <a:noFill/>
+        </p:spPr>
+        <p:txBody>
+          <a:bodyPr wrap="square" rtlCol="0">
+            <a:spAutoFit/>
+          </a:bodyPr>
+          <a:lstStyle/>
+          <a:p>
+            <a:r>
+              <a:rPr lang="en-US" dirty="0"/>
+              <a:t>Language expressing </a:t>
+            </a:r>
+            <a:r>
+              <a:rPr lang="en-US" b="1" dirty="0"/>
+              <a:t>frustration</a:t>
+            </a:r>
+            <a:endParaRPr lang="nl-NL" b="1" dirty="0"/>
+          </a:p>
+        </p:txBody>
+      </p:sp>
+      <p:sp>
+        <p:nvSpPr>
+          <p:cNvPr id="26" name="TextBox 25">
+            <a:extLst>
+              <a:ext uri="{FF2B5EF4-FFF2-40B4-BE49-F238E27FC236}">
+                <a16:creationId xmlns:a16="http://schemas.microsoft.com/office/drawing/2014/main" id="{1EB50937-71E9-D3BB-B674-3CC5782B9CA2}"/>
+              </a:ext>
+            </a:extLst>
+          </p:cNvPr>
+          <p:cNvSpPr txBox="1"/>
+          <p:nvPr/>
+        </p:nvSpPr>
+        <p:spPr>
+          <a:xfrm>
+            <a:off x="11508094" y="964051"/>
+            <a:ext cx="1823863" cy="369332"/>
+          </a:xfrm>
+          <a:prstGeom prst="rect">
+            <a:avLst/>
+          </a:prstGeom>
+          <a:noFill/>
+        </p:spPr>
+        <p:txBody>
+          <a:bodyPr wrap="square" rtlCol="0">
+            <a:spAutoFit/>
+          </a:bodyPr>
+          <a:lstStyle/>
+          <a:p>
+            <a:r>
+              <a:rPr lang="en-US" dirty="0"/>
+              <a:t>Introduce task</a:t>
+            </a:r>
+            <a:endParaRPr lang="nl-NL" dirty="0"/>
+          </a:p>
+        </p:txBody>
+      </p:sp>
+      <p:sp>
+        <p:nvSpPr>
+          <p:cNvPr id="27" name="TextBox 26">
+            <a:extLst>
+              <a:ext uri="{FF2B5EF4-FFF2-40B4-BE49-F238E27FC236}">
+                <a16:creationId xmlns:a16="http://schemas.microsoft.com/office/drawing/2014/main" id="{B9BC3DA6-6CFA-6981-A20C-1D68E0F8771F}"/>
+              </a:ext>
+            </a:extLst>
+          </p:cNvPr>
+          <p:cNvSpPr txBox="1"/>
+          <p:nvPr/>
+        </p:nvSpPr>
+        <p:spPr>
+          <a:xfrm>
+            <a:off x="11477696" y="1615719"/>
+            <a:ext cx="3401961" cy="369332"/>
+          </a:xfrm>
+          <a:prstGeom prst="rect">
+            <a:avLst/>
+          </a:prstGeom>
+          <a:noFill/>
+        </p:spPr>
+        <p:txBody>
+          <a:bodyPr wrap="square" rtlCol="0">
+            <a:spAutoFit/>
+          </a:bodyPr>
+          <a:lstStyle/>
+          <a:p>
+            <a:r>
+              <a:rPr lang="en-US" dirty="0"/>
+              <a:t>Choose method</a:t>
+            </a:r>
+            <a:endParaRPr lang="nl-NL" dirty="0"/>
+          </a:p>
+        </p:txBody>
+      </p:sp>
+      <p:sp>
+        <p:nvSpPr>
+          <p:cNvPr id="28" name="TextBox 27">
+            <a:extLst>
+              <a:ext uri="{FF2B5EF4-FFF2-40B4-BE49-F238E27FC236}">
+                <a16:creationId xmlns:a16="http://schemas.microsoft.com/office/drawing/2014/main" id="{679EFB02-C1FD-F1C3-77EF-61D548C22234}"/>
+              </a:ext>
+            </a:extLst>
+          </p:cNvPr>
+          <p:cNvSpPr txBox="1"/>
+          <p:nvPr/>
+        </p:nvSpPr>
+        <p:spPr>
+          <a:xfrm>
+            <a:off x="13012858" y="3968426"/>
+            <a:ext cx="3401961" cy="369332"/>
+          </a:xfrm>
+          <a:prstGeom prst="rect">
+            <a:avLst/>
+          </a:prstGeom>
+          <a:noFill/>
+        </p:spPr>
+        <p:txBody>
+          <a:bodyPr wrap="square" rtlCol="0">
+            <a:spAutoFit/>
+          </a:bodyPr>
+          <a:lstStyle/>
+          <a:p>
+            <a:r>
+              <a:rPr lang="en-US" dirty="0"/>
+              <a:t>Change method</a:t>
+            </a:r>
+            <a:endParaRPr lang="nl-NL" dirty="0"/>
+          </a:p>
+        </p:txBody>
+      </p:sp>
+      <p:sp>
+        <p:nvSpPr>
+          <p:cNvPr id="29" name="TextBox 28">
+            <a:extLst>
+              <a:ext uri="{FF2B5EF4-FFF2-40B4-BE49-F238E27FC236}">
+                <a16:creationId xmlns:a16="http://schemas.microsoft.com/office/drawing/2014/main" id="{B8157A55-B608-7C6F-0F11-CC132871D837}"/>
+              </a:ext>
+            </a:extLst>
+          </p:cNvPr>
+          <p:cNvSpPr txBox="1"/>
+          <p:nvPr/>
+        </p:nvSpPr>
+        <p:spPr>
+          <a:xfrm>
+            <a:off x="11943163" y="5627675"/>
+            <a:ext cx="3401961" cy="369332"/>
+          </a:xfrm>
+          <a:prstGeom prst="rect">
+            <a:avLst/>
+          </a:prstGeom>
+          <a:noFill/>
+        </p:spPr>
+        <p:txBody>
+          <a:bodyPr wrap="square" rtlCol="0">
+            <a:spAutoFit/>
+          </a:bodyPr>
+          <a:lstStyle/>
+          <a:p>
+            <a:r>
+              <a:rPr lang="en-US" dirty="0"/>
+              <a:t>(Validate)</a:t>
+            </a:r>
+            <a:endParaRPr lang="nl-NL" dirty="0"/>
+          </a:p>
+        </p:txBody>
+      </p:sp>
+      <p:sp>
+        <p:nvSpPr>
+          <p:cNvPr id="30" name="TextBox 29">
+            <a:extLst>
+              <a:ext uri="{FF2B5EF4-FFF2-40B4-BE49-F238E27FC236}">
+                <a16:creationId xmlns:a16="http://schemas.microsoft.com/office/drawing/2014/main" id="{1F0FD100-652E-7EF4-CF83-12FC73827948}"/>
+              </a:ext>
+            </a:extLst>
+          </p:cNvPr>
+          <p:cNvSpPr txBox="1"/>
+          <p:nvPr/>
+        </p:nvSpPr>
+        <p:spPr>
+          <a:xfrm>
+            <a:off x="11907848" y="5938215"/>
+            <a:ext cx="3401961" cy="369332"/>
+          </a:xfrm>
+          <a:prstGeom prst="rect">
+            <a:avLst/>
+          </a:prstGeom>
+          <a:noFill/>
+        </p:spPr>
+        <p:txBody>
+          <a:bodyPr wrap="square" rtlCol="0">
+            <a:spAutoFit/>
+          </a:bodyPr>
+          <a:lstStyle/>
+          <a:p>
+            <a:r>
+              <a:rPr lang="en-US" dirty="0"/>
+              <a:t>(Summarize)</a:t>
+            </a:r>
+            <a:endParaRPr lang="nl-NL" dirty="0"/>
+          </a:p>
+        </p:txBody>
+      </p:sp>
+      <p:sp>
+        <p:nvSpPr>
+          <p:cNvPr id="33" name="TextBox 32">
+            <a:extLst>
+              <a:ext uri="{FF2B5EF4-FFF2-40B4-BE49-F238E27FC236}">
+                <a16:creationId xmlns:a16="http://schemas.microsoft.com/office/drawing/2014/main" id="{F6B4DBB9-6D40-E928-C28C-57C8E8612D38}"/>
+              </a:ext>
+            </a:extLst>
+          </p:cNvPr>
+          <p:cNvSpPr txBox="1"/>
+          <p:nvPr/>
+        </p:nvSpPr>
+        <p:spPr>
+          <a:xfrm>
+            <a:off x="15022923" y="3788737"/>
+            <a:ext cx="1838632" cy="338554"/>
+          </a:xfrm>
+          <a:prstGeom prst="rect">
+            <a:avLst/>
+          </a:prstGeom>
+          <a:noFill/>
+        </p:spPr>
+        <p:txBody>
+          <a:bodyPr wrap="square" rtlCol="0">
+            <a:spAutoFit/>
+          </a:bodyPr>
+          <a:lstStyle/>
+          <a:p>
+            <a:r>
+              <a:rPr lang="en-US" sz="1600" b="1" dirty="0"/>
+              <a:t>Reverse search</a:t>
+            </a:r>
+            <a:endParaRPr lang="nl-NL" sz="1600" b="1" dirty="0"/>
+          </a:p>
+        </p:txBody>
+      </p:sp>
+      <p:sp>
+        <p:nvSpPr>
+          <p:cNvPr id="34" name="TextBox 33">
+            <a:extLst>
+              <a:ext uri="{FF2B5EF4-FFF2-40B4-BE49-F238E27FC236}">
+                <a16:creationId xmlns:a16="http://schemas.microsoft.com/office/drawing/2014/main" id="{3CC5D0BC-A64C-E0BF-050B-B00A9E5CB9A3}"/>
+              </a:ext>
+            </a:extLst>
+          </p:cNvPr>
+          <p:cNvSpPr txBox="1"/>
+          <p:nvPr/>
+        </p:nvSpPr>
+        <p:spPr>
+          <a:xfrm>
+            <a:off x="15022923" y="4099069"/>
+            <a:ext cx="1759975" cy="338554"/>
+          </a:xfrm>
+          <a:prstGeom prst="rect">
+            <a:avLst/>
+          </a:prstGeom>
+          <a:noFill/>
+        </p:spPr>
+        <p:txBody>
+          <a:bodyPr wrap="square" rtlCol="0">
+            <a:spAutoFit/>
+          </a:bodyPr>
+          <a:lstStyle/>
+          <a:p>
+            <a:r>
+              <a:rPr lang="en-US" sz="1600" b="1" dirty="0"/>
+              <a:t>Restart</a:t>
+            </a:r>
+            <a:endParaRPr lang="nl-NL" sz="1600" b="1" dirty="0"/>
+          </a:p>
+        </p:txBody>
+      </p:sp>
+      <p:cxnSp>
+        <p:nvCxnSpPr>
+          <p:cNvPr id="37" name="Straight Arrow Connector 36">
+            <a:extLst>
+              <a:ext uri="{FF2B5EF4-FFF2-40B4-BE49-F238E27FC236}">
+                <a16:creationId xmlns:a16="http://schemas.microsoft.com/office/drawing/2014/main" id="{4D04F184-48E1-0C26-DE63-5E1E2703366E}"/>
+              </a:ext>
+            </a:extLst>
+          </p:cNvPr>
+          <p:cNvCxnSpPr>
+            <a:cxnSpLocks/>
+          </p:cNvCxnSpPr>
+          <p:nvPr/>
+        </p:nvCxnSpPr>
+        <p:spPr>
+          <a:xfrm flipV="1">
+            <a:off x="13296642" y="1620007"/>
+            <a:ext cx="312186" cy="110345"/>
+          </a:xfrm>
+          <a:prstGeom prst="straightConnector1">
+            <a:avLst/>
+          </a:prstGeom>
+          <a:ln>
+            <a:solidFill>
+              <a:srgbClr val="EC1CBF"/>
+            </a:solidFill>
+            <a:prstDash val="sysDash"/>
+            <a:tailEnd type="triangle"/>
+          </a:ln>
+        </p:spPr>
+        <p:style>
+          <a:lnRef idx="2">
+            <a:schemeClr val="accent1"/>
+          </a:lnRef>
+          <a:fillRef idx="0">
+            <a:schemeClr val="accent1"/>
+          </a:fillRef>
+          <a:effectRef idx="1">
+            <a:schemeClr val="accent1"/>
+          </a:effectRef>
+          <a:fontRef idx="minor">
+            <a:schemeClr val="tx1"/>
+          </a:fontRef>
+        </p:style>
+      </p:cxnSp>
+      <p:cxnSp>
+        <p:nvCxnSpPr>
+          <p:cNvPr id="38" name="Straight Arrow Connector 37">
+            <a:extLst>
+              <a:ext uri="{FF2B5EF4-FFF2-40B4-BE49-F238E27FC236}">
+                <a16:creationId xmlns:a16="http://schemas.microsoft.com/office/drawing/2014/main" id="{3840B746-8165-D435-2890-3984ACC5A4EA}"/>
+              </a:ext>
+            </a:extLst>
+          </p:cNvPr>
+          <p:cNvCxnSpPr>
+            <a:cxnSpLocks/>
+          </p:cNvCxnSpPr>
+          <p:nvPr/>
+        </p:nvCxnSpPr>
+        <p:spPr>
+          <a:xfrm>
+            <a:off x="13297292" y="1858681"/>
+            <a:ext cx="347501" cy="32137"/>
+          </a:xfrm>
+          <a:prstGeom prst="straightConnector1">
+            <a:avLst/>
+          </a:prstGeom>
+          <a:ln>
+            <a:solidFill>
+              <a:srgbClr val="EC1CBF"/>
+            </a:solidFill>
+            <a:prstDash val="sysDash"/>
+            <a:tailEnd type="triangle"/>
+          </a:ln>
+        </p:spPr>
+        <p:style>
+          <a:lnRef idx="2">
+            <a:schemeClr val="accent1"/>
+          </a:lnRef>
+          <a:fillRef idx="0">
+            <a:schemeClr val="accent1"/>
+          </a:fillRef>
+          <a:effectRef idx="1">
+            <a:schemeClr val="accent1"/>
+          </a:effectRef>
+          <a:fontRef idx="minor">
+            <a:schemeClr val="tx1"/>
+          </a:fontRef>
+        </p:style>
+      </p:cxnSp>
+      <p:sp>
+        <p:nvSpPr>
+          <p:cNvPr id="39" name="TextBox 38">
+            <a:extLst>
+              <a:ext uri="{FF2B5EF4-FFF2-40B4-BE49-F238E27FC236}">
+                <a16:creationId xmlns:a16="http://schemas.microsoft.com/office/drawing/2014/main" id="{E5FD6AE5-F9E5-8B36-96F0-9271D7BD4380}"/>
+              </a:ext>
+            </a:extLst>
+          </p:cNvPr>
+          <p:cNvSpPr txBox="1"/>
+          <p:nvPr/>
+        </p:nvSpPr>
+        <p:spPr>
+          <a:xfrm>
+            <a:off x="13589142" y="1436925"/>
+            <a:ext cx="1838632" cy="338554"/>
+          </a:xfrm>
+          <a:prstGeom prst="rect">
+            <a:avLst/>
+          </a:prstGeom>
+          <a:noFill/>
+        </p:spPr>
+        <p:txBody>
+          <a:bodyPr wrap="square" rtlCol="0">
+            <a:spAutoFit/>
+          </a:bodyPr>
+          <a:lstStyle/>
+          <a:p>
+            <a:r>
+              <a:rPr lang="en-US" sz="1600" b="1" dirty="0"/>
+              <a:t>Algorithm</a:t>
+            </a:r>
+            <a:endParaRPr lang="nl-NL" sz="1600" b="1" dirty="0"/>
+          </a:p>
+        </p:txBody>
+      </p:sp>
+      <p:sp>
+        <p:nvSpPr>
+          <p:cNvPr id="40" name="TextBox 39">
+            <a:extLst>
+              <a:ext uri="{FF2B5EF4-FFF2-40B4-BE49-F238E27FC236}">
+                <a16:creationId xmlns:a16="http://schemas.microsoft.com/office/drawing/2014/main" id="{64234911-E278-5907-C7D4-8B4B7D05BC0B}"/>
+              </a:ext>
+            </a:extLst>
+          </p:cNvPr>
+          <p:cNvSpPr txBox="1"/>
+          <p:nvPr/>
+        </p:nvSpPr>
+        <p:spPr>
+          <a:xfrm>
+            <a:off x="13614914" y="1742801"/>
+            <a:ext cx="1759975" cy="338554"/>
+          </a:xfrm>
+          <a:prstGeom prst="rect">
+            <a:avLst/>
+          </a:prstGeom>
+          <a:noFill/>
+        </p:spPr>
+        <p:txBody>
+          <a:bodyPr wrap="square" rtlCol="0">
+            <a:spAutoFit/>
+          </a:bodyPr>
+          <a:lstStyle/>
+          <a:p>
+            <a:r>
+              <a:rPr lang="en-US" sz="1600" b="1" dirty="0"/>
+              <a:t>Heuristics</a:t>
+            </a:r>
+            <a:endParaRPr lang="nl-NL" sz="1600" b="1" dirty="0"/>
+          </a:p>
+        </p:txBody>
+      </p:sp>
+      <p:cxnSp>
+        <p:nvCxnSpPr>
+          <p:cNvPr id="42" name="Straight Arrow Connector 41">
+            <a:extLst>
+              <a:ext uri="{FF2B5EF4-FFF2-40B4-BE49-F238E27FC236}">
+                <a16:creationId xmlns:a16="http://schemas.microsoft.com/office/drawing/2014/main" id="{CCEF1813-C5D6-D42F-BEC9-9DFDF616673A}"/>
+              </a:ext>
+            </a:extLst>
+          </p:cNvPr>
+          <p:cNvCxnSpPr/>
+          <p:nvPr/>
+        </p:nvCxnSpPr>
+        <p:spPr>
+          <a:xfrm>
+            <a:off x="12238704" y="1333383"/>
+            <a:ext cx="0" cy="303474"/>
+          </a:xfrm>
+          <a:prstGeom prst="straightConnector1">
+            <a:avLst/>
+          </a:prstGeom>
+          <a:ln>
+            <a:tailEnd type="triangle"/>
+          </a:ln>
+        </p:spPr>
+        <p:style>
+          <a:lnRef idx="2">
+            <a:schemeClr val="accent1"/>
+          </a:lnRef>
+          <a:fillRef idx="0">
+            <a:schemeClr val="accent1"/>
+          </a:fillRef>
+          <a:effectRef idx="1">
+            <a:schemeClr val="accent1"/>
+          </a:effectRef>
+          <a:fontRef idx="minor">
+            <a:schemeClr val="tx1"/>
+          </a:fontRef>
+        </p:style>
+      </p:cxnSp>
+      <p:cxnSp>
+        <p:nvCxnSpPr>
+          <p:cNvPr id="46" name="Straight Arrow Connector 45">
+            <a:extLst>
+              <a:ext uri="{FF2B5EF4-FFF2-40B4-BE49-F238E27FC236}">
+                <a16:creationId xmlns:a16="http://schemas.microsoft.com/office/drawing/2014/main" id="{030C0C86-9CEF-B3B1-C845-6465EA169AD1}"/>
+              </a:ext>
+            </a:extLst>
+          </p:cNvPr>
+          <p:cNvCxnSpPr>
+            <a:cxnSpLocks/>
+          </p:cNvCxnSpPr>
+          <p:nvPr/>
+        </p:nvCxnSpPr>
+        <p:spPr>
+          <a:xfrm>
+            <a:off x="12137155" y="2595388"/>
+            <a:ext cx="0" cy="2995851"/>
+          </a:xfrm>
+          <a:prstGeom prst="straightConnector1">
+            <a:avLst/>
+          </a:prstGeom>
+          <a:ln>
+            <a:tailEnd type="triangle"/>
+          </a:ln>
+        </p:spPr>
+        <p:style>
+          <a:lnRef idx="2">
+            <a:schemeClr val="accent1"/>
+          </a:lnRef>
+          <a:fillRef idx="0">
+            <a:schemeClr val="accent1"/>
+          </a:fillRef>
+          <a:effectRef idx="1">
+            <a:schemeClr val="accent1"/>
+          </a:effectRef>
+          <a:fontRef idx="minor">
+            <a:schemeClr val="tx1"/>
+          </a:fontRef>
+        </p:style>
+      </p:cxnSp>
+      <p:sp>
+        <p:nvSpPr>
+          <p:cNvPr id="54" name="Rectangle 53">
+            <a:extLst>
+              <a:ext uri="{FF2B5EF4-FFF2-40B4-BE49-F238E27FC236}">
+                <a16:creationId xmlns:a16="http://schemas.microsoft.com/office/drawing/2014/main" id="{4A85BECB-49CD-7737-1864-F9814E980E12}"/>
+              </a:ext>
+            </a:extLst>
+          </p:cNvPr>
+          <p:cNvSpPr/>
+          <p:nvPr/>
+        </p:nvSpPr>
+        <p:spPr>
+          <a:xfrm>
+            <a:off x="12660943" y="2906252"/>
+            <a:ext cx="983201" cy="369332"/>
+          </a:xfrm>
+          <a:prstGeom prst="rect">
+            <a:avLst/>
+          </a:prstGeom>
+        </p:spPr>
+        <p:style>
+          <a:lnRef idx="2">
+            <a:schemeClr val="accent6"/>
+          </a:lnRef>
+          <a:fillRef idx="1">
+            <a:schemeClr val="lt1"/>
+          </a:fillRef>
+          <a:effectRef idx="0">
+            <a:schemeClr val="accent6"/>
+          </a:effectRef>
+          <a:fontRef idx="minor">
+            <a:schemeClr val="dk1"/>
+          </a:fontRef>
+        </p:style>
+        <p:txBody>
+          <a:bodyPr rtlCol="0" anchor="ctr"/>
+          <a:lstStyle/>
+          <a:p>
+            <a:pPr algn="ctr"/>
+            <a:r>
+              <a:rPr lang="en-US" sz="1200" dirty="0"/>
+              <a:t>If struggling</a:t>
+            </a:r>
+            <a:endParaRPr lang="nl-NL" sz="1200" dirty="0"/>
+          </a:p>
+        </p:txBody>
+      </p:sp>
+      <p:sp>
+        <p:nvSpPr>
+          <p:cNvPr id="55" name="Rectangle 54">
+            <a:extLst>
+              <a:ext uri="{FF2B5EF4-FFF2-40B4-BE49-F238E27FC236}">
+                <a16:creationId xmlns:a16="http://schemas.microsoft.com/office/drawing/2014/main" id="{CE9BC12F-892F-D939-6C06-75CBA23134D7}"/>
+              </a:ext>
+            </a:extLst>
+          </p:cNvPr>
+          <p:cNvSpPr/>
+          <p:nvPr/>
+        </p:nvSpPr>
+        <p:spPr>
+          <a:xfrm>
+            <a:off x="11107556" y="3953651"/>
+            <a:ext cx="983201" cy="369332"/>
+          </a:xfrm>
+          <a:prstGeom prst="rect">
+            <a:avLst/>
+          </a:prstGeom>
+        </p:spPr>
+        <p:style>
+          <a:lnRef idx="2">
+            <a:schemeClr val="accent6"/>
+          </a:lnRef>
+          <a:fillRef idx="1">
+            <a:schemeClr val="lt1"/>
+          </a:fillRef>
+          <a:effectRef idx="0">
+            <a:schemeClr val="accent6"/>
+          </a:effectRef>
+          <a:fontRef idx="minor">
+            <a:schemeClr val="dk1"/>
+          </a:fontRef>
+        </p:style>
+        <p:txBody>
+          <a:bodyPr rtlCol="0" anchor="ctr"/>
+          <a:lstStyle/>
+          <a:p>
+            <a:pPr algn="ctr"/>
+            <a:r>
+              <a:rPr lang="en-US" sz="1200" dirty="0"/>
+              <a:t>If not struggling</a:t>
+            </a:r>
+            <a:endParaRPr lang="nl-NL" sz="1200" dirty="0"/>
+          </a:p>
+        </p:txBody>
+      </p:sp>
+      <p:cxnSp>
+        <p:nvCxnSpPr>
+          <p:cNvPr id="66" name="Connector: Elbow 65">
+            <a:extLst>
+              <a:ext uri="{FF2B5EF4-FFF2-40B4-BE49-F238E27FC236}">
+                <a16:creationId xmlns:a16="http://schemas.microsoft.com/office/drawing/2014/main" id="{C4A0CD69-8443-359B-75C1-1A2A9AF2C611}"/>
+              </a:ext>
+            </a:extLst>
+          </p:cNvPr>
+          <p:cNvCxnSpPr>
+            <a:cxnSpLocks/>
+          </p:cNvCxnSpPr>
+          <p:nvPr/>
+        </p:nvCxnSpPr>
+        <p:spPr>
+          <a:xfrm rot="16200000" flipH="1">
+            <a:off x="12400330" y="2615080"/>
+            <a:ext cx="1440802" cy="1401417"/>
+          </a:xfrm>
+          <a:prstGeom prst="bentConnector3">
+            <a:avLst>
+              <a:gd name="adj1" fmla="val 50000"/>
+            </a:avLst>
+          </a:prstGeom>
+          <a:ln>
+            <a:tailEnd type="triangle"/>
+          </a:ln>
+        </p:spPr>
+        <p:style>
+          <a:lnRef idx="2">
+            <a:schemeClr val="accent1"/>
+          </a:lnRef>
+          <a:fillRef idx="0">
+            <a:schemeClr val="accent1"/>
+          </a:fillRef>
+          <a:effectRef idx="1">
+            <a:schemeClr val="accent1"/>
+          </a:effectRef>
+          <a:fontRef idx="minor">
+            <a:schemeClr val="tx1"/>
+          </a:fontRef>
+        </p:style>
+      </p:cxnSp>
+      <p:cxnSp>
+        <p:nvCxnSpPr>
+          <p:cNvPr id="77" name="Connector: Elbow 76">
+            <a:extLst>
+              <a:ext uri="{FF2B5EF4-FFF2-40B4-BE49-F238E27FC236}">
+                <a16:creationId xmlns:a16="http://schemas.microsoft.com/office/drawing/2014/main" id="{BF915737-AF32-A990-BA9D-85078D57F592}"/>
+              </a:ext>
+            </a:extLst>
+          </p:cNvPr>
+          <p:cNvCxnSpPr>
+            <a:cxnSpLocks/>
+          </p:cNvCxnSpPr>
+          <p:nvPr/>
+        </p:nvCxnSpPr>
+        <p:spPr>
+          <a:xfrm rot="5400000">
+            <a:off x="12620994" y="4390792"/>
+            <a:ext cx="1240395" cy="1160498"/>
+          </a:xfrm>
+          <a:prstGeom prst="bentConnector3">
+            <a:avLst>
+              <a:gd name="adj1" fmla="val 50000"/>
+            </a:avLst>
+          </a:prstGeom>
+          <a:ln>
+            <a:tailEnd type="triangle"/>
+          </a:ln>
+        </p:spPr>
+        <p:style>
+          <a:lnRef idx="2">
+            <a:schemeClr val="accent1"/>
+          </a:lnRef>
+          <a:fillRef idx="0">
+            <a:schemeClr val="accent1"/>
+          </a:fillRef>
+          <a:effectRef idx="1">
+            <a:schemeClr val="accent1"/>
+          </a:effectRef>
+          <a:fontRef idx="minor">
+            <a:schemeClr val="tx1"/>
+          </a:fontRef>
+        </p:style>
+      </p:cxnSp>
+      <p:cxnSp>
+        <p:nvCxnSpPr>
+          <p:cNvPr id="83" name="Straight Connector 82">
+            <a:extLst>
+              <a:ext uri="{FF2B5EF4-FFF2-40B4-BE49-F238E27FC236}">
+                <a16:creationId xmlns:a16="http://schemas.microsoft.com/office/drawing/2014/main" id="{6A99E56D-5CB2-6A32-9A58-2CF448D3023C}"/>
+              </a:ext>
+            </a:extLst>
+          </p:cNvPr>
+          <p:cNvCxnSpPr>
+            <a:cxnSpLocks/>
+          </p:cNvCxnSpPr>
+          <p:nvPr/>
+        </p:nvCxnSpPr>
+        <p:spPr>
+          <a:xfrm flipV="1">
+            <a:off x="11367810" y="2873261"/>
+            <a:ext cx="3346028" cy="1452"/>
+          </a:xfrm>
+          <a:prstGeom prst="line">
+            <a:avLst/>
+          </a:prstGeom>
+          <a:ln>
+            <a:solidFill>
+              <a:schemeClr val="bg2">
+                <a:lumMod val="50000"/>
+              </a:schemeClr>
+            </a:solidFill>
+            <a:prstDash val="dash"/>
+          </a:ln>
+        </p:spPr>
+        <p:style>
+          <a:lnRef idx="2">
+            <a:schemeClr val="accent1"/>
+          </a:lnRef>
+          <a:fillRef idx="0">
+            <a:schemeClr val="accent1"/>
+          </a:fillRef>
+          <a:effectRef idx="1">
+            <a:schemeClr val="accent1"/>
+          </a:effectRef>
+          <a:fontRef idx="minor">
+            <a:schemeClr val="tx1"/>
+          </a:fontRef>
+        </p:style>
+      </p:cxnSp>
+      <p:sp>
+        <p:nvSpPr>
+          <p:cNvPr id="92" name="TextBox 91">
+            <a:extLst>
+              <a:ext uri="{FF2B5EF4-FFF2-40B4-BE49-F238E27FC236}">
+                <a16:creationId xmlns:a16="http://schemas.microsoft.com/office/drawing/2014/main" id="{E2E6B0D6-0853-99CC-3A5E-A134DBCEA3E0}"/>
+              </a:ext>
+            </a:extLst>
+          </p:cNvPr>
+          <p:cNvSpPr txBox="1"/>
+          <p:nvPr/>
+        </p:nvSpPr>
+        <p:spPr>
+          <a:xfrm>
+            <a:off x="10719041" y="489168"/>
+            <a:ext cx="3401961" cy="400110"/>
+          </a:xfrm>
+          <a:prstGeom prst="rect">
+            <a:avLst/>
+          </a:prstGeom>
+          <a:noFill/>
+        </p:spPr>
+        <p:txBody>
+          <a:bodyPr wrap="square" rtlCol="0">
+            <a:spAutoFit/>
+          </a:bodyPr>
+          <a:lstStyle/>
+          <a:p>
+            <a:r>
+              <a:rPr lang="en-US" sz="2000" dirty="0"/>
+              <a:t>General Response Layout</a:t>
+            </a:r>
+            <a:endParaRPr lang="nl-NL" sz="2000" dirty="0"/>
+          </a:p>
+        </p:txBody>
+      </p:sp>
+      <p:cxnSp>
+        <p:nvCxnSpPr>
+          <p:cNvPr id="98" name="Straight Connector 97">
+            <a:extLst>
+              <a:ext uri="{FF2B5EF4-FFF2-40B4-BE49-F238E27FC236}">
+                <a16:creationId xmlns:a16="http://schemas.microsoft.com/office/drawing/2014/main" id="{09D3CAE3-0031-276A-C969-B8A3FB781E33}"/>
+              </a:ext>
+            </a:extLst>
+          </p:cNvPr>
+          <p:cNvCxnSpPr>
+            <a:cxnSpLocks/>
+          </p:cNvCxnSpPr>
+          <p:nvPr/>
+        </p:nvCxnSpPr>
+        <p:spPr>
+          <a:xfrm flipV="1">
+            <a:off x="11367810" y="6306095"/>
+            <a:ext cx="3346028" cy="1452"/>
+          </a:xfrm>
+          <a:prstGeom prst="line">
+            <a:avLst/>
+          </a:prstGeom>
+          <a:ln>
+            <a:solidFill>
+              <a:schemeClr val="bg2">
+                <a:lumMod val="50000"/>
+              </a:schemeClr>
+            </a:solidFill>
+            <a:prstDash val="dash"/>
+          </a:ln>
+        </p:spPr>
+        <p:style>
+          <a:lnRef idx="2">
+            <a:schemeClr val="accent1"/>
+          </a:lnRef>
+          <a:fillRef idx="0">
+            <a:schemeClr val="accent1"/>
+          </a:fillRef>
+          <a:effectRef idx="1">
+            <a:schemeClr val="accent1"/>
+          </a:effectRef>
+          <a:fontRef idx="minor">
+            <a:schemeClr val="tx1"/>
+          </a:fontRef>
+        </p:style>
+      </p:cxnSp>
+      <p:cxnSp>
+        <p:nvCxnSpPr>
+          <p:cNvPr id="102" name="Straight Arrow Connector 101">
+            <a:extLst>
+              <a:ext uri="{FF2B5EF4-FFF2-40B4-BE49-F238E27FC236}">
+                <a16:creationId xmlns:a16="http://schemas.microsoft.com/office/drawing/2014/main" id="{421E2B2B-B7E5-F3EC-A00D-9DEE3EDBE648}"/>
+              </a:ext>
+            </a:extLst>
+          </p:cNvPr>
+          <p:cNvCxnSpPr>
+            <a:cxnSpLocks/>
+          </p:cNvCxnSpPr>
+          <p:nvPr/>
+        </p:nvCxnSpPr>
+        <p:spPr>
+          <a:xfrm flipV="1">
+            <a:off x="14750277" y="3964838"/>
+            <a:ext cx="312186" cy="110345"/>
+          </a:xfrm>
+          <a:prstGeom prst="straightConnector1">
+            <a:avLst/>
+          </a:prstGeom>
+          <a:ln>
+            <a:solidFill>
+              <a:srgbClr val="EC1CBF"/>
+            </a:solidFill>
+            <a:prstDash val="sysDash"/>
+            <a:tailEnd type="triangle"/>
+          </a:ln>
+        </p:spPr>
+        <p:style>
+          <a:lnRef idx="2">
+            <a:schemeClr val="accent1"/>
+          </a:lnRef>
+          <a:fillRef idx="0">
+            <a:schemeClr val="accent1"/>
+          </a:fillRef>
+          <a:effectRef idx="1">
+            <a:schemeClr val="accent1"/>
+          </a:effectRef>
+          <a:fontRef idx="minor">
+            <a:schemeClr val="tx1"/>
+          </a:fontRef>
+        </p:style>
+      </p:cxnSp>
+      <p:cxnSp>
+        <p:nvCxnSpPr>
+          <p:cNvPr id="103" name="Straight Arrow Connector 102">
+            <a:extLst>
+              <a:ext uri="{FF2B5EF4-FFF2-40B4-BE49-F238E27FC236}">
+                <a16:creationId xmlns:a16="http://schemas.microsoft.com/office/drawing/2014/main" id="{04295568-FCE5-1C9C-9A0E-A76D18A67700}"/>
+              </a:ext>
+            </a:extLst>
+          </p:cNvPr>
+          <p:cNvCxnSpPr>
+            <a:cxnSpLocks/>
+          </p:cNvCxnSpPr>
+          <p:nvPr/>
+        </p:nvCxnSpPr>
+        <p:spPr>
+          <a:xfrm>
+            <a:off x="14750277" y="4232124"/>
+            <a:ext cx="347501" cy="32137"/>
+          </a:xfrm>
+          <a:prstGeom prst="straightConnector1">
+            <a:avLst/>
+          </a:prstGeom>
+          <a:ln>
+            <a:solidFill>
+              <a:srgbClr val="EC1CBF"/>
+            </a:solidFill>
+            <a:prstDash val="sysDash"/>
+            <a:tailEnd type="triangle"/>
+          </a:ln>
+        </p:spPr>
+        <p:style>
+          <a:lnRef idx="2">
+            <a:schemeClr val="accent1"/>
+          </a:lnRef>
+          <a:fillRef idx="0">
+            <a:schemeClr val="accent1"/>
+          </a:fillRef>
+          <a:effectRef idx="1">
+            <a:schemeClr val="accent1"/>
+          </a:effectRef>
+          <a:fontRef idx="minor">
+            <a:schemeClr val="tx1"/>
+          </a:fontRef>
+        </p:style>
+      </p:cxnSp>
+      <p:cxnSp>
+        <p:nvCxnSpPr>
+          <p:cNvPr id="104" name="Straight Arrow Connector 103">
+            <a:extLst>
+              <a:ext uri="{FF2B5EF4-FFF2-40B4-BE49-F238E27FC236}">
+                <a16:creationId xmlns:a16="http://schemas.microsoft.com/office/drawing/2014/main" id="{F627D0FC-EEC7-357A-4897-00EE42C2B6F1}"/>
+              </a:ext>
+            </a:extLst>
+          </p:cNvPr>
+          <p:cNvCxnSpPr/>
+          <p:nvPr/>
+        </p:nvCxnSpPr>
+        <p:spPr>
+          <a:xfrm>
+            <a:off x="12238704" y="1966880"/>
+            <a:ext cx="0" cy="303474"/>
+          </a:xfrm>
+          <a:prstGeom prst="straightConnector1">
+            <a:avLst/>
+          </a:prstGeom>
+          <a:ln>
+            <a:tailEnd type="triangle"/>
+          </a:ln>
+        </p:spPr>
+        <p:style>
+          <a:lnRef idx="2">
+            <a:schemeClr val="accent1"/>
+          </a:lnRef>
+          <a:fillRef idx="0">
+            <a:schemeClr val="accent1"/>
+          </a:fillRef>
+          <a:effectRef idx="1">
+            <a:schemeClr val="accent1"/>
+          </a:effectRef>
+          <a:fontRef idx="minor">
+            <a:schemeClr val="tx1"/>
+          </a:fontRef>
+        </p:style>
+      </p:cxnSp>
+      <p:sp>
+        <p:nvSpPr>
+          <p:cNvPr id="105" name="TextBox 104">
+            <a:extLst>
+              <a:ext uri="{FF2B5EF4-FFF2-40B4-BE49-F238E27FC236}">
+                <a16:creationId xmlns:a16="http://schemas.microsoft.com/office/drawing/2014/main" id="{3E4D2E2C-43D4-6A78-B2B2-06DE85473F96}"/>
+              </a:ext>
+            </a:extLst>
+          </p:cNvPr>
+          <p:cNvSpPr txBox="1"/>
+          <p:nvPr/>
+        </p:nvSpPr>
+        <p:spPr>
+          <a:xfrm>
+            <a:off x="11504409" y="2271041"/>
+            <a:ext cx="3401961" cy="369332"/>
+          </a:xfrm>
+          <a:prstGeom prst="rect">
+            <a:avLst/>
+          </a:prstGeom>
+          <a:noFill/>
+        </p:spPr>
+        <p:txBody>
+          <a:bodyPr wrap="square" rtlCol="0">
+            <a:spAutoFit/>
+          </a:bodyPr>
+          <a:lstStyle/>
+          <a:p>
+            <a:r>
+              <a:rPr lang="en-US" dirty="0"/>
+              <a:t>Try to solve maze</a:t>
+            </a:r>
+            <a:endParaRPr lang="nl-NL" dirty="0"/>
+          </a:p>
+        </p:txBody>
+      </p:sp>
+      <p:sp>
+        <p:nvSpPr>
+          <p:cNvPr id="109" name="TextBox 108">
+            <a:extLst>
+              <a:ext uri="{FF2B5EF4-FFF2-40B4-BE49-F238E27FC236}">
+                <a16:creationId xmlns:a16="http://schemas.microsoft.com/office/drawing/2014/main" id="{F917C1F9-C3C3-2352-922F-B26257ACB2CF}"/>
+              </a:ext>
+            </a:extLst>
+          </p:cNvPr>
+          <p:cNvSpPr txBox="1"/>
+          <p:nvPr/>
+        </p:nvSpPr>
+        <p:spPr>
+          <a:xfrm>
+            <a:off x="2595869" y="1116451"/>
+            <a:ext cx="1823863" cy="369332"/>
+          </a:xfrm>
+          <a:prstGeom prst="rect">
+            <a:avLst/>
+          </a:prstGeom>
+          <a:noFill/>
+        </p:spPr>
+        <p:txBody>
+          <a:bodyPr wrap="square" rtlCol="0">
+            <a:spAutoFit/>
+          </a:bodyPr>
+          <a:lstStyle/>
+          <a:p>
+            <a:r>
+              <a:rPr lang="en-US" dirty="0"/>
+              <a:t>Introduce task</a:t>
+            </a:r>
+            <a:endParaRPr lang="nl-NL" dirty="0"/>
+          </a:p>
+        </p:txBody>
+      </p:sp>
+      <p:sp>
+        <p:nvSpPr>
+          <p:cNvPr id="110" name="TextBox 109">
+            <a:extLst>
+              <a:ext uri="{FF2B5EF4-FFF2-40B4-BE49-F238E27FC236}">
+                <a16:creationId xmlns:a16="http://schemas.microsoft.com/office/drawing/2014/main" id="{27B0120B-B053-D183-4C61-01C617DA060F}"/>
+              </a:ext>
+            </a:extLst>
+          </p:cNvPr>
+          <p:cNvSpPr txBox="1"/>
+          <p:nvPr/>
+        </p:nvSpPr>
+        <p:spPr>
+          <a:xfrm>
+            <a:off x="2565471" y="1768119"/>
+            <a:ext cx="3401961" cy="369332"/>
+          </a:xfrm>
+          <a:prstGeom prst="rect">
+            <a:avLst/>
+          </a:prstGeom>
+          <a:noFill/>
+        </p:spPr>
+        <p:txBody>
+          <a:bodyPr wrap="square" rtlCol="0">
+            <a:spAutoFit/>
+          </a:bodyPr>
+          <a:lstStyle/>
+          <a:p>
+            <a:r>
+              <a:rPr lang="en-US" dirty="0"/>
+              <a:t>Choose method</a:t>
+            </a:r>
+            <a:endParaRPr lang="nl-NL" dirty="0"/>
+          </a:p>
+        </p:txBody>
+      </p:sp>
+      <p:sp>
+        <p:nvSpPr>
+          <p:cNvPr id="111" name="TextBox 110">
+            <a:extLst>
+              <a:ext uri="{FF2B5EF4-FFF2-40B4-BE49-F238E27FC236}">
+                <a16:creationId xmlns:a16="http://schemas.microsoft.com/office/drawing/2014/main" id="{F26BBDAF-613B-CB3C-7A96-A2F82518DF45}"/>
+              </a:ext>
+            </a:extLst>
+          </p:cNvPr>
+          <p:cNvSpPr txBox="1"/>
+          <p:nvPr/>
+        </p:nvSpPr>
+        <p:spPr>
+          <a:xfrm>
+            <a:off x="2449601" y="3927781"/>
+            <a:ext cx="1854132" cy="369332"/>
+          </a:xfrm>
+          <a:prstGeom prst="rect">
+            <a:avLst/>
+          </a:prstGeom>
+          <a:noFill/>
+        </p:spPr>
+        <p:txBody>
+          <a:bodyPr wrap="square" rtlCol="0">
+            <a:spAutoFit/>
+          </a:bodyPr>
+          <a:lstStyle/>
+          <a:p>
+            <a:r>
+              <a:rPr lang="en-US" dirty="0"/>
+              <a:t>Change method</a:t>
+            </a:r>
+            <a:endParaRPr lang="nl-NL" dirty="0"/>
+          </a:p>
+        </p:txBody>
+      </p:sp>
+      <p:sp>
+        <p:nvSpPr>
+          <p:cNvPr id="112" name="TextBox 111">
+            <a:extLst>
+              <a:ext uri="{FF2B5EF4-FFF2-40B4-BE49-F238E27FC236}">
+                <a16:creationId xmlns:a16="http://schemas.microsoft.com/office/drawing/2014/main" id="{F0A50D87-5B30-4032-4543-36B8E6DA9992}"/>
+              </a:ext>
+            </a:extLst>
+          </p:cNvPr>
+          <p:cNvSpPr txBox="1"/>
+          <p:nvPr/>
+        </p:nvSpPr>
+        <p:spPr>
+          <a:xfrm>
+            <a:off x="5094522" y="3903037"/>
+            <a:ext cx="2425270" cy="646331"/>
+          </a:xfrm>
+          <a:prstGeom prst="rect">
+            <a:avLst/>
+          </a:prstGeom>
+          <a:noFill/>
+        </p:spPr>
+        <p:txBody>
+          <a:bodyPr wrap="square" rtlCol="0">
+            <a:spAutoFit/>
+          </a:bodyPr>
+          <a:lstStyle/>
+          <a:p>
+            <a:r>
+              <a:rPr lang="en-US" dirty="0"/>
+              <a:t>(Summarize)</a:t>
+            </a:r>
+          </a:p>
+          <a:p>
+            <a:r>
+              <a:rPr lang="en-US" dirty="0"/>
+              <a:t>Concluding remark</a:t>
+            </a:r>
+            <a:endParaRPr lang="nl-NL" dirty="0"/>
+          </a:p>
+        </p:txBody>
+      </p:sp>
+      <p:sp>
+        <p:nvSpPr>
+          <p:cNvPr id="115" name="TextBox 114">
+            <a:extLst>
+              <a:ext uri="{FF2B5EF4-FFF2-40B4-BE49-F238E27FC236}">
+                <a16:creationId xmlns:a16="http://schemas.microsoft.com/office/drawing/2014/main" id="{0D7A98F4-D3E6-20D8-E256-F8BF60C30AF0}"/>
+              </a:ext>
+            </a:extLst>
+          </p:cNvPr>
+          <p:cNvSpPr txBox="1"/>
+          <p:nvPr/>
+        </p:nvSpPr>
+        <p:spPr>
+          <a:xfrm>
+            <a:off x="2762097" y="4427347"/>
+            <a:ext cx="3039937" cy="1569660"/>
+          </a:xfrm>
+          <a:prstGeom prst="rect">
+            <a:avLst/>
+          </a:prstGeom>
+          <a:noFill/>
+        </p:spPr>
+        <p:txBody>
+          <a:bodyPr wrap="square" rtlCol="0">
+            <a:spAutoFit/>
+          </a:bodyPr>
+          <a:lstStyle/>
+          <a:p>
+            <a:r>
+              <a:rPr lang="en-US" sz="1600" b="1" dirty="0"/>
+              <a:t>Restart</a:t>
+            </a:r>
+            <a:endParaRPr lang="nl-NL" sz="1600" dirty="0"/>
+          </a:p>
+          <a:p>
+            <a:pPr marL="285750" indent="-285750">
+              <a:buFont typeface="Arial" panose="020B0604020202020204" pitchFamily="34" charset="0"/>
+              <a:buChar char="•"/>
+            </a:pPr>
+            <a:r>
+              <a:rPr lang="nl-NL" sz="1600" dirty="0" err="1"/>
+              <a:t>using</a:t>
+            </a:r>
+            <a:r>
+              <a:rPr lang="nl-NL" sz="1600" dirty="0"/>
+              <a:t> </a:t>
+            </a:r>
+            <a:r>
+              <a:rPr lang="nl-NL" sz="1600" dirty="0" err="1"/>
+              <a:t>the</a:t>
+            </a:r>
+            <a:r>
+              <a:rPr lang="nl-NL" sz="1600" dirty="0"/>
+              <a:t> </a:t>
+            </a:r>
+            <a:r>
+              <a:rPr lang="nl-NL" sz="1600" dirty="0" err="1"/>
+              <a:t>same</a:t>
+            </a:r>
+            <a:r>
+              <a:rPr lang="nl-NL" sz="1600" dirty="0"/>
+              <a:t> </a:t>
+            </a:r>
+            <a:r>
+              <a:rPr lang="nl-NL" sz="1600" dirty="0" err="1"/>
+              <a:t>method</a:t>
+            </a:r>
+            <a:endParaRPr lang="nl-NL" sz="1600" dirty="0"/>
+          </a:p>
+          <a:p>
+            <a:pPr marL="285750" indent="-285750">
+              <a:buFont typeface="Arial" panose="020B0604020202020204" pitchFamily="34" charset="0"/>
+              <a:buChar char="•"/>
+            </a:pPr>
+            <a:r>
+              <a:rPr lang="nl-NL" sz="1600" dirty="0" err="1"/>
+              <a:t>using</a:t>
+            </a:r>
+            <a:r>
+              <a:rPr lang="nl-NL" sz="1600" dirty="0"/>
+              <a:t> a different </a:t>
+            </a:r>
+            <a:r>
+              <a:rPr lang="nl-NL" sz="1600" dirty="0" err="1"/>
+              <a:t>method</a:t>
+            </a:r>
+            <a:r>
+              <a:rPr lang="nl-NL" sz="1600" dirty="0"/>
+              <a:t>:</a:t>
+            </a:r>
+          </a:p>
+          <a:p>
+            <a:pPr marL="742950" lvl="1" indent="-285750">
+              <a:buFont typeface="Arial" panose="020B0604020202020204" pitchFamily="34" charset="0"/>
+              <a:buChar char="•"/>
+            </a:pPr>
+            <a:r>
+              <a:rPr lang="nl-NL" sz="1600" b="1" dirty="0" err="1"/>
+              <a:t>algorithm</a:t>
+            </a:r>
+            <a:r>
+              <a:rPr lang="nl-NL" sz="1600" b="1" dirty="0"/>
+              <a:t>, heuristics, reverse search</a:t>
+            </a:r>
+          </a:p>
+          <a:p>
+            <a:pPr marL="285750" indent="-285750">
+              <a:buFontTx/>
+              <a:buChar char="-"/>
+            </a:pPr>
+            <a:endParaRPr lang="en-US" sz="1600" dirty="0"/>
+          </a:p>
+        </p:txBody>
+      </p:sp>
+      <p:cxnSp>
+        <p:nvCxnSpPr>
+          <p:cNvPr id="116" name="Straight Arrow Connector 115">
+            <a:extLst>
+              <a:ext uri="{FF2B5EF4-FFF2-40B4-BE49-F238E27FC236}">
+                <a16:creationId xmlns:a16="http://schemas.microsoft.com/office/drawing/2014/main" id="{4AB66E52-F556-7906-7EF6-077627E7A9E5}"/>
+              </a:ext>
+            </a:extLst>
+          </p:cNvPr>
+          <p:cNvCxnSpPr>
+            <a:cxnSpLocks/>
+          </p:cNvCxnSpPr>
+          <p:nvPr/>
+        </p:nvCxnSpPr>
+        <p:spPr>
+          <a:xfrm flipV="1">
+            <a:off x="4384417" y="1772407"/>
+            <a:ext cx="312186" cy="110345"/>
+          </a:xfrm>
+          <a:prstGeom prst="straightConnector1">
+            <a:avLst/>
+          </a:prstGeom>
+          <a:ln>
+            <a:solidFill>
+              <a:srgbClr val="EC1CBF"/>
+            </a:solidFill>
+            <a:prstDash val="sysDash"/>
+            <a:tailEnd type="triangle"/>
+          </a:ln>
+        </p:spPr>
+        <p:style>
+          <a:lnRef idx="2">
+            <a:schemeClr val="accent1"/>
+          </a:lnRef>
+          <a:fillRef idx="0">
+            <a:schemeClr val="accent1"/>
+          </a:fillRef>
+          <a:effectRef idx="1">
+            <a:schemeClr val="accent1"/>
+          </a:effectRef>
+          <a:fontRef idx="minor">
+            <a:schemeClr val="tx1"/>
+          </a:fontRef>
+        </p:style>
+      </p:cxnSp>
+      <p:cxnSp>
+        <p:nvCxnSpPr>
+          <p:cNvPr id="117" name="Straight Arrow Connector 116">
+            <a:extLst>
+              <a:ext uri="{FF2B5EF4-FFF2-40B4-BE49-F238E27FC236}">
+                <a16:creationId xmlns:a16="http://schemas.microsoft.com/office/drawing/2014/main" id="{BAB7E76F-8382-0E0E-C05F-D9ECD07DA3AA}"/>
+              </a:ext>
+            </a:extLst>
+          </p:cNvPr>
+          <p:cNvCxnSpPr>
+            <a:cxnSpLocks/>
+          </p:cNvCxnSpPr>
+          <p:nvPr/>
+        </p:nvCxnSpPr>
+        <p:spPr>
+          <a:xfrm>
+            <a:off x="4385067" y="2011081"/>
+            <a:ext cx="347501" cy="32137"/>
+          </a:xfrm>
+          <a:prstGeom prst="straightConnector1">
+            <a:avLst/>
+          </a:prstGeom>
+          <a:ln>
+            <a:solidFill>
+              <a:srgbClr val="EC1CBF"/>
+            </a:solidFill>
+            <a:prstDash val="sysDash"/>
+            <a:tailEnd type="triangle"/>
+          </a:ln>
+        </p:spPr>
+        <p:style>
+          <a:lnRef idx="2">
+            <a:schemeClr val="accent1"/>
+          </a:lnRef>
+          <a:fillRef idx="0">
+            <a:schemeClr val="accent1"/>
+          </a:fillRef>
+          <a:effectRef idx="1">
+            <a:schemeClr val="accent1"/>
+          </a:effectRef>
+          <a:fontRef idx="minor">
+            <a:schemeClr val="tx1"/>
+          </a:fontRef>
+        </p:style>
+      </p:cxnSp>
+      <p:sp>
+        <p:nvSpPr>
+          <p:cNvPr id="118" name="TextBox 117">
+            <a:extLst>
+              <a:ext uri="{FF2B5EF4-FFF2-40B4-BE49-F238E27FC236}">
+                <a16:creationId xmlns:a16="http://schemas.microsoft.com/office/drawing/2014/main" id="{55B27615-5601-4E21-CD5B-C7E2230102EE}"/>
+              </a:ext>
+            </a:extLst>
+          </p:cNvPr>
+          <p:cNvSpPr txBox="1"/>
+          <p:nvPr/>
+        </p:nvSpPr>
+        <p:spPr>
+          <a:xfrm>
+            <a:off x="4676917" y="1589325"/>
+            <a:ext cx="1838632" cy="338554"/>
+          </a:xfrm>
+          <a:prstGeom prst="rect">
+            <a:avLst/>
+          </a:prstGeom>
+          <a:noFill/>
+        </p:spPr>
+        <p:txBody>
+          <a:bodyPr wrap="square" rtlCol="0">
+            <a:spAutoFit/>
+          </a:bodyPr>
+          <a:lstStyle/>
+          <a:p>
+            <a:r>
+              <a:rPr lang="en-US" sz="1600" b="1" dirty="0"/>
+              <a:t>Algorithm</a:t>
+            </a:r>
+            <a:endParaRPr lang="nl-NL" sz="1600" b="1" dirty="0"/>
+          </a:p>
+        </p:txBody>
+      </p:sp>
+      <p:sp>
+        <p:nvSpPr>
+          <p:cNvPr id="119" name="TextBox 118">
+            <a:extLst>
+              <a:ext uri="{FF2B5EF4-FFF2-40B4-BE49-F238E27FC236}">
+                <a16:creationId xmlns:a16="http://schemas.microsoft.com/office/drawing/2014/main" id="{FE7B2657-CBE5-2B81-6E63-3160A24730C3}"/>
+              </a:ext>
+            </a:extLst>
+          </p:cNvPr>
+          <p:cNvSpPr txBox="1"/>
+          <p:nvPr/>
+        </p:nvSpPr>
+        <p:spPr>
+          <a:xfrm>
+            <a:off x="4702689" y="1895201"/>
+            <a:ext cx="1759975" cy="338554"/>
+          </a:xfrm>
+          <a:prstGeom prst="rect">
+            <a:avLst/>
+          </a:prstGeom>
+          <a:noFill/>
+        </p:spPr>
+        <p:txBody>
+          <a:bodyPr wrap="square" rtlCol="0">
+            <a:spAutoFit/>
+          </a:bodyPr>
+          <a:lstStyle/>
+          <a:p>
+            <a:r>
+              <a:rPr lang="en-US" sz="1600" b="1" dirty="0"/>
+              <a:t>Heuristics</a:t>
+            </a:r>
+            <a:endParaRPr lang="nl-NL" sz="1600" b="1" dirty="0"/>
+          </a:p>
+        </p:txBody>
+      </p:sp>
+      <p:cxnSp>
+        <p:nvCxnSpPr>
+          <p:cNvPr id="120" name="Straight Arrow Connector 119">
+            <a:extLst>
+              <a:ext uri="{FF2B5EF4-FFF2-40B4-BE49-F238E27FC236}">
+                <a16:creationId xmlns:a16="http://schemas.microsoft.com/office/drawing/2014/main" id="{5BAD2900-7CAA-1D12-2C43-0019C8EE405E}"/>
+              </a:ext>
+            </a:extLst>
+          </p:cNvPr>
+          <p:cNvCxnSpPr/>
+          <p:nvPr/>
+        </p:nvCxnSpPr>
+        <p:spPr>
+          <a:xfrm>
+            <a:off x="3326479" y="1485783"/>
+            <a:ext cx="0" cy="303474"/>
+          </a:xfrm>
+          <a:prstGeom prst="straightConnector1">
+            <a:avLst/>
+          </a:prstGeom>
+          <a:ln>
+            <a:solidFill>
+              <a:schemeClr val="tx2">
+                <a:lumMod val="50000"/>
+                <a:lumOff val="50000"/>
+              </a:schemeClr>
+            </a:solidFill>
+            <a:tailEnd type="triangle"/>
+          </a:ln>
+        </p:spPr>
+        <p:style>
+          <a:lnRef idx="2">
+            <a:schemeClr val="accent1"/>
+          </a:lnRef>
+          <a:fillRef idx="0">
+            <a:schemeClr val="accent1"/>
+          </a:fillRef>
+          <a:effectRef idx="1">
+            <a:schemeClr val="accent1"/>
+          </a:effectRef>
+          <a:fontRef idx="minor">
+            <a:schemeClr val="tx1"/>
+          </a:fontRef>
+        </p:style>
+      </p:cxnSp>
+      <p:sp>
+        <p:nvSpPr>
+          <p:cNvPr id="122" name="Rectangle 121">
+            <a:extLst>
+              <a:ext uri="{FF2B5EF4-FFF2-40B4-BE49-F238E27FC236}">
+                <a16:creationId xmlns:a16="http://schemas.microsoft.com/office/drawing/2014/main" id="{EB1A3F24-AE84-A99F-FF8F-809AFBA46BF4}"/>
+              </a:ext>
+            </a:extLst>
+          </p:cNvPr>
+          <p:cNvSpPr/>
+          <p:nvPr/>
+        </p:nvSpPr>
+        <p:spPr>
+          <a:xfrm>
+            <a:off x="3493574" y="3491038"/>
+            <a:ext cx="922695" cy="369332"/>
+          </a:xfrm>
+          <a:prstGeom prst="rect">
+            <a:avLst/>
+          </a:prstGeom>
+        </p:spPr>
+        <p:style>
+          <a:lnRef idx="2">
+            <a:schemeClr val="accent6"/>
+          </a:lnRef>
+          <a:fillRef idx="1">
+            <a:schemeClr val="lt1"/>
+          </a:fillRef>
+          <a:effectRef idx="0">
+            <a:schemeClr val="accent6"/>
+          </a:effectRef>
+          <a:fontRef idx="minor">
+            <a:schemeClr val="dk1"/>
+          </a:fontRef>
+        </p:style>
+        <p:txBody>
+          <a:bodyPr rtlCol="0" anchor="ctr"/>
+          <a:lstStyle/>
+          <a:p>
+            <a:pPr algn="ctr"/>
+            <a:r>
+              <a:rPr lang="en-US" sz="1200" dirty="0"/>
+              <a:t>If struggling</a:t>
+            </a:r>
+            <a:endParaRPr lang="nl-NL" sz="1200" dirty="0"/>
+          </a:p>
+        </p:txBody>
+      </p:sp>
+      <p:sp>
+        <p:nvSpPr>
+          <p:cNvPr id="123" name="Rectangle 122">
+            <a:extLst>
+              <a:ext uri="{FF2B5EF4-FFF2-40B4-BE49-F238E27FC236}">
+                <a16:creationId xmlns:a16="http://schemas.microsoft.com/office/drawing/2014/main" id="{BACA42D8-2F3E-FD0E-9940-92297EDCE839}"/>
+              </a:ext>
+            </a:extLst>
+          </p:cNvPr>
+          <p:cNvSpPr/>
+          <p:nvPr/>
+        </p:nvSpPr>
+        <p:spPr>
+          <a:xfrm>
+            <a:off x="4818833" y="3491375"/>
+            <a:ext cx="983201" cy="369332"/>
+          </a:xfrm>
+          <a:prstGeom prst="rect">
+            <a:avLst/>
+          </a:prstGeom>
+        </p:spPr>
+        <p:style>
+          <a:lnRef idx="2">
+            <a:schemeClr val="accent6"/>
+          </a:lnRef>
+          <a:fillRef idx="1">
+            <a:schemeClr val="lt1"/>
+          </a:fillRef>
+          <a:effectRef idx="0">
+            <a:schemeClr val="accent6"/>
+          </a:effectRef>
+          <a:fontRef idx="minor">
+            <a:schemeClr val="dk1"/>
+          </a:fontRef>
+        </p:style>
+        <p:txBody>
+          <a:bodyPr rtlCol="0" anchor="ctr"/>
+          <a:lstStyle/>
+          <a:p>
+            <a:pPr algn="ctr"/>
+            <a:r>
+              <a:rPr lang="en-US" sz="1200" dirty="0"/>
+              <a:t>If not struggling</a:t>
+            </a:r>
+            <a:endParaRPr lang="nl-NL" sz="1200" dirty="0"/>
+          </a:p>
+        </p:txBody>
+      </p:sp>
+      <p:sp>
+        <p:nvSpPr>
+          <p:cNvPr id="127" name="TextBox 126">
+            <a:extLst>
+              <a:ext uri="{FF2B5EF4-FFF2-40B4-BE49-F238E27FC236}">
+                <a16:creationId xmlns:a16="http://schemas.microsoft.com/office/drawing/2014/main" id="{CADCF4E4-C037-02DD-9336-467A9F5B8C98}"/>
+              </a:ext>
+            </a:extLst>
+          </p:cNvPr>
+          <p:cNvSpPr txBox="1"/>
+          <p:nvPr/>
+        </p:nvSpPr>
+        <p:spPr>
+          <a:xfrm>
+            <a:off x="2023222" y="641568"/>
+            <a:ext cx="3401961" cy="400110"/>
+          </a:xfrm>
+          <a:prstGeom prst="rect">
+            <a:avLst/>
+          </a:prstGeom>
+          <a:noFill/>
+        </p:spPr>
+        <p:txBody>
+          <a:bodyPr wrap="square" rtlCol="0">
+            <a:spAutoFit/>
+          </a:bodyPr>
+          <a:lstStyle/>
+          <a:p>
+            <a:r>
+              <a:rPr lang="en-US" sz="2000" dirty="0"/>
+              <a:t>General Reasoning Process</a:t>
+            </a:r>
+            <a:endParaRPr lang="nl-NL" sz="2000" dirty="0"/>
+          </a:p>
+        </p:txBody>
+      </p:sp>
+      <p:cxnSp>
+        <p:nvCxnSpPr>
+          <p:cNvPr id="130" name="Straight Arrow Connector 129">
+            <a:extLst>
+              <a:ext uri="{FF2B5EF4-FFF2-40B4-BE49-F238E27FC236}">
+                <a16:creationId xmlns:a16="http://schemas.microsoft.com/office/drawing/2014/main" id="{D7F4FE8D-D7ED-AEB2-45D4-9C2A28EF31DA}"/>
+              </a:ext>
+            </a:extLst>
+          </p:cNvPr>
+          <p:cNvCxnSpPr>
+            <a:cxnSpLocks/>
+          </p:cNvCxnSpPr>
+          <p:nvPr/>
+        </p:nvCxnSpPr>
+        <p:spPr>
+          <a:xfrm>
+            <a:off x="3258906" y="4230063"/>
+            <a:ext cx="0" cy="207560"/>
+          </a:xfrm>
+          <a:prstGeom prst="straightConnector1">
+            <a:avLst/>
+          </a:prstGeom>
+          <a:ln>
+            <a:solidFill>
+              <a:srgbClr val="EC1CBF"/>
+            </a:solidFill>
+            <a:prstDash val="sysDash"/>
+            <a:tailEnd type="triangle"/>
+          </a:ln>
+        </p:spPr>
+        <p:style>
+          <a:lnRef idx="2">
+            <a:schemeClr val="accent1"/>
+          </a:lnRef>
+          <a:fillRef idx="0">
+            <a:schemeClr val="accent1"/>
+          </a:fillRef>
+          <a:effectRef idx="1">
+            <a:schemeClr val="accent1"/>
+          </a:effectRef>
+          <a:fontRef idx="minor">
+            <a:schemeClr val="tx1"/>
+          </a:fontRef>
+        </p:style>
+      </p:cxnSp>
+      <p:sp>
+        <p:nvSpPr>
+          <p:cNvPr id="132" name="TextBox 131">
+            <a:extLst>
+              <a:ext uri="{FF2B5EF4-FFF2-40B4-BE49-F238E27FC236}">
+                <a16:creationId xmlns:a16="http://schemas.microsoft.com/office/drawing/2014/main" id="{4CF9E22C-BE58-F748-3643-43076D6F080C}"/>
+              </a:ext>
+            </a:extLst>
+          </p:cNvPr>
+          <p:cNvSpPr txBox="1"/>
+          <p:nvPr/>
+        </p:nvSpPr>
+        <p:spPr>
+          <a:xfrm>
+            <a:off x="2409849" y="2512611"/>
+            <a:ext cx="1893884" cy="369332"/>
+          </a:xfrm>
+          <a:prstGeom prst="rect">
+            <a:avLst/>
+          </a:prstGeom>
+          <a:noFill/>
+        </p:spPr>
+        <p:txBody>
+          <a:bodyPr wrap="square" rtlCol="0">
+            <a:spAutoFit/>
+          </a:bodyPr>
+          <a:lstStyle/>
+          <a:p>
+            <a:r>
+              <a:rPr lang="en-US" dirty="0"/>
+              <a:t>Try to solve maze</a:t>
+            </a:r>
+            <a:endParaRPr lang="nl-NL" dirty="0"/>
+          </a:p>
+        </p:txBody>
+      </p:sp>
+      <p:sp>
+        <p:nvSpPr>
+          <p:cNvPr id="136" name="Arc 135">
+            <a:extLst>
+              <a:ext uri="{FF2B5EF4-FFF2-40B4-BE49-F238E27FC236}">
+                <a16:creationId xmlns:a16="http://schemas.microsoft.com/office/drawing/2014/main" id="{60CBC753-B7F5-5696-CEF8-C6DECC0FFEFF}"/>
+              </a:ext>
+            </a:extLst>
+          </p:cNvPr>
+          <p:cNvSpPr/>
+          <p:nvPr/>
+        </p:nvSpPr>
+        <p:spPr>
+          <a:xfrm>
+            <a:off x="3839569" y="2708210"/>
+            <a:ext cx="776154" cy="1336826"/>
+          </a:xfrm>
+          <a:prstGeom prst="arc">
+            <a:avLst>
+              <a:gd name="adj1" fmla="val 16200000"/>
+              <a:gd name="adj2" fmla="val 5307480"/>
+            </a:avLst>
+          </a:prstGeom>
+          <a:ln w="19050" cap="flat" cmpd="sng" algn="ctr">
+            <a:solidFill>
+              <a:schemeClr val="accent4"/>
+            </a:solidFill>
+            <a:prstDash val="solid"/>
+            <a:round/>
+            <a:headEnd type="none" w="med" len="med"/>
+            <a:tailEnd type="arrow" w="med" len="med"/>
+          </a:ln>
+        </p:spPr>
+        <p:style>
+          <a:lnRef idx="0">
+            <a:scrgbClr r="0" g="0" b="0"/>
+          </a:lnRef>
+          <a:fillRef idx="0">
+            <a:scrgbClr r="0" g="0" b="0"/>
+          </a:fillRef>
+          <a:effectRef idx="0">
+            <a:scrgbClr r="0" g="0" b="0"/>
+          </a:effectRef>
+          <a:fontRef idx="minor">
+            <a:schemeClr val="tx1"/>
+          </a:fontRef>
+        </p:style>
+        <p:txBody>
+          <a:bodyPr rtlCol="0" anchor="ctr"/>
+          <a:lstStyle/>
+          <a:p>
+            <a:pPr algn="ctr"/>
+            <a:endParaRPr lang="nl-NL"/>
+          </a:p>
+        </p:txBody>
+      </p:sp>
+      <p:sp>
+        <p:nvSpPr>
+          <p:cNvPr id="137" name="Arc 136">
+            <a:extLst>
+              <a:ext uri="{FF2B5EF4-FFF2-40B4-BE49-F238E27FC236}">
+                <a16:creationId xmlns:a16="http://schemas.microsoft.com/office/drawing/2014/main" id="{909ECA68-959D-5831-4076-FCBB6D76866E}"/>
+              </a:ext>
+            </a:extLst>
+          </p:cNvPr>
+          <p:cNvSpPr/>
+          <p:nvPr/>
+        </p:nvSpPr>
+        <p:spPr>
+          <a:xfrm>
+            <a:off x="2058383" y="2762177"/>
+            <a:ext cx="776154" cy="1336826"/>
+          </a:xfrm>
+          <a:prstGeom prst="arc">
+            <a:avLst>
+              <a:gd name="adj1" fmla="val 5400000"/>
+              <a:gd name="adj2" fmla="val 15922600"/>
+            </a:avLst>
+          </a:prstGeom>
+          <a:ln w="19050" cap="flat" cmpd="sng" algn="ctr">
+            <a:solidFill>
+              <a:schemeClr val="accent4"/>
+            </a:solidFill>
+            <a:prstDash val="solid"/>
+            <a:round/>
+            <a:headEnd type="none" w="med" len="med"/>
+            <a:tailEnd type="arrow" w="med" len="med"/>
+          </a:ln>
+        </p:spPr>
+        <p:style>
+          <a:lnRef idx="0">
+            <a:scrgbClr r="0" g="0" b="0"/>
+          </a:lnRef>
+          <a:fillRef idx="0">
+            <a:scrgbClr r="0" g="0" b="0"/>
+          </a:fillRef>
+          <a:effectRef idx="0">
+            <a:scrgbClr r="0" g="0" b="0"/>
+          </a:effectRef>
+          <a:fontRef idx="minor">
+            <a:schemeClr val="tx1"/>
+          </a:fontRef>
+        </p:style>
+        <p:txBody>
+          <a:bodyPr rtlCol="0" anchor="ctr"/>
+          <a:lstStyle/>
+          <a:p>
+            <a:pPr algn="ctr"/>
+            <a:endParaRPr lang="nl-NL"/>
+          </a:p>
+        </p:txBody>
+      </p:sp>
+      <p:cxnSp>
+        <p:nvCxnSpPr>
+          <p:cNvPr id="143" name="Straight Arrow Connector 142">
+            <a:extLst>
+              <a:ext uri="{FF2B5EF4-FFF2-40B4-BE49-F238E27FC236}">
+                <a16:creationId xmlns:a16="http://schemas.microsoft.com/office/drawing/2014/main" id="{82DAF8EB-A704-3794-7612-04BCD59B4A9D}"/>
+              </a:ext>
+            </a:extLst>
+          </p:cNvPr>
+          <p:cNvCxnSpPr/>
+          <p:nvPr/>
+        </p:nvCxnSpPr>
+        <p:spPr>
+          <a:xfrm>
+            <a:off x="3347783" y="2168637"/>
+            <a:ext cx="0" cy="303474"/>
+          </a:xfrm>
+          <a:prstGeom prst="straightConnector1">
+            <a:avLst/>
+          </a:prstGeom>
+          <a:ln>
+            <a:solidFill>
+              <a:schemeClr val="tx2">
+                <a:lumMod val="50000"/>
+                <a:lumOff val="50000"/>
+              </a:schemeClr>
+            </a:solidFill>
+            <a:tailEnd type="triangle"/>
+          </a:ln>
+        </p:spPr>
+        <p:style>
+          <a:lnRef idx="2">
+            <a:schemeClr val="accent1"/>
+          </a:lnRef>
+          <a:fillRef idx="0">
+            <a:schemeClr val="accent1"/>
+          </a:fillRef>
+          <a:effectRef idx="1">
+            <a:schemeClr val="accent1"/>
+          </a:effectRef>
+          <a:fontRef idx="minor">
+            <a:schemeClr val="tx1"/>
+          </a:fontRef>
+        </p:style>
+      </p:cxnSp>
+      <p:sp>
+        <p:nvSpPr>
+          <p:cNvPr id="144" name="Arc 143">
+            <a:extLst>
+              <a:ext uri="{FF2B5EF4-FFF2-40B4-BE49-F238E27FC236}">
+                <a16:creationId xmlns:a16="http://schemas.microsoft.com/office/drawing/2014/main" id="{7EAD75FF-161A-F81D-02C3-EF4FB219F240}"/>
+              </a:ext>
+            </a:extLst>
+          </p:cNvPr>
+          <p:cNvSpPr/>
+          <p:nvPr/>
+        </p:nvSpPr>
+        <p:spPr>
+          <a:xfrm flipH="1">
+            <a:off x="4615721" y="2708211"/>
+            <a:ext cx="875701" cy="1337704"/>
+          </a:xfrm>
+          <a:prstGeom prst="arc">
+            <a:avLst>
+              <a:gd name="adj1" fmla="val 21551687"/>
+              <a:gd name="adj2" fmla="val 5180967"/>
+            </a:avLst>
+          </a:prstGeom>
+          <a:ln w="19050" cap="flat" cmpd="sng" algn="ctr">
+            <a:solidFill>
+              <a:schemeClr val="accent4"/>
+            </a:solidFill>
+            <a:prstDash val="solid"/>
+            <a:round/>
+            <a:headEnd type="none" w="med" len="med"/>
+            <a:tailEnd type="arrow" w="med" len="med"/>
+          </a:ln>
+        </p:spPr>
+        <p:style>
+          <a:lnRef idx="0">
+            <a:scrgbClr r="0" g="0" b="0"/>
+          </a:lnRef>
+          <a:fillRef idx="0">
+            <a:scrgbClr r="0" g="0" b="0"/>
+          </a:fillRef>
+          <a:effectRef idx="0">
+            <a:scrgbClr r="0" g="0" b="0"/>
+          </a:effectRef>
+          <a:fontRef idx="minor">
+            <a:schemeClr val="tx1"/>
+          </a:fontRef>
+        </p:style>
+        <p:txBody>
+          <a:bodyPr rtlCol="0" anchor="ctr"/>
+          <a:lstStyle/>
+          <a:p>
+            <a:pPr algn="ctr"/>
+            <a:endParaRPr lang="nl-NL"/>
+          </a:p>
+        </p:txBody>
+      </p:sp>
+      <p:sp>
+        <p:nvSpPr>
+          <p:cNvPr id="145" name="Left Brace 144">
+            <a:extLst>
+              <a:ext uri="{FF2B5EF4-FFF2-40B4-BE49-F238E27FC236}">
+                <a16:creationId xmlns:a16="http://schemas.microsoft.com/office/drawing/2014/main" id="{88ADAC49-B5FB-CF1A-7E4A-2E59E6BD1D2D}"/>
+              </a:ext>
+            </a:extLst>
+          </p:cNvPr>
+          <p:cNvSpPr/>
+          <p:nvPr/>
+        </p:nvSpPr>
+        <p:spPr>
+          <a:xfrm>
+            <a:off x="1470576" y="2546946"/>
+            <a:ext cx="538485" cy="3163704"/>
+          </a:xfrm>
+          <a:prstGeom prst="leftBrace">
+            <a:avLst>
+              <a:gd name="adj1" fmla="val 30914"/>
+              <a:gd name="adj2" fmla="val 50683"/>
+            </a:avLst>
+          </a:prstGeom>
+          <a:ln>
+            <a:solidFill>
+              <a:schemeClr val="bg2">
+                <a:lumMod val="50000"/>
+              </a:schemeClr>
+            </a:solidFill>
+          </a:ln>
+        </p:spPr>
+        <p:style>
+          <a:lnRef idx="2">
+            <a:schemeClr val="accent1"/>
+          </a:lnRef>
+          <a:fillRef idx="0">
+            <a:schemeClr val="accent1"/>
+          </a:fillRef>
+          <a:effectRef idx="1">
+            <a:schemeClr val="accent1"/>
+          </a:effectRef>
+          <a:fontRef idx="minor">
+            <a:schemeClr val="tx1"/>
+          </a:fontRef>
+        </p:style>
+        <p:txBody>
+          <a:bodyPr rtlCol="0" anchor="ctr"/>
+          <a:lstStyle/>
+          <a:p>
+            <a:pPr algn="ctr"/>
+            <a:endParaRPr lang="nl-NL"/>
+          </a:p>
+        </p:txBody>
+      </p:sp>
+      <p:sp>
+        <p:nvSpPr>
+          <p:cNvPr id="146" name="TextBox 145">
+            <a:extLst>
+              <a:ext uri="{FF2B5EF4-FFF2-40B4-BE49-F238E27FC236}">
+                <a16:creationId xmlns:a16="http://schemas.microsoft.com/office/drawing/2014/main" id="{C0E25092-2AF0-22F6-1FF6-F0182CBCC01D}"/>
+              </a:ext>
+            </a:extLst>
+          </p:cNvPr>
+          <p:cNvSpPr txBox="1"/>
+          <p:nvPr/>
+        </p:nvSpPr>
+        <p:spPr>
+          <a:xfrm>
+            <a:off x="294596" y="3155736"/>
+            <a:ext cx="1838632" cy="923330"/>
+          </a:xfrm>
+          <a:prstGeom prst="rect">
+            <a:avLst/>
+          </a:prstGeom>
+          <a:noFill/>
+        </p:spPr>
+        <p:txBody>
+          <a:bodyPr wrap="square" rtlCol="0">
+            <a:spAutoFit/>
+          </a:bodyPr>
+          <a:lstStyle/>
+          <a:p>
+            <a:r>
+              <a:rPr lang="en-US" dirty="0"/>
+              <a:t>Language expressing </a:t>
+            </a:r>
+            <a:r>
+              <a:rPr lang="en-US" b="1" dirty="0"/>
+              <a:t>frustration</a:t>
+            </a:r>
+            <a:endParaRPr lang="nl-NL" b="1" dirty="0"/>
+          </a:p>
+        </p:txBody>
+      </p:sp>
+      <p:cxnSp>
+        <p:nvCxnSpPr>
+          <p:cNvPr id="147" name="Straight Connector 146">
+            <a:extLst>
+              <a:ext uri="{FF2B5EF4-FFF2-40B4-BE49-F238E27FC236}">
+                <a16:creationId xmlns:a16="http://schemas.microsoft.com/office/drawing/2014/main" id="{71003106-49BB-AC9F-2ACD-C7603EC4AC01}"/>
+              </a:ext>
+            </a:extLst>
+          </p:cNvPr>
+          <p:cNvCxnSpPr>
+            <a:cxnSpLocks/>
+          </p:cNvCxnSpPr>
+          <p:nvPr/>
+        </p:nvCxnSpPr>
+        <p:spPr>
+          <a:xfrm>
+            <a:off x="2046471" y="2548398"/>
+            <a:ext cx="4925829" cy="28571"/>
+          </a:xfrm>
+          <a:prstGeom prst="line">
+            <a:avLst/>
+          </a:prstGeom>
+          <a:ln>
+            <a:solidFill>
+              <a:schemeClr val="bg2">
+                <a:lumMod val="50000"/>
+              </a:schemeClr>
+            </a:solidFill>
+            <a:prstDash val="dash"/>
+          </a:ln>
+        </p:spPr>
+        <p:style>
+          <a:lnRef idx="2">
+            <a:schemeClr val="accent1"/>
+          </a:lnRef>
+          <a:fillRef idx="0">
+            <a:schemeClr val="accent1"/>
+          </a:fillRef>
+          <a:effectRef idx="1">
+            <a:schemeClr val="accent1"/>
+          </a:effectRef>
+          <a:fontRef idx="minor">
+            <a:schemeClr val="tx1"/>
+          </a:fontRef>
+        </p:style>
+      </p:cxnSp>
+      <p:cxnSp>
+        <p:nvCxnSpPr>
+          <p:cNvPr id="148" name="Straight Connector 147">
+            <a:extLst>
+              <a:ext uri="{FF2B5EF4-FFF2-40B4-BE49-F238E27FC236}">
+                <a16:creationId xmlns:a16="http://schemas.microsoft.com/office/drawing/2014/main" id="{0D8AB1CF-CB8C-3964-CFCF-893ABC60F766}"/>
+              </a:ext>
+            </a:extLst>
+          </p:cNvPr>
+          <p:cNvCxnSpPr>
+            <a:cxnSpLocks/>
+          </p:cNvCxnSpPr>
+          <p:nvPr/>
+        </p:nvCxnSpPr>
+        <p:spPr>
+          <a:xfrm>
+            <a:off x="2058383" y="5710650"/>
+            <a:ext cx="4875907" cy="12536"/>
+          </a:xfrm>
+          <a:prstGeom prst="line">
+            <a:avLst/>
+          </a:prstGeom>
+          <a:ln>
+            <a:solidFill>
+              <a:schemeClr val="bg2">
+                <a:lumMod val="50000"/>
+              </a:schemeClr>
+            </a:solidFill>
+            <a:prstDash val="dash"/>
+          </a:ln>
+        </p:spPr>
+        <p:style>
+          <a:lnRef idx="2">
+            <a:schemeClr val="accent1"/>
+          </a:lnRef>
+          <a:fillRef idx="0">
+            <a:schemeClr val="accent1"/>
+          </a:fillRef>
+          <a:effectRef idx="1">
+            <a:schemeClr val="accent1"/>
+          </a:effectRef>
+          <a:fontRef idx="minor">
+            <a:schemeClr val="tx1"/>
+          </a:fontRef>
+        </p:style>
+      </p:cxnSp>
+    </p:spTree>
+    <p:extLst>
+      <p:ext uri="{BB962C8B-B14F-4D97-AF65-F5344CB8AC3E}">
+        <p14:creationId xmlns:p14="http://schemas.microsoft.com/office/powerpoint/2010/main" val="3532999483"/>
+      </p:ext>
+    </p:extLst>
+  </p:cSld>
+  <p:clrMapOvr>
+    <a:masterClrMapping/>
+  </p:clrMapOvr>
+</p:sld>
+</file>
+
+<file path=ppt/slides/slide3.xml><?xml version="1.0" encoding="utf-8"?>
+<p:sld xmlns:a="http://schemas.openxmlformats.org/drawingml/2006/main" xmlns:r="http://schemas.openxmlformats.org/officeDocument/2006/relationships" xmlns:p="http://schemas.openxmlformats.org/presentationml/2006/main">
+  <p:cSld>
+    <p:spTree>
+      <p:nvGrpSpPr>
+        <p:cNvPr id="1" name=""/>
+        <p:cNvGrpSpPr/>
+        <p:nvPr/>
+      </p:nvGrpSpPr>
+      <p:grpSpPr>
+        <a:xfrm>
+          <a:off x="0" y="0"/>
+          <a:ext cx="0" cy="0"/>
+          <a:chOff x="0" y="0"/>
+          <a:chExt cx="0" cy="0"/>
+        </a:xfrm>
+      </p:grpSpPr>
+      <p:sp>
+        <p:nvSpPr>
           <p:cNvPr id="5" name="TextBox 4">
             <a:extLst>
               <a:ext uri="{FF2B5EF4-FFF2-40B4-BE49-F238E27FC236}">
@@ -5742,7 +7919,7 @@
 </p:sld>
 </file>
 
-<file path=ppt/slides/slide3.xml><?xml version="1.0" encoding="utf-8"?>
+<file path=ppt/slides/slide4.xml><?xml version="1.0" encoding="utf-8"?>
 <p:sld xmlns:a="http://schemas.openxmlformats.org/drawingml/2006/main" xmlns:r="http://schemas.openxmlformats.org/officeDocument/2006/relationships" xmlns:p="http://schemas.openxmlformats.org/presentationml/2006/main">
   <p:cSld>
     <p:spTree>
@@ -6526,7 +8703,7 @@
 </p:sld>
 </file>
 
-<file path=ppt/slides/slide4.xml><?xml version="1.0" encoding="utf-8"?>
+<file path=ppt/slides/slide5.xml><?xml version="1.0" encoding="utf-8"?>
 <p:sld xmlns:a="http://schemas.openxmlformats.org/drawingml/2006/main" xmlns:r="http://schemas.openxmlformats.org/officeDocument/2006/relationships" xmlns:p="http://schemas.openxmlformats.org/presentationml/2006/main">
   <p:cSld>
     <p:spTree>
@@ -7265,7 +9442,7 @@
 </p:sld>
 </file>
 
-<file path=ppt/slides/slide5.xml><?xml version="1.0" encoding="utf-8"?>
+<file path=ppt/slides/slide6.xml><?xml version="1.0" encoding="utf-8"?>
 <p:sld xmlns:a="http://schemas.openxmlformats.org/drawingml/2006/main" xmlns:r="http://schemas.openxmlformats.org/officeDocument/2006/relationships" xmlns:p="http://schemas.openxmlformats.org/presentationml/2006/main">
   <p:cSld>
     <p:spTree>
@@ -9342,7 +11519,7 @@
 </p:sld>
 </file>
 
-<file path=ppt/slides/slide6.xml><?xml version="1.0" encoding="utf-8"?>
+<file path=ppt/slides/slide7.xml><?xml version="1.0" encoding="utf-8"?>
 <p:sld xmlns:a="http://schemas.openxmlformats.org/drawingml/2006/main" xmlns:r="http://schemas.openxmlformats.org/officeDocument/2006/relationships" xmlns:p="http://schemas.openxmlformats.org/presentationml/2006/main">
   <p:cSld>
     <p:spTree>
@@ -11402,7 +13579,7 @@
 </p:sld>
 </file>
 
-<file path=ppt/slides/slide7.xml><?xml version="1.0" encoding="utf-8"?>
+<file path=ppt/slides/slide8.xml><?xml version="1.0" encoding="utf-8"?>
 <p:sld xmlns:a="http://schemas.openxmlformats.org/drawingml/2006/main" xmlns:r="http://schemas.openxmlformats.org/officeDocument/2006/relationships" xmlns:p="http://schemas.openxmlformats.org/presentationml/2006/main">
   <p:cSld>
     <p:spTree>
@@ -11433,10 +13610,10 @@
         </p:nvGrpSpPr>
         <p:grpSpPr>
           <a:xfrm>
-            <a:off x="-1904999" y="-264778"/>
-            <a:ext cx="22387559" cy="15147234"/>
-            <a:chOff x="-1904999" y="-1100471"/>
-            <a:chExt cx="22387559" cy="15147234"/>
+            <a:off x="-1904999" y="-261587"/>
+            <a:ext cx="20848319" cy="15144043"/>
+            <a:chOff x="-1904999" y="-1097280"/>
+            <a:chExt cx="21625560" cy="15144043"/>
           </a:xfrm>
         </p:grpSpPr>
         <p:grpSp>
@@ -11453,10 +13630,10 @@
           </p:nvGrpSpPr>
           <p:grpSpPr>
             <a:xfrm>
-              <a:off x="-1904999" y="-1100471"/>
-              <a:ext cx="22387559" cy="15147234"/>
-              <a:chOff x="-2133599" y="-1100471"/>
-              <a:chExt cx="21617351" cy="15147234"/>
+              <a:off x="-1904999" y="-1097280"/>
+              <a:ext cx="21625560" cy="15144043"/>
+              <a:chOff x="-2133599" y="-1097280"/>
+              <a:chExt cx="20881567" cy="15144043"/>
             </a:xfrm>
           </p:grpSpPr>
           <p:sp>
@@ -11473,8 +13650,8 @@
             </p:nvSpPr>
             <p:spPr>
               <a:xfrm>
-                <a:off x="-2133599" y="-1097280"/>
-                <a:ext cx="21617351" cy="15136808"/>
+                <a:off x="-2133597" y="-1097280"/>
+                <a:ext cx="20881565" cy="15136808"/>
               </a:xfrm>
               <a:prstGeom prst="rect">
                 <a:avLst/>
@@ -11567,7 +13744,7 @@
             </p:nvCxnSpPr>
             <p:spPr>
               <a:xfrm>
-                <a:off x="2140720" y="-1097280"/>
+                <a:off x="2557108" y="-1097280"/>
                 <a:ext cx="0" cy="15136808"/>
               </a:xfrm>
               <a:prstGeom prst="line">
@@ -11605,7 +13782,7 @@
             </p:nvCxnSpPr>
             <p:spPr>
               <a:xfrm>
-                <a:off x="5733529" y="-1097280"/>
+                <a:off x="6130401" y="-1097280"/>
                 <a:ext cx="0" cy="15136808"/>
               </a:xfrm>
               <a:prstGeom prst="line">
@@ -11643,7 +13820,7 @@
             </p:nvCxnSpPr>
             <p:spPr>
               <a:xfrm>
-                <a:off x="9627698" y="-1097280"/>
+                <a:off x="10146684" y="-1097280"/>
                 <a:ext cx="0" cy="15136808"/>
               </a:xfrm>
               <a:prstGeom prst="line">
@@ -11681,7 +13858,7 @@
             </p:nvCxnSpPr>
             <p:spPr>
               <a:xfrm>
-                <a:off x="16177581" y="-1090045"/>
+                <a:off x="16803418" y="-1090045"/>
                 <a:ext cx="0" cy="15136808"/>
               </a:xfrm>
               <a:prstGeom prst="line">
@@ -11718,9 +13895,9 @@
               <p:nvPr/>
             </p:nvCxnSpPr>
             <p:spPr>
-              <a:xfrm flipV="1">
-                <a:off x="-2133599" y="-635615"/>
-                <a:ext cx="21617351" cy="8857"/>
+              <a:xfrm>
+                <a:off x="-2133599" y="-626758"/>
+                <a:ext cx="20881567" cy="6380"/>
               </a:xfrm>
               <a:prstGeom prst="line">
                 <a:avLst/>
@@ -11757,8 +13934,8 @@
             </p:nvCxnSpPr>
             <p:spPr>
               <a:xfrm flipV="1">
-                <a:off x="-2133599" y="6702492"/>
-                <a:ext cx="21617351" cy="40521"/>
+                <a:off x="-2133599" y="6692822"/>
+                <a:ext cx="20881567" cy="50191"/>
               </a:xfrm>
               <a:prstGeom prst="line">
                 <a:avLst/>
@@ -11865,7 +14042,7 @@
             </p:nvSpPr>
             <p:spPr>
               <a:xfrm>
-                <a:off x="-262678" y="-1085232"/>
+                <a:off x="65815" y="-1065358"/>
                 <a:ext cx="1011112" cy="461665"/>
               </a:xfrm>
               <a:prstGeom prst="rect">
@@ -11901,8 +14078,8 @@
             </p:nvSpPr>
             <p:spPr>
               <a:xfrm>
-                <a:off x="2634095" y="-1078535"/>
-                <a:ext cx="2635731" cy="461665"/>
+                <a:off x="2838611" y="-1080507"/>
+                <a:ext cx="3007335" cy="461665"/>
               </a:xfrm>
               <a:prstGeom prst="rect">
                 <a:avLst/>
@@ -11937,8 +14114,8 @@
             </p:nvSpPr>
             <p:spPr>
               <a:xfrm>
-                <a:off x="6293379" y="-1100471"/>
-                <a:ext cx="2802801" cy="461665"/>
+                <a:off x="6649437" y="-1080507"/>
+                <a:ext cx="3170829" cy="461665"/>
               </a:xfrm>
               <a:prstGeom prst="rect">
                 <a:avLst/>
@@ -11973,7 +14150,7 @@
             </p:nvSpPr>
             <p:spPr>
               <a:xfrm>
-                <a:off x="10753088" y="-1055687"/>
+                <a:off x="11743904" y="-1088711"/>
                 <a:ext cx="1630903" cy="461665"/>
               </a:xfrm>
               <a:prstGeom prst="rect">
@@ -12009,7 +14186,7 @@
             </p:nvSpPr>
             <p:spPr>
               <a:xfrm>
-                <a:off x="14746530" y="-1092852"/>
+                <a:off x="15298446" y="-1065358"/>
                 <a:ext cx="1014786" cy="461665"/>
               </a:xfrm>
               <a:prstGeom prst="rect">
@@ -12990,7 +15167,7 @@
             </p:nvSpPr>
             <p:spPr>
               <a:xfrm>
-                <a:off x="2189836" y="-591813"/>
+                <a:off x="2586708" y="-591813"/>
                 <a:ext cx="3524250" cy="7294305"/>
               </a:xfrm>
               <a:prstGeom prst="rect">
@@ -13455,7 +15632,7 @@
             </p:nvSpPr>
             <p:spPr>
               <a:xfrm>
-                <a:off x="2189836" y="6745224"/>
+                <a:off x="2571443" y="6745224"/>
                 <a:ext cx="3524250" cy="7294305"/>
               </a:xfrm>
               <a:prstGeom prst="rect">
@@ -13920,8 +16097,8 @@
             </p:nvSpPr>
             <p:spPr>
               <a:xfrm>
-                <a:off x="5765687" y="-489425"/>
-                <a:ext cx="3832544" cy="1200329"/>
+                <a:off x="6177824" y="-489425"/>
+                <a:ext cx="3931922" cy="1200329"/>
               </a:xfrm>
               <a:prstGeom prst="rect">
                 <a:avLst/>
@@ -13966,8 +16143,8 @@
             </p:nvSpPr>
             <p:spPr>
               <a:xfrm>
-                <a:off x="5764650" y="6858000"/>
-                <a:ext cx="3833581" cy="1200329"/>
+                <a:off x="6176786" y="6858000"/>
+                <a:ext cx="3921540" cy="1200329"/>
               </a:xfrm>
               <a:prstGeom prst="rect">
                 <a:avLst/>
@@ -14012,7 +16189,7 @@
             </p:nvSpPr>
             <p:spPr>
               <a:xfrm>
-                <a:off x="9700173" y="-461665"/>
+                <a:off x="10188631" y="-492145"/>
                 <a:ext cx="3947160" cy="923330"/>
               </a:xfrm>
               <a:prstGeom prst="rect">
@@ -14064,7 +16241,7 @@
             </p:nvSpPr>
             <p:spPr>
               <a:xfrm>
-                <a:off x="9700173" y="6996499"/>
+                <a:off x="10173366" y="6859339"/>
                 <a:ext cx="4764405" cy="923330"/>
               </a:xfrm>
               <a:prstGeom prst="rect">
@@ -14091,13 +16268,13 @@
               <a:p>
                 <a:r>
                   <a:rPr lang="nl-NL" dirty="0"/>
-                  <a:t> &lt;|1-2|&gt; &lt;|occupied_wall|&gt; &lt;|1-3|&gt; &lt;|blank|&gt; …</a:t>
+                  <a:t>&lt;|1-2|&gt; &lt;|occupied_wall|&gt; &lt;|1-3|&gt; &lt;|blank|&gt; …</a:t>
                 </a:r>
               </a:p>
               <a:p>
                 <a:r>
                   <a:rPr lang="nl-NL" dirty="0"/>
-                  <a:t> &lt;|5-5|&gt; &lt;|target|&gt; … &lt;|6-6|&gt; &lt;|occupied_wall|&gt;</a:t>
+                  <a:t>&lt;|5-5|&gt; &lt;|target|&gt; … &lt;|6-6|&gt; &lt;|occupied_wall|&gt;</a:t>
                 </a:r>
               </a:p>
             </p:txBody>
@@ -14124,8 +16301,8 @@
             </p:blipFill>
             <p:spPr>
               <a:xfrm>
-                <a:off x="14608662" y="6979920"/>
-                <a:ext cx="1290522" cy="2458136"/>
+                <a:off x="15156536" y="6857999"/>
+                <a:ext cx="1286204" cy="2449911"/>
               </a:xfrm>
               <a:prstGeom prst="rect">
                 <a:avLst/>
@@ -14149,7 +16326,7 @@
             </p:nvSpPr>
             <p:spPr>
               <a:xfrm>
-                <a:off x="14912872" y="-502583"/>
+                <a:off x="14973929" y="-563543"/>
                 <a:ext cx="827868" cy="369332"/>
               </a:xfrm>
               <a:prstGeom prst="rect">
@@ -14188,7 +16365,7 @@
           </p:nvCxnSpPr>
           <p:spPr>
             <a:xfrm>
-              <a:off x="15145458" y="-1090050"/>
+              <a:off x="15714551" y="-1090050"/>
               <a:ext cx="0" cy="15136808"/>
             </a:xfrm>
             <a:prstGeom prst="line">
@@ -14224,7 +16401,7 @@
           </p:nvSpPr>
           <p:spPr>
             <a:xfrm>
-              <a:off x="18341412" y="-1097281"/>
+              <a:off x="18283028" y="-1082043"/>
               <a:ext cx="877018" cy="461665"/>
             </a:xfrm>
             <a:prstGeom prst="rect">
@@ -14274,8 +16451,8 @@
           </p:blipFill>
           <p:spPr>
             <a:xfrm>
-              <a:off x="17292980" y="-555910"/>
-              <a:ext cx="2955193" cy="2955193"/>
+              <a:off x="17869206" y="-527705"/>
+              <a:ext cx="1704664" cy="1704664"/>
             </a:xfrm>
             <a:prstGeom prst="rect">
               <a:avLst/>
@@ -14311,8 +16488,8 @@
           </p:blipFill>
           <p:spPr>
             <a:xfrm>
-              <a:off x="17302320" y="6845267"/>
-              <a:ext cx="2955202" cy="2851029"/>
+              <a:off x="17840827" y="6816084"/>
+              <a:ext cx="1766950" cy="1704664"/>
             </a:xfrm>
             <a:prstGeom prst="rect">
               <a:avLst/>

</xml_diff>

<commit_message>
keyword search for all FoRs 15x15
</commit_message>
<xml_diff>
--- a/representations image.pptx
+++ b/representations image.pptx
@@ -204,7 +204,7 @@
           <a:p>
             <a:fld id="{D94C1F51-8E4F-4E5B-B98C-042184E4D3EC}" type="datetimeFigureOut">
               <a:rPr lang="nl-NL" smtClean="0"/>
-              <a:t>16-3-2026</a:t>
+              <a:t>23-3-2026</a:t>
             </a:fld>
             <a:endParaRPr lang="nl-NL"/>
           </a:p>
@@ -705,7 +705,7 @@
           <a:p>
             <a:fld id="{170662DF-287D-431E-B338-DA766D8B3B6C}" type="datetimeFigureOut">
               <a:rPr lang="nl-NL" smtClean="0"/>
-              <a:t>16-3-2026</a:t>
+              <a:t>23-3-2026</a:t>
             </a:fld>
             <a:endParaRPr lang="nl-NL"/>
           </a:p>
@@ -905,7 +905,7 @@
           <a:p>
             <a:fld id="{170662DF-287D-431E-B338-DA766D8B3B6C}" type="datetimeFigureOut">
               <a:rPr lang="nl-NL" smtClean="0"/>
-              <a:t>16-3-2026</a:t>
+              <a:t>23-3-2026</a:t>
             </a:fld>
             <a:endParaRPr lang="nl-NL"/>
           </a:p>
@@ -1115,7 +1115,7 @@
           <a:p>
             <a:fld id="{170662DF-287D-431E-B338-DA766D8B3B6C}" type="datetimeFigureOut">
               <a:rPr lang="nl-NL" smtClean="0"/>
-              <a:t>16-3-2026</a:t>
+              <a:t>23-3-2026</a:t>
             </a:fld>
             <a:endParaRPr lang="nl-NL"/>
           </a:p>
@@ -1315,7 +1315,7 @@
           <a:p>
             <a:fld id="{170662DF-287D-431E-B338-DA766D8B3B6C}" type="datetimeFigureOut">
               <a:rPr lang="nl-NL" smtClean="0"/>
-              <a:t>16-3-2026</a:t>
+              <a:t>23-3-2026</a:t>
             </a:fld>
             <a:endParaRPr lang="nl-NL"/>
           </a:p>
@@ -1591,7 +1591,7 @@
           <a:p>
             <a:fld id="{170662DF-287D-431E-B338-DA766D8B3B6C}" type="datetimeFigureOut">
               <a:rPr lang="nl-NL" smtClean="0"/>
-              <a:t>16-3-2026</a:t>
+              <a:t>23-3-2026</a:t>
             </a:fld>
             <a:endParaRPr lang="nl-NL"/>
           </a:p>
@@ -1859,7 +1859,7 @@
           <a:p>
             <a:fld id="{170662DF-287D-431E-B338-DA766D8B3B6C}" type="datetimeFigureOut">
               <a:rPr lang="nl-NL" smtClean="0"/>
-              <a:t>16-3-2026</a:t>
+              <a:t>23-3-2026</a:t>
             </a:fld>
             <a:endParaRPr lang="nl-NL"/>
           </a:p>
@@ -2274,7 +2274,7 @@
           <a:p>
             <a:fld id="{170662DF-287D-431E-B338-DA766D8B3B6C}" type="datetimeFigureOut">
               <a:rPr lang="nl-NL" smtClean="0"/>
-              <a:t>16-3-2026</a:t>
+              <a:t>23-3-2026</a:t>
             </a:fld>
             <a:endParaRPr lang="nl-NL"/>
           </a:p>
@@ -2416,7 +2416,7 @@
           <a:p>
             <a:fld id="{170662DF-287D-431E-B338-DA766D8B3B6C}" type="datetimeFigureOut">
               <a:rPr lang="nl-NL" smtClean="0"/>
-              <a:t>16-3-2026</a:t>
+              <a:t>23-3-2026</a:t>
             </a:fld>
             <a:endParaRPr lang="nl-NL"/>
           </a:p>
@@ -2529,7 +2529,7 @@
           <a:p>
             <a:fld id="{170662DF-287D-431E-B338-DA766D8B3B6C}" type="datetimeFigureOut">
               <a:rPr lang="nl-NL" smtClean="0"/>
-              <a:t>16-3-2026</a:t>
+              <a:t>23-3-2026</a:t>
             </a:fld>
             <a:endParaRPr lang="nl-NL"/>
           </a:p>
@@ -2842,7 +2842,7 @@
           <a:p>
             <a:fld id="{170662DF-287D-431E-B338-DA766D8B3B6C}" type="datetimeFigureOut">
               <a:rPr lang="nl-NL" smtClean="0"/>
-              <a:t>16-3-2026</a:t>
+              <a:t>23-3-2026</a:t>
             </a:fld>
             <a:endParaRPr lang="nl-NL"/>
           </a:p>
@@ -3131,7 +3131,7 @@
           <a:p>
             <a:fld id="{170662DF-287D-431E-B338-DA766D8B3B6C}" type="datetimeFigureOut">
               <a:rPr lang="nl-NL" smtClean="0"/>
-              <a:t>16-3-2026</a:t>
+              <a:t>23-3-2026</a:t>
             </a:fld>
             <a:endParaRPr lang="nl-NL"/>
           </a:p>
@@ -3374,7 +3374,7 @@
           <a:p>
             <a:fld id="{170662DF-287D-431E-B338-DA766D8B3B6C}" type="datetimeFigureOut">
               <a:rPr lang="nl-NL" smtClean="0"/>
-              <a:t>16-3-2026</a:t>
+              <a:t>23-3-2026</a:t>
             </a:fld>
             <a:endParaRPr lang="nl-NL"/>
           </a:p>

</xml_diff>